<commit_message>
fix(reproducibility): address D_REPAIR review items for Phase S1 package
- Namespace mock-fixture outputs to outputs/reproduction/fixture_diagnostics/ with _fixture_metadata.json
- Add authoritative completed-run reproduction path with --manifest and --run-dir (fail-closed on incomplete runs)
- Update T20 pairwise computation to canonical 296 anchor pairs (65/23/208) alongside secondary 252 strict pairs
- Remove non-stdlib module-level imports in scripts/reproduce_study.py (lazy import project/evaluator modules)
- Add [PENDING EXECUTION OF CANONICAL STUDY] markers to Slide 8 & 9 in deck and outline
- Delineate 5 scientific provenance tiers across docs, tables, slides, and sanitized evidence manifests
- Disclose runtime launcher SHA-256 (05b60f05...), WinError 5/32 retry wrapper, technique naming, and MIT license status
</commit_message>
<xml_diff>
--- a/docs/presentation/slides.pptx
+++ b/docs/presentation/slides.pptx
@@ -7701,7 +7701,7 @@
               </a:defRPr>
             </a:pPr>
             <a:r>
-              <a:t>Hiện tượng pha loãng ngữ cảnh (Context Dilution) giữa Single và Contextual</a:t>
+              <a:t>So sánh thực nghiệm Single vs Contextual trên 670 cặp kịch bản đối ứng</a:t>
             </a:r>
           </a:p>
         </p:txBody>
@@ -7782,135 +7782,167 @@
               </a:defRPr>
             </a:pPr>
             <a:r>
-              <a:t>So Sánh Cặp Đối Ứng (252 Cặp Hợp Lệ)</a:t>
-            </a:r>
-          </a:p>
-          <a:p>
-            <a:pPr>
-              <a:spcBef>
-                <a:spcPts val="600"/>
-              </a:spcBef>
-              <a:defRPr sz="1300">
-                <a:solidFill>
-                  <a:srgbClr val="0F172A"/>
-                </a:solidFill>
-                <a:latin typeface="Calibri"/>
-              </a:defRPr>
-            </a:pPr>
-            <a:r>
-              <a:t>•  Số cặp kịch bản đơn kỹ thuật đủ điều kiện: 252 cặp.</a:t>
-            </a:r>
-          </a:p>
-          <a:p>
-            <a:pPr>
-              <a:spcBef>
-                <a:spcPts val="600"/>
-              </a:spcBef>
-              <a:defRPr sz="1300">
-                <a:solidFill>
-                  <a:srgbClr val="0F172A"/>
-                </a:solidFill>
-                <a:latin typeface="Calibri"/>
-              </a:defRPr>
-            </a:pPr>
-            <a:r>
-              <a:t>•  Kết quả so sánh trực tiếp:</a:t>
-            </a:r>
-          </a:p>
-          <a:p>
-            <a:pPr>
-              <a:spcBef>
-                <a:spcPts val="600"/>
-              </a:spcBef>
-              <a:defRPr sz="1300">
-                <a:solidFill>
-                  <a:srgbClr val="0F172A"/>
-                </a:solidFill>
-                <a:latin typeface="Calibri"/>
-              </a:defRPr>
-            </a:pPr>
-            <a:r>
-              <a:t>•    • Single-event tốt hơn: 59 cặp (23.4%)</a:t>
-            </a:r>
-          </a:p>
-          <a:p>
-            <a:pPr>
-              <a:spcBef>
-                <a:spcPts val="600"/>
-              </a:spcBef>
-              <a:defRPr sz="1300">
-                <a:solidFill>
-                  <a:srgbClr val="0F172A"/>
-                </a:solidFill>
-                <a:latin typeface="Calibri"/>
-              </a:defRPr>
-            </a:pPr>
-            <a:r>
-              <a:t>•    • Contextual-event tốt hơn: 23 cặp (9.1%)</a:t>
-            </a:r>
-          </a:p>
-          <a:p>
-            <a:pPr>
-              <a:spcBef>
-                <a:spcPts val="600"/>
-              </a:spcBef>
-              <a:defRPr sz="1300">
-                <a:solidFill>
-                  <a:srgbClr val="0F172A"/>
-                </a:solidFill>
-                <a:latin typeface="Calibri"/>
-              </a:defRPr>
-            </a:pPr>
-            <a:r>
-              <a:t>•    • Hiệu năng ngang nhau: 170 cặp (67.5%)</a:t>
-            </a:r>
-          </a:p>
-          <a:p>
-            <a:pPr>
-              <a:spcBef>
-                <a:spcPts val="600"/>
-              </a:spcBef>
-              <a:defRPr sz="1300">
-                <a:solidFill>
-                  <a:srgbClr val="0F172A"/>
-                </a:solidFill>
-                <a:latin typeface="Calibri"/>
-              </a:defRPr>
-            </a:pPr>
-            <a:r>
-              <a:t>•    • Trong đó cả 2 cùng trượt Top-10: 119 cặp.</a:t>
-            </a:r>
-          </a:p>
-          <a:p>
-            <a:pPr>
-              <a:spcBef>
-                <a:spcPts val="600"/>
-              </a:spcBef>
-              <a:defRPr sz="1300">
-                <a:solidFill>
-                  <a:srgbClr val="0F172A"/>
-                </a:solidFill>
-                <a:latin typeface="Calibri"/>
-              </a:defRPr>
-            </a:pPr>
-            <a:r>
-              <a:t>•  Tỷ lệ Single vượt trội gấp 2.56 lần so với Contextual!</a:t>
-            </a:r>
-          </a:p>
-          <a:p>
-            <a:pPr>
-              <a:spcBef>
-                <a:spcPts val="600"/>
-              </a:spcBef>
-              <a:defRPr sz="1300">
-                <a:solidFill>
-                  <a:srgbClr val="0F172A"/>
-                </a:solidFill>
-                <a:latin typeface="Calibri"/>
-              </a:defRPr>
-            </a:pPr>
-            <a:r>
-              <a:t>•  Số liệu chứng minh thực tế ngược trực giác: Thêm nhiều log ngữ cảnh làm giảm chất lượng tìm kiếm vector.</a:t>
+              <a:t>Phân Tích Cặp Anchor Chuẩn (296 Cặp)</a:t>
+            </a:r>
+          </a:p>
+          <a:p>
+            <a:pPr>
+              <a:spcBef>
+                <a:spcPts val="600"/>
+              </a:spcBef>
+              <a:defRPr sz="1300">
+                <a:solidFill>
+                  <a:srgbClr val="0F172A"/>
+                </a:solidFill>
+                <a:latin typeface="Calibri"/>
+              </a:defRPr>
+            </a:pPr>
+            <a:r>
+              <a:t>•  Quy mô: 670 cặp kịch bản đối ứng; 374 cặp bị loại trừ do đa nhãn/mismatch.</a:t>
+            </a:r>
+          </a:p>
+          <a:p>
+            <a:pPr>
+              <a:spcBef>
+                <a:spcPts val="600"/>
+              </a:spcBef>
+              <a:defRPr sz="1300">
+                <a:solidFill>
+                  <a:srgbClr val="0F172A"/>
+                </a:solidFill>
+                <a:latin typeface="Calibri"/>
+              </a:defRPr>
+            </a:pPr>
+            <a:r>
+              <a:t>•  Tiêu chí Anchor chuẩn (scripts/verify_t20_canonical_artifacts.py):</a:t>
+            </a:r>
+          </a:p>
+          <a:p>
+            <a:pPr>
+              <a:spcBef>
+                <a:spcPts val="600"/>
+              </a:spcBef>
+              <a:defRPr sz="1300">
+                <a:solidFill>
+                  <a:srgbClr val="0F172A"/>
+                </a:solidFill>
+                <a:latin typeface="Calibri"/>
+              </a:defRPr>
+            </a:pPr>
+            <a:r>
+              <a:t>•    • Single view có duy nhất 1 kỹ thuật và kỹ thuật này có mặt trong Contextual view.</a:t>
+            </a:r>
+          </a:p>
+          <a:p>
+            <a:pPr>
+              <a:spcBef>
+                <a:spcPts val="600"/>
+              </a:spcBef>
+              <a:defRPr sz="1300">
+                <a:solidFill>
+                  <a:srgbClr val="0F172A"/>
+                </a:solidFill>
+                <a:latin typeface="Calibri"/>
+              </a:defRPr>
+            </a:pPr>
+            <a:r>
+              <a:t>•  Phân bố thứ hạng thực nghiệm quan sát được:</a:t>
+            </a:r>
+          </a:p>
+          <a:p>
+            <a:pPr>
+              <a:spcBef>
+                <a:spcPts val="600"/>
+              </a:spcBef>
+              <a:defRPr sz="1300">
+                <a:solidFill>
+                  <a:srgbClr val="0F172A"/>
+                </a:solidFill>
+                <a:latin typeface="Calibri"/>
+              </a:defRPr>
+            </a:pPr>
+            <a:r>
+              <a:t>•    • Single-event đạt thứ hạng tốt hơn: 65 cặp (22.0%)</a:t>
+            </a:r>
+          </a:p>
+          <a:p>
+            <a:pPr>
+              <a:spcBef>
+                <a:spcPts val="600"/>
+              </a:spcBef>
+              <a:defRPr sz="1300">
+                <a:solidFill>
+                  <a:srgbClr val="0F172A"/>
+                </a:solidFill>
+                <a:latin typeface="Calibri"/>
+              </a:defRPr>
+            </a:pPr>
+            <a:r>
+              <a:t>•    • Contextual-event đạt thứ hạng tốt hơn: 23 cặp (7.8%)</a:t>
+            </a:r>
+          </a:p>
+          <a:p>
+            <a:pPr>
+              <a:spcBef>
+                <a:spcPts val="600"/>
+              </a:spcBef>
+              <a:defRPr sz="1300">
+                <a:solidFill>
+                  <a:srgbClr val="0F172A"/>
+                </a:solidFill>
+                <a:latin typeface="Calibri"/>
+              </a:defRPr>
+            </a:pPr>
+            <a:r>
+              <a:t>•    • Hiệu năng thứ hạng tương đương: 208 cặp (70.3%)</a:t>
+            </a:r>
+          </a:p>
+          <a:p>
+            <a:pPr>
+              <a:spcBef>
+                <a:spcPts val="600"/>
+              </a:spcBef>
+              <a:defRPr sz="1300">
+                <a:solidFill>
+                  <a:srgbClr val="0F172A"/>
+                </a:solidFill>
+                <a:latin typeface="Calibri"/>
+              </a:defRPr>
+            </a:pPr>
+            <a:r>
+              <a:t>•      - Cả hai biểu diễn cùng trượt Top-10: 147 cặp</a:t>
+            </a:r>
+          </a:p>
+          <a:p>
+            <a:pPr>
+              <a:spcBef>
+                <a:spcPts val="600"/>
+              </a:spcBef>
+              <a:defRPr sz="1300">
+                <a:solidFill>
+                  <a:srgbClr val="0F172A"/>
+                </a:solidFill>
+                <a:latin typeface="Calibri"/>
+              </a:defRPr>
+            </a:pPr>
+            <a:r>
+              <a:t>•      - Đồng hạng chính xác trong Top-10: 61 cặp</a:t>
+            </a:r>
+          </a:p>
+          <a:p>
+            <a:pPr>
+              <a:spcBef>
+                <a:spcPts val="600"/>
+              </a:spcBef>
+              <a:defRPr sz="1300">
+                <a:solidFill>
+                  <a:srgbClr val="0F172A"/>
+                </a:solidFill>
+                <a:latin typeface="Calibri"/>
+              </a:defRPr>
+            </a:pPr>
+            <a:r>
+              <a:t>•  Nhóm lọc đơn kỹ thuật nghiêm ngặt (252 cặp): Single tốt hơn 59 cặp (23.4%) vs. Contextual 23 cặp (9.1%), ngang nhau 170 cặp.</a:t>
             </a:r>
           </a:p>
         </p:txBody>
@@ -7991,119 +8023,135 @@
               </a:defRPr>
             </a:pPr>
             <a:r>
-              <a:t>Cơ Chế Pha Loãng Ngữ Cảnh (Context Dilution)</a:t>
-            </a:r>
-          </a:p>
-          <a:p>
-            <a:pPr>
-              <a:spcBef>
-                <a:spcPts val="600"/>
-              </a:spcBef>
-              <a:defRPr sz="1300">
-                <a:solidFill>
-                  <a:srgbClr val="0F172A"/>
-                </a:solidFill>
-                <a:latin typeface="Calibri"/>
-              </a:defRPr>
-            </a:pPr>
-            <a:r>
-              <a:t>•  Nguyên nhân bản chất:</a:t>
-            </a:r>
-          </a:p>
-          <a:p>
-            <a:pPr>
-              <a:spcBef>
-                <a:spcPts val="600"/>
-              </a:spcBef>
-              <a:defRPr sz="1300">
-                <a:solidFill>
-                  <a:srgbClr val="0F172A"/>
-                </a:solidFill>
-                <a:latin typeface="Calibri"/>
-              </a:defRPr>
-            </a:pPr>
-            <a:r>
-              <a:t>•    • Khi gộp các sự kiện lân cận (tiến trình nền, truy vấn DNS thường quy), các token không độc hại chiếm đa số văn bản.</a:t>
-            </a:r>
-          </a:p>
-          <a:p>
-            <a:pPr>
-              <a:spcBef>
-                <a:spcPts val="600"/>
-              </a:spcBef>
-              <a:defRPr sz="1300">
-                <a:solidFill>
-                  <a:srgbClr val="0F172A"/>
-                </a:solidFill>
-                <a:latin typeface="Calibri"/>
-              </a:defRPr>
-            </a:pPr>
-            <a:r>
-              <a:t>•    • Vector nhúng tổng thể (dense embedding) bị kéo về phía các sự kiện bình thường (benign drift).</a:t>
-            </a:r>
-          </a:p>
-          <a:p>
-            <a:pPr>
-              <a:spcBef>
-                <a:spcPts val="600"/>
-              </a:spcBef>
-              <a:defRPr sz="1300">
-                <a:solidFill>
-                  <a:srgbClr val="0F172A"/>
-                </a:solidFill>
-                <a:latin typeface="Calibri"/>
-              </a:defRPr>
-            </a:pPr>
-            <a:r>
-              <a:t>•    • Hành vi tấn công cốt lõi bị làm mờ, khiến kỹ thuật ATT&amp;CK tương ứng bị đẩy xuống thứ hạng thấp.</a:t>
-            </a:r>
-          </a:p>
-          <a:p>
-            <a:pPr>
-              <a:spcBef>
-                <a:spcPts val="600"/>
-              </a:spcBef>
-              <a:defRPr sz="1300">
-                <a:solidFill>
-                  <a:srgbClr val="0F172A"/>
-                </a:solidFill>
-                <a:latin typeface="Calibri"/>
-              </a:defRPr>
-            </a:pPr>
-            <a:r>
-              <a:t>•  Hàm ý thiết kế hệ thống:</a:t>
-            </a:r>
-          </a:p>
-          <a:p>
-            <a:pPr>
-              <a:spcBef>
-                <a:spcPts val="600"/>
-              </a:spcBef>
-              <a:defRPr sz="1300">
-                <a:solidFill>
-                  <a:srgbClr val="0F172A"/>
-                </a:solidFill>
-                <a:latin typeface="Calibri"/>
-              </a:defRPr>
-            </a:pPr>
-            <a:r>
-              <a:t>•    • Không nên đưa toàn bộ chuỗi log thô vào bộ nhúng.</a:t>
-            </a:r>
-          </a:p>
-          <a:p>
-            <a:pPr>
-              <a:spcBef>
-                <a:spcPts val="600"/>
-              </a:spcBef>
-              <a:defRPr sz="1300">
-                <a:solidFill>
-                  <a:srgbClr val="0F172A"/>
-                </a:solidFill>
-                <a:latin typeface="Calibri"/>
-              </a:defRPr>
-            </a:pPr>
-            <a:r>
-              <a:t>•    • Cần có bộ lọc sự kiện nghi vấn (Event Scorer / Filter) trước khi thực hiện truy xuất RAG.</a:t>
+              <a:t>Hiện Tượng Quan Sát &amp; Hàm Ý Thiết Kế</a:t>
+            </a:r>
+          </a:p>
+          <a:p>
+            <a:pPr>
+              <a:spcBef>
+                <a:spcPts val="600"/>
+              </a:spcBef>
+              <a:defRPr sz="1300">
+                <a:solidFill>
+                  <a:srgbClr val="0F172A"/>
+                </a:solidFill>
+                <a:latin typeface="Calibri"/>
+              </a:defRPr>
+            </a:pPr>
+            <a:r>
+              <a:t>•  Hiện tượng suy giảm thứ hạng khi mở rộng ngữ cảnh:</a:t>
+            </a:r>
+          </a:p>
+          <a:p>
+            <a:pPr>
+              <a:spcBef>
+                <a:spcPts val="600"/>
+              </a:spcBef>
+              <a:defRPr sz="1300">
+                <a:solidFill>
+                  <a:srgbClr val="0F172A"/>
+                </a:solidFill>
+                <a:latin typeface="Calibri"/>
+              </a:defRPr>
+            </a:pPr>
+            <a:r>
+              <a:t>•    • Khi gộp các sự kiện lân cận (tiến trình nền, DNS thông thường), các token không độc hại chiếm đa số văn bản.</a:t>
+            </a:r>
+          </a:p>
+          <a:p>
+            <a:pPr>
+              <a:spcBef>
+                <a:spcPts val="600"/>
+              </a:spcBef>
+              <a:defRPr sz="1300">
+                <a:solidFill>
+                  <a:srgbClr val="0F172A"/>
+                </a:solidFill>
+                <a:latin typeface="Calibri"/>
+              </a:defRPr>
+            </a:pPr>
+            <a:r>
+              <a:t>•    • Vector nhúng tổng thể (dense embedding) bị kéo lệch về phía hành vi bình thường (benign drift).</a:t>
+            </a:r>
+          </a:p>
+          <a:p>
+            <a:pPr>
+              <a:spcBef>
+                <a:spcPts val="600"/>
+              </a:spcBef>
+              <a:defRPr sz="1300">
+                <a:solidFill>
+                  <a:srgbClr val="0F172A"/>
+                </a:solidFill>
+                <a:latin typeface="Calibri"/>
+              </a:defRPr>
+            </a:pPr>
+            <a:r>
+              <a:t>•    • Dẫn đến thứ hạng của kỹ thuật tấn công cốt lõi bị tụt lùi so với khi chỉ nhúng log sự kiện đơn lẻ.</a:t>
+            </a:r>
+          </a:p>
+          <a:p>
+            <a:pPr>
+              <a:spcBef>
+                <a:spcPts val="600"/>
+              </a:spcBef>
+              <a:defRPr sz="1300">
+                <a:solidFill>
+                  <a:srgbClr val="0F172A"/>
+                </a:solidFill>
+                <a:latin typeface="Calibri"/>
+              </a:defRPr>
+            </a:pPr>
+            <a:r>
+              <a:t>•  Hàm ý thiết kế hệ thống RAG an ninh mạng:</a:t>
+            </a:r>
+          </a:p>
+          <a:p>
+            <a:pPr>
+              <a:spcBef>
+                <a:spcPts val="600"/>
+              </a:spcBef>
+              <a:defRPr sz="1300">
+                <a:solidFill>
+                  <a:srgbClr val="0F172A"/>
+                </a:solidFill>
+                <a:latin typeface="Calibri"/>
+              </a:defRPr>
+            </a:pPr>
+            <a:r>
+              <a:t>•    • Không nên đưa toàn bộ chuỗi log thô nguyên khối vào bộ nhúng vector.</a:t>
+            </a:r>
+          </a:p>
+          <a:p>
+            <a:pPr>
+              <a:spcBef>
+                <a:spcPts val="600"/>
+              </a:spcBef>
+              <a:defRPr sz="1300">
+                <a:solidFill>
+                  <a:srgbClr val="0F172A"/>
+                </a:solidFill>
+                <a:latin typeface="Calibri"/>
+              </a:defRPr>
+            </a:pPr>
+            <a:r>
+              <a:t>•    • Cần áp dụng bộ lọc sự kiện nghi vấn (Event Filter) trước khi thực hiện truy xuất dense semantic.</a:t>
+            </a:r>
+          </a:p>
+          <a:p>
+            <a:pPr>
+              <a:spcBef>
+                <a:spcPts val="600"/>
+              </a:spcBef>
+              <a:defRPr sz="1300">
+                <a:solidFill>
+                  <a:srgbClr val="0F172A"/>
+                </a:solidFill>
+                <a:latin typeface="Calibri"/>
+              </a:defRPr>
+            </a:pPr>
+            <a:r>
+              <a:t>•    • Khảo sát được ghi nhận trên synthetic-paired-v1; cần tiếp tục kiểm chứng trên telemetry thực tế.</a:t>
             </a:r>
           </a:p>
         </p:txBody>
@@ -8313,7 +8361,7 @@
         <p:spPr>
           <a:xfrm>
             <a:off x="731520" y="1280160"/>
-            <a:ext cx="10698480" cy="2103120"/>
+            <a:ext cx="10698480" cy="2011680"/>
           </a:xfrm>
           <a:prstGeom prst="roundRect">
             <a:avLst/>
@@ -8358,7 +8406,7 @@
         <p:spPr>
           <a:xfrm>
             <a:off x="914400" y="1417319"/>
-            <a:ext cx="10332719" cy="1828799"/>
+            <a:ext cx="10332719" cy="1737360"/>
           </a:xfrm>
           <a:prstGeom prst="rect">
             <a:avLst/>
@@ -8457,8 +8505,8 @@
         </p:nvSpPr>
         <p:spPr>
           <a:xfrm>
-            <a:off x="731520" y="3566160"/>
-            <a:ext cx="5212080" cy="2743200"/>
+            <a:off x="731520" y="3474720"/>
+            <a:ext cx="5212080" cy="2926080"/>
           </a:xfrm>
           <a:prstGeom prst="roundRect">
             <a:avLst/>
@@ -8502,8 +8550,8 @@
         </p:nvSpPr>
         <p:spPr>
           <a:xfrm>
-            <a:off x="914400" y="3703320"/>
-            <a:ext cx="4846320" cy="2468880"/>
+            <a:off x="914400" y="3611879"/>
+            <a:ext cx="4846320" cy="2651760"/>
           </a:xfrm>
           <a:prstGeom prst="rect">
             <a:avLst/>
@@ -8576,6 +8624,22 @@
               <a:t>•  Macro-F1 &amp; Exact Match: Tính trên vũ trụ kỹ thuật chuẩn Frozen Benchmark Universe.</a:t>
             </a:r>
           </a:p>
+          <a:p>
+            <a:pPr>
+              <a:spcBef>
+                <a:spcPts val="600"/>
+              </a:spcBef>
+              <a:defRPr sz="1300">
+                <a:solidFill>
+                  <a:srgbClr val="0F172A"/>
+                </a:solidFill>
+                <a:latin typeface="Calibri"/>
+              </a:defRPr>
+            </a:pPr>
+            <a:r>
+              <a:t>•  Chống rò rỉ: Evaluator chỉ đọc dữ liệu offline, kiểm tra SHA-256 từng bản ghi.</a:t>
+            </a:r>
+          </a:p>
         </p:txBody>
       </p:sp>
       <p:sp>
@@ -8586,8 +8650,8 @@
         </p:nvSpPr>
         <p:spPr>
           <a:xfrm>
-            <a:off x="6217920" y="3566160"/>
-            <a:ext cx="5212080" cy="2743200"/>
+            <a:off x="6217920" y="3474720"/>
+            <a:ext cx="5212080" cy="2926080"/>
           </a:xfrm>
           <a:prstGeom prst="roundRect">
             <a:avLst/>
@@ -8631,8 +8695,8 @@
         </p:nvSpPr>
         <p:spPr>
           <a:xfrm>
-            <a:off x="6400800" y="3703320"/>
-            <a:ext cx="4846320" cy="2468880"/>
+            <a:off x="6400800" y="3611879"/>
+            <a:ext cx="4846320" cy="2651760"/>
           </a:xfrm>
           <a:prstGeom prst="rect">
             <a:avLst/>
@@ -8648,45 +8712,109 @@
             <a:pPr>
               <a:defRPr sz="1600" b="1">
                 <a:solidFill>
-                  <a:srgbClr val="059669"/>
-                </a:solidFill>
-                <a:latin typeface="Calibri"/>
-              </a:defRPr>
-            </a:pPr>
-            <a:r>
-              <a:t>Kiến Trúc Evaluator Khép Kín</a:t>
-            </a:r>
-          </a:p>
-          <a:p>
-            <a:pPr>
-              <a:spcBef>
-                <a:spcPts val="600"/>
-              </a:spcBef>
-              <a:defRPr sz="1300">
-                <a:solidFill>
-                  <a:srgbClr val="0F172A"/>
-                </a:solidFill>
-                <a:latin typeface="Calibri"/>
-              </a:defRPr>
-            </a:pPr>
-            <a:r>
-              <a:t>•  Tự động xuất 6 artifact chuẩn: overall_metrics.json, per_condition_metrics.json, per_technique_metrics.json, retrieval_conditional_metrics.json, failure_decomposition.json, run_provenance.json.</a:t>
-            </a:r>
-          </a:p>
-          <a:p>
-            <a:pPr>
-              <a:spcBef>
-                <a:spcPts val="600"/>
-              </a:spcBef>
-              <a:defRPr sz="1300">
-                <a:solidFill>
-                  <a:srgbClr val="0F172A"/>
-                </a:solidFill>
-                <a:latin typeface="Calibri"/>
-              </a:defRPr>
-            </a:pPr>
-            <a:r>
-              <a:t>•  Chống rò rỉ: Evaluator chỉ đọc dữ liệu offline, không kết nối mạng.</a:t>
+                  <a:srgbClr val="DC2626"/>
+                </a:solidFill>
+                <a:latin typeface="Calibri"/>
+              </a:defRPr>
+            </a:pPr>
+            <a:r>
+              <a:t>[PENDING EXECUTION] Trạng Thái Thực Nghiệm</a:t>
+            </a:r>
+          </a:p>
+          <a:p>
+            <a:pPr>
+              <a:spcBef>
+                <a:spcPts val="600"/>
+              </a:spcBef>
+              <a:defRPr sz="1300">
+                <a:solidFill>
+                  <a:srgbClr val="0F172A"/>
+                </a:solidFill>
+                <a:latin typeface="Calibri"/>
+              </a:defRPr>
+            </a:pPr>
+            <a:r>
+              <a:t>•  Trạng thái thực nghiệm chính thức: [AWAITING LIVE RUN TERMINATION]</a:t>
+            </a:r>
+          </a:p>
+          <a:p>
+            <a:pPr>
+              <a:spcBef>
+                <a:spcPts val="600"/>
+              </a:spcBef>
+              <a:defRPr sz="1300">
+                <a:solidFill>
+                  <a:srgbClr val="0F172A"/>
+                </a:solidFill>
+                <a:latin typeface="Calibri"/>
+              </a:defRPr>
+            </a:pPr>
+            <a:r>
+              <a:t>•    • Ma trận hoàn chỉnh 1,280 mẫu x 5 nhánh (6,400 bản ghi) đang chạy (PID 50192).</a:t>
+            </a:r>
+          </a:p>
+          <a:p>
+            <a:pPr>
+              <a:spcBef>
+                <a:spcPts val="600"/>
+              </a:spcBef>
+              <a:defRPr sz="1300">
+                <a:solidFill>
+                  <a:srgbClr val="0F172A"/>
+                </a:solidFill>
+                <a:latin typeface="Calibri"/>
+              </a:defRPr>
+            </a:pPr>
+            <a:r>
+              <a:t>•    • Nguyên tắc Fail-Closed: Evaluator từ chối công bố điểm chính thức khi chưa đủ 6,400 records.</a:t>
+            </a:r>
+          </a:p>
+          <a:p>
+            <a:pPr>
+              <a:spcBef>
+                <a:spcPts val="600"/>
+              </a:spcBef>
+              <a:defRPr sz="1300">
+                <a:solidFill>
+                  <a:srgbClr val="0F172A"/>
+                </a:solidFill>
+                <a:latin typeface="Calibri"/>
+              </a:defRPr>
+            </a:pPr>
+            <a:r>
+              <a:t>•  Kiểm định toán học ngoại tuyến của Evaluator:</a:t>
+            </a:r>
+          </a:p>
+          <a:p>
+            <a:pPr>
+              <a:spcBef>
+                <a:spcPts val="600"/>
+              </a:spcBef>
+              <a:defRPr sz="1300">
+                <a:solidFill>
+                  <a:srgbClr val="0F172A"/>
+                </a:solidFill>
+                <a:latin typeface="Calibri"/>
+              </a:defRPr>
+            </a:pPr>
+            <a:r>
+              <a:t>•    • Đã kiểm tra qua 5 fixture mẫu chuẩn (outputs/reproduction/fixture_diagnostics/).</a:t>
+            </a:r>
+          </a:p>
+          <a:p>
+            <a:pPr>
+              <a:spcBef>
+                <a:spcPts val="600"/>
+              </a:spcBef>
+              <a:defRPr sz="1300">
+                <a:solidFill>
+                  <a:srgbClr val="0F172A"/>
+                </a:solidFill>
+                <a:latin typeface="Calibri"/>
+              </a:defRPr>
+            </a:pPr>
+            <a:r>
+              <a:t>•    • Tự động xuất đủ 6 metric artifacts với _fixture_metadata.json (fixture_only=True).</a:t>
             </a:r>
           </a:p>
         </p:txBody>
@@ -8869,7 +8997,7 @@
               </a:defRPr>
             </a:pPr>
             <a:r>
-              <a:t>8. Nghiên Cứu Cắt Giảm &amp; Chi Phí Thực Nghiệm RQ3</a:t>
+              <a:t>8. Nghiên Cứu Tiêu Thụ Tài Nguyên &amp; Chi Phí Thực Nghiệm RQ3</a:t>
             </a:r>
           </a:p>
           <a:p>
@@ -8882,7 +9010,7 @@
               </a:defRPr>
             </a:pPr>
             <a:r>
-              <a:t>Kết quả thực nghiệm từ DEV Cost Pilot trên OpenAI gpt-5.6-luna (20 requests)</a:t>
+              <a:t>Dữ liệu đo lường thực tế từ DEV Cost Pilot trên OpenAI gpt-5.6-luna (20 requests)</a:t>
             </a:r>
           </a:p>
         </p:txBody>
@@ -8963,39 +9091,55 @@
               </a:defRPr>
             </a:pPr>
             <a:r>
-              <a:t>Số Liệu Thực Nghiệm DEV Cost Pilot (2026-10-01)</a:t>
-            </a:r>
-          </a:p>
-          <a:p>
-            <a:pPr>
-              <a:spcBef>
-                <a:spcPts val="600"/>
-              </a:spcBef>
-              <a:defRPr sz="1300">
-                <a:solidFill>
-                  <a:srgbClr val="0F172A"/>
-                </a:solidFill>
-                <a:latin typeface="Calibri"/>
-              </a:defRPr>
-            </a:pPr>
-            <a:r>
-              <a:t>•  Quy mô: 20 yêu cầu thực tế qua Responses API trên 4 DEV views.</a:t>
-            </a:r>
-          </a:p>
-          <a:p>
-            <a:pPr>
-              <a:spcBef>
-                <a:spcPts val="600"/>
-              </a:spcBef>
-              <a:defRPr sz="1300">
-                <a:solidFill>
-                  <a:srgbClr val="0F172A"/>
-                </a:solidFill>
-                <a:latin typeface="Calibri"/>
-              </a:defRPr>
-            </a:pPr>
-            <a:r>
-              <a:t>•  Tuân thủ Schema: 100% VALID  |  Số lần Retry: 0.</a:t>
+              <a:t>DEV Cost Pilot: 20 Mẫu Thăm Dò Thực Tế</a:t>
+            </a:r>
+          </a:p>
+          <a:p>
+            <a:pPr>
+              <a:spcBef>
+                <a:spcPts val="600"/>
+              </a:spcBef>
+              <a:defRPr sz="1300">
+                <a:solidFill>
+                  <a:srgbClr val="0F172A"/>
+                </a:solidFill>
+                <a:latin typeface="Calibri"/>
+              </a:defRPr>
+            </a:pPr>
+            <a:r>
+              <a:t>•  Mục đích: Đo lường mức tăng trưởng token thực tế và kiểm tra độ ổn định schema.</a:t>
+            </a:r>
+          </a:p>
+          <a:p>
+            <a:pPr>
+              <a:spcBef>
+                <a:spcPts val="600"/>
+              </a:spcBef>
+              <a:defRPr sz="1300">
+                <a:solidFill>
+                  <a:srgbClr val="0F172A"/>
+                </a:solidFill>
+                <a:latin typeface="Calibri"/>
+              </a:defRPr>
+            </a:pPr>
+            <a:r>
+              <a:t>•  Quy mô: 20 yêu cầu thực tế qua Responses API trên 4 DEV views x 5 nhánh điều kiện.</a:t>
+            </a:r>
+          </a:p>
+          <a:p>
+            <a:pPr>
+              <a:spcBef>
+                <a:spcPts val="600"/>
+              </a:spcBef>
+              <a:defRPr sz="1300">
+                <a:solidFill>
+                  <a:srgbClr val="0F172A"/>
+                </a:solidFill>
+                <a:latin typeface="Calibri"/>
+              </a:defRPr>
+            </a:pPr>
+            <a:r>
+              <a:t>•  Tuân thủ Schema: 100% VALID  |  Số lần Retry: 0 (Độ trễ TB: 8,127.6 ms).</a:t>
             </a:r>
           </a:p>
           <a:p>
@@ -9107,23 +9251,23 @@
               </a:defRPr>
             </a:pPr>
             <a:r>
-              <a:t>•  Chi phí thanh toán thực tế cho 20 requests: $0.0242 USD.</a:t>
-            </a:r>
-          </a:p>
-          <a:p>
-            <a:pPr>
-              <a:spcBef>
-                <a:spcPts val="600"/>
-              </a:spcBef>
-              <a:defRPr sz="1300">
-                <a:solidFill>
-                  <a:srgbClr val="0F172A"/>
-                </a:solidFill>
-                <a:latin typeface="Calibri"/>
-              </a:defRPr>
-            </a:pPr>
-            <a:r>
-              <a:t>•  Dự phóng chi phí toàn bộ 6,400 requests tập TEST: $8.20 – $8.99 USD.</a:t>
+              <a:t>•  Chi phí thanh toán thực tế cho 20 requests: $0.0242 USD (~600 VNĐ).</a:t>
+            </a:r>
+          </a:p>
+          <a:p>
+            <a:pPr>
+              <a:spcBef>
+                <a:spcPts val="600"/>
+              </a:spcBef>
+              <a:defRPr sz="1300">
+                <a:solidFill>
+                  <a:srgbClr val="0F172A"/>
+                </a:solidFill>
+                <a:latin typeface="Calibri"/>
+              </a:defRPr>
+            </a:pPr>
+            <a:r>
+              <a:t>•  [PENDING] Toàn bộ ma trận TEST 6,400 requests dự phóng chi phí: $8.20 – $8.99 USD.</a:t>
             </a:r>
           </a:p>
         </p:txBody>

</xml_diff>

<commit_message>
fix(presentation): implement CD_FACTUAL_R2 adjustments for cost terminology, guard scope, and protocol labels
</commit_message>
<xml_diff>
--- a/docs/presentation/slides.pptx
+++ b/docs/presentation/slides.pptx
@@ -523,6 +523,11 @@
           </a:p>
           <a:p>
             <a:r>
+              <a:t>Khai báo tác tạo: Slide deck này được tác tạo tự động bằng kịch bản Python scripts/generate_slides.py (sử dụng thư viện python-pptx định dạng 16:9 widescreen), được thẩm định hiển thị qua bundled artifact tools.</a:t>
+            </a:r>
+          </a:p>
+          <a:p>
+            <a:r>
               <a:t>Bằng chứng dự án: config/canonical_experiment_lock_v1.json (SHA-256: 961ba9b3e9e1b459a6694a5c8c76424d36c89d65bd4d88b14d0b0de7e4c017ac); reports/experiment_protocol_v1.md (SHA-256: d3bf3d31ad307100ac437a7daecc470bf12de9ada49f19de3d77592d5a21974c); scripts/reproduce_study.py.</a:t>
             </a:r>
           </a:p>
@@ -598,7 +603,7 @@
           </a:p>
           <a:p>
             <a:r>
-              <a:t>Nghiên cứu công khai các giới hạn khoa học: Dữ liệu hiện tại nằm trong phạm vi kịch bản có cấu trúc synthetic-paired-v1; bộ nhúng dense đơn tầng chưa kết nối được từ vựng kỹ thuật hệ thống (Event ID số); và mô hình đánh giá là gpt-5.6-luna. Để đảm bảo an toàn tuyệt đối, mọi quy trình kiểm thử tái lập phải thực thi qua runner offline scripts/run_offline_tests.py nhằm bảo đảm không phát sinh bất kỳ kết nối mạng ngoài nào.</a:t>
+              <a:t>Nghiên cứu công khai các giới hạn khoa học: Dữ liệu hiện tại nằm trong phạm vi kịch bản có cấu trúc synthetic-paired-v1; bộ nhúng dense đơn tầng chưa kết nối được từ vựng kỹ thuật hệ thống (Event ID số); và mô hình đánh giá là gpt-5.6-luna. Để đảm bảo an toàn, mọi quy trình kiểm thử tái lập phải thực thi qua runner offline scripts/run_offline_tests.py nhằm đánh chặn các kết nối mạng ngẫu nhiên ở tầng socket Python.</a:t>
             </a:r>
           </a:p>
           <a:p>
@@ -678,7 +683,7 @@
           </a:p>
           <a:p>
             <a:r>
-              <a:t>Khả năng tái lập độc lập là cam kết trọng tâm của dự án. Lệnh reproduce_study.py --all tái tạo toàn bộ chẩn đoán, bảng biểu và đồ thị từ 15 artifact đã đóng băng mà không tốn chi phí. Việc kiểm thử bắt buộc sử dụng runner scripts/run_offline_tests.py để kích hoạt OFFLINE_GUARD. Tái lập toàn diện luồng live provider yêu cầu credentials thực và chạy dưới budget guard kiểm soát ngân sách trần $19.99 USD. Bốn đóng góp khoa học cốt lõi đã thiết lập nền tảng đối chứng vững chắc cho cộng đồng RAG an ninh mạng.</a:t>
+              <a:t>Khả năng tái lập độc lập là cam kết trọng tâm của dự án. Lệnh reproduce_study.py --all tái tạo toàn bộ chẩn đoán, bảng biểu và đồ thị từ 15 artifact đã đóng băng mà không tốn chi phí. Việc kiểm thử bắt buộc sử dụng runner scripts/run_offline_tests.py để kích hoạt OFFLINE_GUARD. Chúng tôi minh bạch rõ ràng: offline_guard là cơ chế đánh chặn ở tầng socket Python và lọc biến môi trường, không phải là sandbox cấp OS. Tái lập toàn diện luồng live provider yêu cầu credentials thực và chạy dưới budget guard kiểm soát ngân sách trần $19.99 USD. Bốn đóng góp khoa học cốt lõi đã thiết lập nền tảng đối chứng vững chắc cho cộng đồng RAG an ninh mạng.</a:t>
             </a:r>
           </a:p>
           <a:p>
@@ -758,7 +763,12 @@
           </a:p>
           <a:p>
             <a:r>
-              <a:t>Tóm lại, RAG2ATT&amp;CK đã chứng minh rằng để ứng dụng RAG thành công trong SOC, chúng ta không thể chỉ kỳ vọng vào mô hình ngôn ngữ lớn, mà phải giải quyết bài toán cốt lõi là tối ưu hóa bộ truy xuất và cấu trúc hóa biểu diễn log. Toàn bộ mã nguồn, dữ liệu thực nghiệm và gói tái lập đã được công bố tại PR #26. Tôi xin chân thành cảm ơn sự lắng nghe của Quý Thầy Cô và kính mời Hội đồng đặt câu hỏi thảo luận.</a:t>
+              <a:t>Tóm lại, RAG2ATT&amp;CK đo lường thực nghiệm đối chứng vai trò của RAG trong bài toán ánh xạ log Windows sang ATT&amp;CK techniques. Các phát hiện hiện tại phản ánh phạm vi đo lường thực nghiệm và các giả thuyết đang chờ hoàn tất ma trận TEST. Chúng tôi nhấn mạnh tính trung thực khoa học: phân rã lỗi D2i theo các trục đo lường độc lập không giả định độc lập xác suất ngẫu nhiên, và quy trình tái lập sử dụng runner can thiệp socket tầng ứng dụng.</a:t>
+            </a:r>
+          </a:p>
+          <a:p>
+            <a:r>
+              <a:t>Khai báo công cụ: Toàn bộ slide deck này được tác tạo tự động bằng kịch bản Python scripts/generate_slides.py (sử dụng thư viện python-pptx định dạng 16:9 widescreen), được thẩm định hiển thị qua bundled artifact tools.</a:t>
             </a:r>
           </a:p>
           <a:p>
@@ -1078,7 +1088,37 @@
           </a:p>
           <a:p>
             <a:r>
-              <a:t>Giao thức thực nghiệm v1.1 đóng băng 7 quyết định phương pháp luận cốt lõi D1-D7. Về mô hình đe dọa, danh mục kỹ thuật được neo tại STIX ATT&amp;CK v19.2 Enterprise Windows (474 techniques). Điểm đặc biệt quan trọng là chính sách D2g ALLOW_HISTORICAL: các mã kỹ thuật lịch sử hoặc đã bị thu hồi có trong benchmark được chấp nhận và báo cáo dạng distinct observation count, không tự ý gán lại mã thay thế. Bốn tiêu chí đánh giá cốt lõi gồm D2h (ANY_GT_RETRIEVED cho multi-label), D2i (INDEPENDENT_AXES ghi nhận đầy đủ overlap), D2e (invalid ID tính vào mẫu số), và D2f (lỗi mạng tính vào mẫu số) thiết lập nguyên tắc fail-closed nghiêm ngặt.</a:t>
+              <a:t>Giao thức thực nghiệm v1.1 đóng băng 7 quyết định phương pháp luận cốt lõi D1-D7 và được tách bạch rõ ràng từng nhãn:</a:t>
+            </a:r>
+          </a:p>
+          <a:p>
+            <a:r>
+              <a:t>- D2d: Vũ trụ Macro-F1 cố định đúng 474 lớp (FROZEN_BENCHMARK_UNIVERSE = 474).</a:t>
+            </a:r>
+          </a:p>
+          <a:p>
+            <a:r>
+              <a:t>- D2e: invalid_id_as_failure (INCLUDE_IN_DENOMINATOR cho mã sai cú pháp/ảo giác).</a:t>
+            </a:r>
+          </a:p>
+          <a:p>
+            <a:r>
+              <a:t>- D2f: api_failure_as_failure (INCLUDE_IN_DENOMINATOR cho lỗi provider/timeout/parser).</a:t>
+            </a:r>
+          </a:p>
+          <a:p>
+            <a:r>
+              <a:t>- D2g: ALLOW_HISTORICAL chấp nhận các mã lịch sử/thu hồi dưới dạng distinct observation count, không tự ý gán lại mã thay thế.</a:t>
+            </a:r>
+          </a:p>
+          <a:p>
+            <a:r>
+              <a:t>- D2h: ANY_GT_RETRIEVED cho multi-label retrieval success.</a:t>
+            </a:r>
+          </a:p>
+          <a:p>
+            <a:r>
+              <a:t>- D2i: INDEPENDENT_AXES ghi nhận đầy đủ phần giao thoa giữa các trục đo lường lỗi.</a:t>
             </a:r>
           </a:p>
           <a:p>
@@ -1318,12 +1358,12 @@
           </a:p>
           <a:p>
             <a:r>
-              <a:t>Khung đánh giá RQ1 &amp; RQ2 được xây dựng trên định đề D2i (Independent Axes). Chúng tôi bác bỏ hoàn toàn công thức cộng xác suất rời rạc sai lầm, bởi retrieval failure và downstream generation failure không hề xung khắc nhau mà có phần giao thoa rõ ràng. Các chỉ số có điều kiện P(Correct | GT in Top-k) và P(Correct | GT NOT in Top-k) cho phép định lượng chính xác xem LLM có bị đánh lừa bởi distractor hay có khả năng tự sửa sai. Toàn bộ ma trận chính thức 6,400 bản ghi đang chạy; tính đúng đắn toán học của Evaluator đã được chứng minh qua 5 test fixtures.</a:t>
-            </a:r>
-          </a:p>
-          <a:p>
-            <a:r>
-              <a:t>Bằng chứng dự án: reports/experiment_protocol_v1.md (D2e, D2f, D2h, D2i; SHA-256: d3bf3d31ad307100ac437a7daecc470bf12de9ada49f19de3d77592d5a21974c); tests/test_experiment_evaluation.py (94 tests pass).</a:t>
+              <a:t>Khung đánh giá RQ1 &amp; RQ2 được xây dựng trên định đề D2i (Independent Measurement Axes). Chúng tôi bác bỏ hoàn toàn công thức cộng xác suất rời rạc sai lầm, bởi retrieval failure và downstream generation failure không hề xung khắc nhau mà có phần giao thoa rõ ràng; chúng tôi cũng không giả định độc lập xác suất ngẫu nhiên. Các chỉ số có điều kiện P(Correct | GT in Top-k) và P(Correct | GT NOT in Top-k) cho phép định lượng xem LLM có bị đánh lừa bởi distractor hay có khả năng tự sửa sai. Toàn bộ ma trận chính thức 6,400 bản ghi đang chạy; tính đúng đắn toán học của Evaluator đã được chứng minh qua 5 test fixtures.</a:t>
+            </a:r>
+          </a:p>
+          <a:p>
+            <a:r>
+              <a:t>Bằng chứng dự án: reports/experiment_protocol_v1.md (D2e, D2f, D2h, D2i; SHA-256: d3bf3d31...); tests/test_experiment_evaluation.py (94 tests pass).</a:t>
             </a:r>
           </a:p>
         </p:txBody>
@@ -1398,12 +1438,32 @@
           </a:p>
           <a:p>
             <a:r>
-              <a:t>Trong phân tích RQ3, chúng tôi làm rõ số liệu chi phí từ DEV Cost Pilot (20 requests thực tế trên gpt-5.6-luna). Con số ~$0.00165/query là ước tính từ telemetry pilot ban đầu tại nhánh k=3 do độ dài reasoning output. Chi phí quyết toán thực tế (verified spend) là $0.024209 USD (conservative rate: $0.026320 USD). Chi phí dự phóng cho toàn bộ 6,400 requests của tập TEST là $8.20 – $8.99 USD. Toàn bộ tiến trình được kiểm soát bởi trần ngân sách đóng băng $19.99 USD và khoản giữ chỗ conservative pilot $0.05264010 USD, bảo đảm không bao giờ vượt ngân sách.</a:t>
-            </a:r>
-          </a:p>
-          <a:p>
-            <a:r>
-              <a:t>Bằng chứng dự án: config/experiment_config.json (hard_budget_limit_usd: 19.99); reports/evidence/dev_cost_pilot_20261001/summary.json (SHA-256: f8dfe99479346dbbeff94d6e9dc7d11019623e5932ef27a00f1c3222e4c92b23); tests/test_monetary_guard.py.</a:t>
+              <a:t>Trong phân tích RQ3, chúng tôi làm rõ các khái niệm chi phí và dữ liệu:</a:t>
+            </a:r>
+          </a:p>
+          <a:p>
+            <a:r>
+              <a:t>1. Dữ liệu DEV là dữ liệu tổng hợp (synthetic-paired-v1 DEV split, 4 views x 5 nhánh). Việc gửi request lên OpenAI không biến log tổng hợp thành dữ liệu thực địa in-the-wild.</a:t>
+            </a:r>
+          </a:p>
+          <a:p>
+            <a:r>
+              <a:t>2. Chi phí pilot 20 request ($0.024209 USD standard, $0.026320 USD conservative) là 'Chi phí hạch toán ước tính từ token quan sát được và biểu giá công bố', vì chúng tôi chưa có hóa đơn quyết toán chính thức từ OpenAI.</a:t>
+            </a:r>
+          </a:p>
+          <a:p>
+            <a:r>
+              <a:t>3. Con số ~$0.00165/query là ước tính ban đầu tại nhánh k=3 do độ dài reasoning output.</a:t>
+            </a:r>
+          </a:p>
+          <a:p>
+            <a:r>
+              <a:t>4. Phân biệt rõ khoản giữ chỗ thận trọng tạm thời ($0.05264010 USD prior_pilot_provisional_hold_usd), dự báo chuẩn tắc tập TEST ($8.20 – $8.99 USD cho 6,400 requests), và trần ngân sách đóng băng cứng $19.99 USD (hard_budget_limit_usd).</a:t>
+            </a:r>
+          </a:p>
+          <a:p>
+            <a:r>
+              <a:t>Bằng chứng dự án: config/experiment_config.json (hard_budget_limit_usd: 19.99); reports/evidence/dev_cost_pilot_20261001/summary.json (SHA-256: f8dfe994...); tests/test_monetary_guard.py.</a:t>
             </a:r>
           </a:p>
         </p:txBody>
@@ -4574,7 +4634,7 @@
               </a:defRPr>
             </a:pPr>
             <a:r>
-              <a:t>Giao thức khoa học: experiment-protocol-v1.1  |  Khóa chuẩn: canonical-lock-v1  |  Tái lập: 100% Offline</a:t>
+              <a:t>Giao thức khoa học: experiment-protocol-v1.1  |  Khóa chuẩn: canonical-lock-v1  |  Tác tạo: Python-pptx automated pipeline</a:t>
             </a:r>
           </a:p>
         </p:txBody>
@@ -4857,9 +4917,9 @@
           <a:p>
             <a:pPr>
               <a:spcBef>
-                <a:spcPts val="400"/>
-              </a:spcBef>
-              <a:defRPr sz="1200">
+                <a:spcPts val="350"/>
+              </a:spcBef>
+              <a:defRPr sz="1150">
                 <a:solidFill>
                   <a:srgbClr val="0F172A"/>
                 </a:solidFill>
@@ -4873,9 +4933,9 @@
           <a:p>
             <a:pPr>
               <a:spcBef>
-                <a:spcPts val="400"/>
-              </a:spcBef>
-              <a:defRPr sz="1200">
+                <a:spcPts val="350"/>
+              </a:spcBef>
+              <a:defRPr sz="1150">
                 <a:solidFill>
                   <a:srgbClr val="0F172A"/>
                 </a:solidFill>
@@ -4889,9 +4949,9 @@
           <a:p>
             <a:pPr>
               <a:spcBef>
-                <a:spcPts val="400"/>
-              </a:spcBef>
-              <a:defRPr sz="1200">
+                <a:spcPts val="350"/>
+              </a:spcBef>
+              <a:defRPr sz="1150">
                 <a:solidFill>
                   <a:srgbClr val="0F172A"/>
                 </a:solidFill>
@@ -4986,9 +5046,9 @@
           <a:p>
             <a:pPr>
               <a:spcBef>
-                <a:spcPts val="400"/>
-              </a:spcBef>
-              <a:defRPr sz="1200">
+                <a:spcPts val="350"/>
+              </a:spcBef>
+              <a:defRPr sz="1150">
                 <a:solidFill>
                   <a:srgbClr val="0F172A"/>
                 </a:solidFill>
@@ -5002,9 +5062,9 @@
           <a:p>
             <a:pPr>
               <a:spcBef>
-                <a:spcPts val="400"/>
-              </a:spcBef>
-              <a:defRPr sz="1200">
+                <a:spcPts val="350"/>
+              </a:spcBef>
+              <a:defRPr sz="1150">
                 <a:solidFill>
                   <a:srgbClr val="0F172A"/>
                 </a:solidFill>
@@ -5093,15 +5153,15 @@
               </a:defRPr>
             </a:pPr>
             <a:r>
-              <a:t>Phạm Vi Mô Hình &amp; Tái Lập An Toàn</a:t>
-            </a:r>
-          </a:p>
-          <a:p>
-            <a:pPr>
-              <a:spcBef>
-                <a:spcPts val="400"/>
-              </a:spcBef>
-              <a:defRPr sz="1200">
+              <a:t>Phạm Vi Mô Hình &amp; Quy Trình Tái Lập</a:t>
+            </a:r>
+          </a:p>
+          <a:p>
+            <a:pPr>
+              <a:spcBef>
+                <a:spcPts val="350"/>
+              </a:spcBef>
+              <a:defRPr sz="1150">
                 <a:solidFill>
                   <a:srgbClr val="0F172A"/>
                 </a:solidFill>
@@ -5115,9 +5175,9 @@
           <a:p>
             <a:pPr>
               <a:spcBef>
-                <a:spcPts val="400"/>
-              </a:spcBef>
-              <a:defRPr sz="1200">
+                <a:spcPts val="350"/>
+              </a:spcBef>
+              <a:defRPr sz="1150">
                 <a:solidFill>
                   <a:srgbClr val="0F172A"/>
                 </a:solidFill>
@@ -5131,17 +5191,17 @@
           <a:p>
             <a:pPr>
               <a:spcBef>
-                <a:spcPts val="400"/>
-              </a:spcBef>
-              <a:defRPr sz="1200">
-                <a:solidFill>
-                  <a:srgbClr val="0F172A"/>
-                </a:solidFill>
-                <a:latin typeface="Calibri"/>
-              </a:defRPr>
-            </a:pPr>
-            <a:r>
-              <a:t>•  Quy trình tái lập an toàn: Mọi kịch bản kiểm thử bắt buộc chạy qua runner offline scripts/run_offline_tests.py, tuyệt đối không dùng pytest trần không có guard.</a:t>
+                <a:spcPts val="350"/>
+              </a:spcBef>
+              <a:defRPr sz="1150">
+                <a:solidFill>
+                  <a:srgbClr val="0F172A"/>
+                </a:solidFill>
+                <a:latin typeface="Calibri"/>
+              </a:defRPr>
+            </a:pPr>
+            <a:r>
+              <a:t>•  Quy trình tái lập an toàn: Mọi kịch bản kiểm thử bắt buộc chạy qua runner offline scripts/run_offline_tests.py, can thiệp socket Python để chặn kết nối ngoài ý muốn.</a:t>
             </a:r>
           </a:p>
         </p:txBody>
@@ -5418,135 +5478,135 @@
               </a:defRPr>
             </a:pPr>
             <a:r>
-              <a:t>Tái Lập 100% Ngoại Tuyến (Zero-Cost)</a:t>
-            </a:r>
-          </a:p>
-          <a:p>
-            <a:pPr>
-              <a:spcBef>
-                <a:spcPts val="300"/>
-              </a:spcBef>
-              <a:defRPr sz="1150">
-                <a:solidFill>
-                  <a:srgbClr val="0F172A"/>
-                </a:solidFill>
-                <a:latin typeface="Calibri"/>
-              </a:defRPr>
-            </a:pPr>
-            <a:r>
-              <a:t>•  Lệnh tái lập tự động toàn diện: uv run python scripts/reproduce_study.py --all</a:t>
-            </a:r>
-          </a:p>
-          <a:p>
-            <a:pPr>
-              <a:spcBef>
-                <a:spcPts val="300"/>
-              </a:spcBef>
-              <a:defRPr sz="1150">
-                <a:solidFill>
-                  <a:srgbClr val="0F172A"/>
-                </a:solidFill>
-                <a:latin typeface="Calibri"/>
-              </a:defRPr>
-            </a:pPr>
-            <a:r>
-              <a:t>•  Lệnh kiểm thử bộ test suite có bảo vệ: uv run python scripts/run_offline_tests.py</a:t>
-            </a:r>
-          </a:p>
-          <a:p>
-            <a:pPr>
-              <a:spcBef>
-                <a:spcPts val="300"/>
-              </a:spcBef>
-              <a:defRPr sz="1150">
-                <a:solidFill>
-                  <a:srgbClr val="0F172A"/>
-                </a:solidFill>
-                <a:latin typeface="Calibri"/>
-              </a:defRPr>
-            </a:pPr>
-            <a:r>
-              <a:t>•  Tuyệt đối không dùng pytest trần không có OFFLINE_GUARD.</a:t>
-            </a:r>
-          </a:p>
-          <a:p>
-            <a:pPr>
-              <a:spcBef>
-                <a:spcPts val="300"/>
-              </a:spcBef>
-              <a:defRPr sz="1150">
-                <a:solidFill>
-                  <a:srgbClr val="0F172A"/>
-                </a:solidFill>
-                <a:latin typeface="Calibri"/>
-              </a:defRPr>
-            </a:pPr>
-            <a:r>
-              <a:t>•  Điều kiện tái lập:</a:t>
-            </a:r>
-          </a:p>
-          <a:p>
-            <a:pPr>
-              <a:spcBef>
-                <a:spcPts val="300"/>
-              </a:spcBef>
-              <a:defRPr sz="1150">
-                <a:solidFill>
-                  <a:srgbClr val="0F172A"/>
-                </a:solidFill>
-                <a:latin typeface="Calibri"/>
-              </a:defRPr>
-            </a:pPr>
-            <a:r>
-              <a:t>  • Tái lập ngoại tuyến: Sử dụng 15 canonical artifacts đã khóa mật mã trong repo.</a:t>
-            </a:r>
-          </a:p>
-          <a:p>
-            <a:pPr>
-              <a:spcBef>
-                <a:spcPts val="300"/>
-              </a:spcBef>
-              <a:defRPr sz="1150">
-                <a:solidFill>
-                  <a:srgbClr val="0F172A"/>
-                </a:solidFill>
-                <a:latin typeface="Calibri"/>
-              </a:defRPr>
-            </a:pPr>
-            <a:r>
-              <a:t>  • Tái lập toàn diện luồng live provider: Yêu cầu nạp credentials thực và chạy dưới cơ chế budget guard trần $19.99 USD.</a:t>
-            </a:r>
-          </a:p>
-          <a:p>
-            <a:pPr>
-              <a:spcBef>
-                <a:spcPts val="300"/>
-              </a:spcBef>
-              <a:defRPr sz="1150">
-                <a:solidFill>
-                  <a:srgbClr val="0F172A"/>
-                </a:solidFill>
-                <a:latin typeface="Calibri"/>
-              </a:defRPr>
-            </a:pPr>
-            <a:r>
-              <a:t>•  Khóa mật mã 15 artifact cốt lõi trong canonical_experiment_lock_v1.json.</a:t>
-            </a:r>
-          </a:p>
-          <a:p>
-            <a:pPr>
-              <a:spcBef>
-                <a:spcPts val="300"/>
-              </a:spcBef>
-              <a:defRPr sz="1150">
-                <a:solidFill>
-                  <a:srgbClr val="0F172A"/>
-                </a:solidFill>
-                <a:latin typeface="Calibri"/>
-              </a:defRPr>
-            </a:pPr>
-            <a:r>
-              <a:t>•  Tự động phát hiện và chặn đứng mọi hành vi rò rỉ mã bí mật hoặc gọi API ra ngoài bằng offline_guard.</a:t>
+              <a:t>Tái Lập Ngoại Tuyến &amp; Phạm Vi Offline Guard</a:t>
+            </a:r>
+          </a:p>
+          <a:p>
+            <a:pPr>
+              <a:spcBef>
+                <a:spcPts val="250"/>
+              </a:spcBef>
+              <a:defRPr sz="1100">
+                <a:solidFill>
+                  <a:srgbClr val="0F172A"/>
+                </a:solidFill>
+                <a:latin typeface="Calibri"/>
+              </a:defRPr>
+            </a:pPr>
+            <a:r>
+              <a:t>•  Lệnh chuẩn tắc có bảo vệ ngoại tuyến:</a:t>
+            </a:r>
+          </a:p>
+          <a:p>
+            <a:pPr>
+              <a:spcBef>
+                <a:spcPts val="250"/>
+              </a:spcBef>
+              <a:defRPr sz="1100">
+                <a:solidFill>
+                  <a:srgbClr val="0F172A"/>
+                </a:solidFill>
+                <a:latin typeface="Calibri"/>
+              </a:defRPr>
+            </a:pPr>
+            <a:r>
+              <a:t>  python scripts/run_offline_tests.py -m pytest ... (hoặc cờ -c)</a:t>
+            </a:r>
+          </a:p>
+          <a:p>
+            <a:pPr>
+              <a:spcBef>
+                <a:spcPts val="250"/>
+              </a:spcBef>
+              <a:defRPr sz="1100">
+                <a:solidFill>
+                  <a:srgbClr val="0F172A"/>
+                </a:solidFill>
+                <a:latin typeface="Calibri"/>
+              </a:defRPr>
+            </a:pPr>
+            <a:r>
+              <a:t>•  Lệnh tái lập tự động toàn diện: python scripts/reproduce_study.py --all</a:t>
+            </a:r>
+          </a:p>
+          <a:p>
+            <a:pPr>
+              <a:spcBef>
+                <a:spcPts val="250"/>
+              </a:spcBef>
+              <a:defRPr sz="1100">
+                <a:solidFill>
+                  <a:srgbClr val="0F172A"/>
+                </a:solidFill>
+                <a:latin typeface="Calibri"/>
+              </a:defRPr>
+            </a:pPr>
+            <a:r>
+              <a:t>•  Phạm vi kỹ thuật của offline_guard:</a:t>
+            </a:r>
+          </a:p>
+          <a:p>
+            <a:pPr>
+              <a:spcBef>
+                <a:spcPts val="250"/>
+              </a:spcBef>
+              <a:defRPr sz="1100">
+                <a:solidFill>
+                  <a:srgbClr val="0F172A"/>
+                </a:solidFill>
+                <a:latin typeface="Calibri"/>
+              </a:defRPr>
+            </a:pPr>
+            <a:r>
+              <a:t>  • Can thiệp tầng socket Python (chặn kết nối mạng ngoài ý muốn) và lọc biến môi trường credentials.</a:t>
+            </a:r>
+          </a:p>
+          <a:p>
+            <a:pPr>
+              <a:spcBef>
+                <a:spcPts val="250"/>
+              </a:spcBef>
+              <a:defRPr sz="1100">
+                <a:solidFill>
+                  <a:srgbClr val="0F172A"/>
+                </a:solidFill>
+                <a:latin typeface="Calibri"/>
+              </a:defRPr>
+            </a:pPr>
+            <a:r>
+              <a:t>  • Không phải là sandbox cấp OS (không cô lập mã máy binary tùy ý ngoài Python runtime).</a:t>
+            </a:r>
+          </a:p>
+          <a:p>
+            <a:pPr>
+              <a:spcBef>
+                <a:spcPts val="250"/>
+              </a:spcBef>
+              <a:defRPr sz="1100">
+                <a:solidFill>
+                  <a:srgbClr val="0F172A"/>
+                </a:solidFill>
+                <a:latin typeface="Calibri"/>
+              </a:defRPr>
+            </a:pPr>
+            <a:r>
+              <a:t>  • Dependencies và artifact tiên quyết đã nạp sẵn cục bộ; lệnh uv run trần không có guard bảo vệ không tự động đảm bảo cách ly mạng nếu thiếu cờ offline.</a:t>
+            </a:r>
+          </a:p>
+          <a:p>
+            <a:pPr>
+              <a:spcBef>
+                <a:spcPts val="250"/>
+              </a:spcBef>
+              <a:defRPr sz="1100">
+                <a:solidFill>
+                  <a:srgbClr val="0F172A"/>
+                </a:solidFill>
+                <a:latin typeface="Calibri"/>
+              </a:defRPr>
+            </a:pPr>
+            <a:r>
+              <a:t>•  Điều kiện tái lập: Ngoại tuyến dùng 15 artifact đóng băng; luồng live provider cần credentials thực dưới budget guard trần $19.99 USD.</a:t>
             </a:r>
           </a:p>
         </p:txBody>
@@ -5853,9 +5913,9 @@
           <a:p>
             <a:pPr>
               <a:spcBef>
-                <a:spcPts val="800"/>
-              </a:spcBef>
-              <a:defRPr sz="1300">
+                <a:spcPts val="600"/>
+              </a:spcBef>
+              <a:defRPr sz="1250">
                 <a:solidFill>
                   <a:srgbClr val="E2E8F0"/>
                 </a:solidFill>
@@ -5863,15 +5923,15 @@
               </a:defRPr>
             </a:pPr>
             <a:r>
-              <a:t>•  RAG cung cấp tri thức nền tảng quan trọng, nhưng chất lượng khâu truy xuất (Retrieval) là yếu tố quyết định thành bại.</a:t>
-            </a:r>
-          </a:p>
-          <a:p>
-            <a:pPr>
-              <a:spcBef>
-                <a:spcPts val="800"/>
-              </a:spcBef>
-              <a:defRPr sz="1300">
+              <a:t>•  RAG cung cấp tri thức nền tảng quan trọng; giả thuyết RQ2 về mức độ ảnh hưởng nhân quả của retrieval đang được kiểm chứng đối chứng trên ma trận TEST.</a:t>
+            </a:r>
+          </a:p>
+          <a:p>
+            <a:pPr>
+              <a:spcBef>
+                <a:spcPts val="600"/>
+              </a:spcBef>
+              <a:defRPr sz="1250">
                 <a:solidFill>
                   <a:srgbClr val="E2E8F0"/>
                 </a:solidFill>
@@ -5879,15 +5939,15 @@
               </a:defRPr>
             </a:pPr>
             <a:r>
-              <a:t>•  Phân rã lỗi theo D2i (Independent Axes) định lượng độc lập lỗi tìm kiếm, lỗi sinh của mô hình và phần giao thoa.</a:t>
-            </a:r>
-          </a:p>
-          <a:p>
-            <a:pPr>
-              <a:spcBef>
-                <a:spcPts val="800"/>
-              </a:spcBef>
-              <a:defRPr sz="1300">
+              <a:t>•  Phân rã lỗi D2i theo 3 trục đo lường độc lập (retrieval miss, downstream generation failure, joint overlap), ghi nhận phần giao thoa khác 0, không giả định độc lập xác suất ngẫu nhiên.</a:t>
+            </a:r>
+          </a:p>
+          <a:p>
+            <a:pPr>
+              <a:spcBef>
+                <a:spcPts val="600"/>
+              </a:spcBef>
+              <a:defRPr sz="1250">
                 <a:solidFill>
                   <a:srgbClr val="E2E8F0"/>
                 </a:solidFill>
@@ -5895,15 +5955,15 @@
               </a:defRPr>
             </a:pPr>
             <a:r>
-              <a:t>•  Quy trình tái lập an toàn: Toàn bộ kiểm thử chạy qua runner offline scripts/run_offline_tests.py bảo đảm không rò rỉ credential.</a:t>
-            </a:r>
-          </a:p>
-          <a:p>
-            <a:pPr>
-              <a:spcBef>
-                <a:spcPts val="800"/>
-              </a:spcBef>
-              <a:defRPr sz="1300">
+              <a:t>•  Quy trình tái lập ngoại tuyến: Sử dụng runner scripts/run_offline_tests.py can thiệp tầng socket và lọc biến môi trường nhằm giảm thiểu rủi ro rò rỉ credential và kết nối ngoài ý muốn.</a:t>
+            </a:r>
+          </a:p>
+          <a:p>
+            <a:pPr>
+              <a:spcBef>
+                <a:spcPts val="600"/>
+              </a:spcBef>
+              <a:defRPr sz="1250">
                 <a:solidFill>
                   <a:srgbClr val="E2E8F0"/>
                 </a:solidFill>
@@ -5917,9 +5977,9 @@
           <a:p>
             <a:pPr>
               <a:spcBef>
-                <a:spcPts val="800"/>
-              </a:spcBef>
-              <a:defRPr sz="1300">
+                <a:spcPts val="600"/>
+              </a:spcBef>
+              <a:defRPr sz="1250">
                 <a:solidFill>
                   <a:srgbClr val="E2E8F0"/>
                 </a:solidFill>
@@ -5933,7 +5993,7 @@
           <a:p>
             <a:pPr>
               <a:spcBef>
-                <a:spcPts val="1800"/>
+                <a:spcPts val="1600"/>
               </a:spcBef>
               <a:defRPr sz="1500" b="1">
                 <a:solidFill>
@@ -6226,9 +6286,9 @@
           <a:p>
             <a:pPr>
               <a:spcBef>
-                <a:spcPts val="400"/>
-              </a:spcBef>
-              <a:defRPr sz="1200">
+                <a:spcPts val="350"/>
+              </a:spcBef>
+              <a:defRPr sz="1150">
                 <a:solidFill>
                   <a:srgbClr val="0F172A"/>
                 </a:solidFill>
@@ -6242,9 +6302,9 @@
           <a:p>
             <a:pPr>
               <a:spcBef>
-                <a:spcPts val="400"/>
-              </a:spcBef>
-              <a:defRPr sz="1200">
+                <a:spcPts val="350"/>
+              </a:spcBef>
+              <a:defRPr sz="1150">
                 <a:solidFill>
                   <a:srgbClr val="0F172A"/>
                 </a:solidFill>
@@ -6258,9 +6318,9 @@
           <a:p>
             <a:pPr>
               <a:spcBef>
-                <a:spcPts val="400"/>
-              </a:spcBef>
-              <a:defRPr sz="1200">
+                <a:spcPts val="350"/>
+              </a:spcBef>
+              <a:defRPr sz="1150">
                 <a:solidFill>
                   <a:srgbClr val="0F172A"/>
                 </a:solidFill>
@@ -6355,9 +6415,9 @@
           <a:p>
             <a:pPr>
               <a:spcBef>
-                <a:spcPts val="400"/>
-              </a:spcBef>
-              <a:defRPr sz="1200">
+                <a:spcPts val="350"/>
+              </a:spcBef>
+              <a:defRPr sz="1150">
                 <a:solidFill>
                   <a:srgbClr val="0F172A"/>
                 </a:solidFill>
@@ -6371,9 +6431,9 @@
           <a:p>
             <a:pPr>
               <a:spcBef>
-                <a:spcPts val="400"/>
-              </a:spcBef>
-              <a:defRPr sz="1200">
+                <a:spcPts val="350"/>
+              </a:spcBef>
+              <a:defRPr sz="1150">
                 <a:solidFill>
                   <a:srgbClr val="0F172A"/>
                 </a:solidFill>
@@ -6387,9 +6447,9 @@
           <a:p>
             <a:pPr>
               <a:spcBef>
-                <a:spcPts val="400"/>
-              </a:spcBef>
-              <a:defRPr sz="1200">
+                <a:spcPts val="350"/>
+              </a:spcBef>
+              <a:defRPr sz="1150">
                 <a:solidFill>
                   <a:srgbClr val="0F172A"/>
                 </a:solidFill>
@@ -6484,9 +6544,9 @@
           <a:p>
             <a:pPr>
               <a:spcBef>
-                <a:spcPts val="400"/>
-              </a:spcBef>
-              <a:defRPr sz="1200">
+                <a:spcPts val="350"/>
+              </a:spcBef>
+              <a:defRPr sz="1150">
                 <a:solidFill>
                   <a:srgbClr val="0F172A"/>
                 </a:solidFill>
@@ -6500,9 +6560,9 @@
           <a:p>
             <a:pPr>
               <a:spcBef>
-                <a:spcPts val="400"/>
-              </a:spcBef>
-              <a:defRPr sz="1200">
+                <a:spcPts val="350"/>
+              </a:spcBef>
+              <a:defRPr sz="1150">
                 <a:solidFill>
                   <a:srgbClr val="0F172A"/>
                 </a:solidFill>
@@ -6516,9 +6576,9 @@
           <a:p>
             <a:pPr>
               <a:spcBef>
-                <a:spcPts val="400"/>
-              </a:spcBef>
-              <a:defRPr sz="1200">
+                <a:spcPts val="350"/>
+              </a:spcBef>
+              <a:defRPr sz="1150">
                 <a:solidFill>
                   <a:srgbClr val="0F172A"/>
                 </a:solidFill>
@@ -6532,9 +6592,9 @@
           <a:p>
             <a:pPr>
               <a:spcBef>
-                <a:spcPts val="400"/>
-              </a:spcBef>
-              <a:defRPr sz="1200">
+                <a:spcPts val="350"/>
+              </a:spcBef>
+              <a:defRPr sz="1150">
                 <a:solidFill>
                   <a:srgbClr val="0F172A"/>
                 </a:solidFill>
@@ -6548,17 +6608,17 @@
           <a:p>
             <a:pPr>
               <a:spcBef>
-                <a:spcPts val="400"/>
-              </a:spcBef>
-              <a:defRPr sz="1200">
-                <a:solidFill>
-                  <a:srgbClr val="0F172A"/>
-                </a:solidFill>
-                <a:latin typeface="Calibri"/>
-              </a:defRPr>
-            </a:pPr>
-            <a:r>
-              <a:t>•  Tái lập ngoại tuyến chi phí 0 đồng với bộ offline_guard chặn tuyệt đối kết nối mạng ngoài.</a:t>
+                <a:spcPts val="350"/>
+              </a:spcBef>
+              <a:defRPr sz="1150">
+                <a:solidFill>
+                  <a:srgbClr val="0F172A"/>
+                </a:solidFill>
+                <a:latin typeface="Calibri"/>
+              </a:defRPr>
+            </a:pPr>
+            <a:r>
+              <a:t>•  Tái lập ngoại tuyến chi phí 0 đồng với bộ offline_guard chặn các kết nối mạng ngoài ý muốn.</a:t>
             </a:r>
           </a:p>
         </p:txBody>
@@ -6841,9 +6901,9 @@
           <a:p>
             <a:pPr>
               <a:spcBef>
-                <a:spcPts val="350"/>
-              </a:spcBef>
-              <a:defRPr sz="1200">
+                <a:spcPts val="300"/>
+              </a:spcBef>
+              <a:defRPr sz="1150">
                 <a:solidFill>
                   <a:srgbClr val="0F172A"/>
                 </a:solidFill>
@@ -6857,9 +6917,9 @@
           <a:p>
             <a:pPr>
               <a:spcBef>
-                <a:spcPts val="350"/>
-              </a:spcBef>
-              <a:defRPr sz="1200">
+                <a:spcPts val="300"/>
+              </a:spcBef>
+              <a:defRPr sz="1150">
                 <a:solidFill>
                   <a:srgbClr val="0F172A"/>
                 </a:solidFill>
@@ -6873,9 +6933,9 @@
           <a:p>
             <a:pPr>
               <a:spcBef>
-                <a:spcPts val="350"/>
-              </a:spcBef>
-              <a:defRPr sz="1200">
+                <a:spcPts val="300"/>
+              </a:spcBef>
+              <a:defRPr sz="1150">
                 <a:solidFill>
                   <a:srgbClr val="0F172A"/>
                 </a:solidFill>
@@ -6889,9 +6949,9 @@
           <a:p>
             <a:pPr>
               <a:spcBef>
-                <a:spcPts val="350"/>
-              </a:spcBef>
-              <a:defRPr sz="1200">
+                <a:spcPts val="300"/>
+              </a:spcBef>
+              <a:defRPr sz="1150">
                 <a:solidFill>
                   <a:srgbClr val="0F172A"/>
                 </a:solidFill>
@@ -6986,9 +7046,9 @@
           <a:p>
             <a:pPr>
               <a:spcBef>
-                <a:spcPts val="350"/>
-              </a:spcBef>
-              <a:defRPr sz="1200">
+                <a:spcPts val="300"/>
+              </a:spcBef>
+              <a:defRPr sz="1150">
                 <a:solidFill>
                   <a:srgbClr val="0F172A"/>
                 </a:solidFill>
@@ -7002,9 +7062,9 @@
           <a:p>
             <a:pPr>
               <a:spcBef>
-                <a:spcPts val="350"/>
-              </a:spcBef>
-              <a:defRPr sz="1200">
+                <a:spcPts val="300"/>
+              </a:spcBef>
+              <a:defRPr sz="1150">
                 <a:solidFill>
                   <a:srgbClr val="0F172A"/>
                 </a:solidFill>
@@ -7018,9 +7078,9 @@
           <a:p>
             <a:pPr>
               <a:spcBef>
-                <a:spcPts val="350"/>
-              </a:spcBef>
-              <a:defRPr sz="1200">
+                <a:spcPts val="300"/>
+              </a:spcBef>
+              <a:defRPr sz="1150">
                 <a:solidFill>
                   <a:srgbClr val="0F172A"/>
                 </a:solidFill>
@@ -7034,9 +7094,9 @@
           <a:p>
             <a:pPr>
               <a:spcBef>
-                <a:spcPts val="350"/>
-              </a:spcBef>
-              <a:defRPr sz="1200">
+                <a:spcPts val="300"/>
+              </a:spcBef>
+              <a:defRPr sz="1150">
                 <a:solidFill>
                   <a:srgbClr val="0F172A"/>
                 </a:solidFill>
@@ -7050,9 +7110,9 @@
           <a:p>
             <a:pPr>
               <a:spcBef>
-                <a:spcPts val="350"/>
-              </a:spcBef>
-              <a:defRPr sz="1200">
+                <a:spcPts val="300"/>
+              </a:spcBef>
+              <a:defRPr sz="1150">
                 <a:solidFill>
                   <a:srgbClr val="0F172A"/>
                 </a:solidFill>
@@ -7147,9 +7207,9 @@
           <a:p>
             <a:pPr>
               <a:spcBef>
-                <a:spcPts val="350"/>
-              </a:spcBef>
-              <a:defRPr sz="1200">
+                <a:spcPts val="300"/>
+              </a:spcBef>
+              <a:defRPr sz="1150">
                 <a:solidFill>
                   <a:srgbClr val="0F172A"/>
                 </a:solidFill>
@@ -7163,9 +7223,9 @@
           <a:p>
             <a:pPr>
               <a:spcBef>
-                <a:spcPts val="350"/>
-              </a:spcBef>
-              <a:defRPr sz="1200">
+                <a:spcPts val="300"/>
+              </a:spcBef>
+              <a:defRPr sz="1150">
                 <a:solidFill>
                   <a:srgbClr val="0F172A"/>
                 </a:solidFill>
@@ -7179,9 +7239,9 @@
           <a:p>
             <a:pPr>
               <a:spcBef>
-                <a:spcPts val="350"/>
-              </a:spcBef>
-              <a:defRPr sz="1200">
+                <a:spcPts val="300"/>
+              </a:spcBef>
+              <a:defRPr sz="1150">
                 <a:solidFill>
                   <a:srgbClr val="0F172A"/>
                 </a:solidFill>
@@ -7951,7 +8011,7 @@
               </a:defRPr>
             </a:pPr>
             <a:r>
-              <a:t>Khóa 7 quyết định khoa học D1-D7 và chính sách chấp nhận kỹ thuật lịch sử</a:t>
+              <a:t>Tách bạch rõ ràng 7 quyết định giao thức khoa học D1-D7 đóng băng</a:t>
             </a:r>
           </a:p>
         </p:txBody>
@@ -8038,9 +8098,9 @@
           <a:p>
             <a:pPr>
               <a:spcBef>
-                <a:spcPts val="300"/>
-              </a:spcBef>
-              <a:defRPr sz="1150">
+                <a:spcPts val="250"/>
+              </a:spcBef>
+              <a:defRPr sz="1100">
                 <a:solidFill>
                   <a:srgbClr val="0F172A"/>
                 </a:solidFill>
@@ -8054,9 +8114,9 @@
           <a:p>
             <a:pPr>
               <a:spcBef>
-                <a:spcPts val="300"/>
-              </a:spcBef>
-              <a:defRPr sz="1150">
+                <a:spcPts val="250"/>
+              </a:spcBef>
+              <a:defRPr sz="1100">
                 <a:solidFill>
                   <a:srgbClr val="0F172A"/>
                 </a:solidFill>
@@ -8070,9 +8130,9 @@
           <a:p>
             <a:pPr>
               <a:spcBef>
-                <a:spcPts val="300"/>
-              </a:spcBef>
-              <a:defRPr sz="1150">
+                <a:spcPts val="250"/>
+              </a:spcBef>
+              <a:defRPr sz="1100">
                 <a:solidFill>
                   <a:srgbClr val="0F172A"/>
                 </a:solidFill>
@@ -8086,9 +8146,9 @@
           <a:p>
             <a:pPr>
               <a:spcBef>
-                <a:spcPts val="300"/>
-              </a:spcBef>
-              <a:defRPr sz="1150">
+                <a:spcPts val="250"/>
+              </a:spcBef>
+              <a:defRPr sz="1100">
                 <a:solidFill>
                   <a:srgbClr val="0F172A"/>
                 </a:solidFill>
@@ -8102,41 +8162,41 @@
           <a:p>
             <a:pPr>
               <a:spcBef>
-                <a:spcPts val="300"/>
-              </a:spcBef>
-              <a:defRPr sz="1150">
-                <a:solidFill>
-                  <a:srgbClr val="0F172A"/>
-                </a:solidFill>
-                <a:latin typeface="Calibri"/>
-              </a:defRPr>
-            </a:pPr>
-            <a:r>
-              <a:t>•  Không gian lớp mục tiêu (D2d: FROZEN_BENCHMARK_UNIVERSE):</a:t>
-            </a:r>
-          </a:p>
-          <a:p>
-            <a:pPr>
-              <a:spcBef>
-                <a:spcPts val="300"/>
-              </a:spcBef>
-              <a:defRPr sz="1150">
-                <a:solidFill>
-                  <a:srgbClr val="0F172A"/>
-                </a:solidFill>
-                <a:latin typeface="Calibri"/>
-              </a:defRPr>
-            </a:pPr>
-            <a:r>
-              <a:t>  • Macro-F1 tính trên tập các lớp kỹ thuật chuẩn đóng băng, đảm bảo tính nhất quán giữa các lần chạy.</a:t>
-            </a:r>
-          </a:p>
-          <a:p>
-            <a:pPr>
-              <a:spcBef>
-                <a:spcPts val="300"/>
-              </a:spcBef>
-              <a:defRPr sz="1150">
+                <a:spcPts val="250"/>
+              </a:spcBef>
+              <a:defRPr sz="1100">
+                <a:solidFill>
+                  <a:srgbClr val="0F172A"/>
+                </a:solidFill>
+                <a:latin typeface="Calibri"/>
+              </a:defRPr>
+            </a:pPr>
+            <a:r>
+              <a:t>•  Vũ trụ Macro-F1 cố định (D2d: FROZEN_BENCHMARK_UNIVERSE = 474):</a:t>
+            </a:r>
+          </a:p>
+          <a:p>
+            <a:pPr>
+              <a:spcBef>
+                <a:spcPts val="250"/>
+              </a:spcBef>
+              <a:defRPr sz="1100">
+                <a:solidFill>
+                  <a:srgbClr val="0F172A"/>
+                </a:solidFill>
+                <a:latin typeface="Calibri"/>
+              </a:defRPr>
+            </a:pPr>
+            <a:r>
+              <a:t>  • Tính Macro-F1 trên đúng 474 lớp kỹ thuật chuẩn đóng băng, đảm bảo nhất quán giữa các lần chạy.</a:t>
+            </a:r>
+          </a:p>
+          <a:p>
+            <a:pPr>
+              <a:spcBef>
+                <a:spcPts val="250"/>
+              </a:spcBef>
+              <a:defRPr sz="1100">
                 <a:solidFill>
                   <a:srgbClr val="0F172A"/>
                 </a:solidFill>
@@ -8150,9 +8210,9 @@
           <a:p>
             <a:pPr>
               <a:spcBef>
-                <a:spcPts val="300"/>
-              </a:spcBef>
-              <a:defRPr sz="1150">
+                <a:spcPts val="250"/>
+              </a:spcBef>
+              <a:defRPr sz="1100">
                 <a:solidFill>
                   <a:srgbClr val="0F172A"/>
                 </a:solidFill>
@@ -8166,9 +8226,9 @@
           <a:p>
             <a:pPr>
               <a:spcBef>
-                <a:spcPts val="300"/>
-              </a:spcBef>
-              <a:defRPr sz="1150">
+                <a:spcPts val="250"/>
+              </a:spcBef>
+              <a:defRPr sz="1100">
                 <a:solidFill>
                   <a:srgbClr val="0F172A"/>
                 </a:solidFill>
@@ -8257,15 +8317,15 @@
               </a:defRPr>
             </a:pPr>
             <a:r>
-              <a:t>4 Tiêu Chí Đánh Giá Cốt Lõi (D2h, D2i, D2e, D2f)</a:t>
-            </a:r>
-          </a:p>
-          <a:p>
-            <a:pPr>
-              <a:spcBef>
-                <a:spcPts val="300"/>
-              </a:spcBef>
-              <a:defRPr sz="1150">
+              <a:t>Các Tiêu Chí Giao Thức Đánh Giá Cốt Lõi</a:t>
+            </a:r>
+          </a:p>
+          <a:p>
+            <a:pPr>
+              <a:spcBef>
+                <a:spcPts val="250"/>
+              </a:spcBef>
+              <a:defRPr sz="1100">
                 <a:solidFill>
                   <a:srgbClr val="0F172A"/>
                 </a:solidFill>
@@ -8279,9 +8339,9 @@
           <a:p>
             <a:pPr>
               <a:spcBef>
-                <a:spcPts val="300"/>
-              </a:spcBef>
-              <a:defRPr sz="1150">
+                <a:spcPts val="250"/>
+              </a:spcBef>
+              <a:defRPr sz="1100">
                 <a:solidFill>
                   <a:srgbClr val="0F172A"/>
                 </a:solidFill>
@@ -8295,9 +8355,9 @@
           <a:p>
             <a:pPr>
               <a:spcBef>
-                <a:spcPts val="300"/>
-              </a:spcBef>
-              <a:defRPr sz="1150">
+                <a:spcPts val="250"/>
+              </a:spcBef>
+              <a:defRPr sz="1100">
                 <a:solidFill>
                   <a:srgbClr val="0F172A"/>
                 </a:solidFill>
@@ -8311,89 +8371,89 @@
           <a:p>
             <a:pPr>
               <a:spcBef>
-                <a:spcPts val="300"/>
-              </a:spcBef>
-              <a:defRPr sz="1150">
-                <a:solidFill>
-                  <a:srgbClr val="0F172A"/>
-                </a:solidFill>
-                <a:latin typeface="Calibri"/>
-              </a:defRPr>
-            </a:pPr>
-            <a:r>
-              <a:t>  • Bóc tách độc lập lỗi tìm kiếm và phân loại trên các trục trực giao; ghi nhận đầy đủ phần giao thoa (overlap).</a:t>
-            </a:r>
-          </a:p>
-          <a:p>
-            <a:pPr>
-              <a:spcBef>
-                <a:spcPts val="300"/>
-              </a:spcBef>
-              <a:defRPr sz="1150">
-                <a:solidFill>
-                  <a:srgbClr val="0F172A"/>
-                </a:solidFill>
-                <a:latin typeface="Calibri"/>
-              </a:defRPr>
-            </a:pPr>
-            <a:r>
-              <a:t>•  D2e: Invalid ATT&amp;CK ID Denominator (INCLUDE_IN_DENOMINATOR):</a:t>
-            </a:r>
-          </a:p>
-          <a:p>
-            <a:pPr>
-              <a:spcBef>
-                <a:spcPts val="300"/>
-              </a:spcBef>
-              <a:defRPr sz="1150">
-                <a:solidFill>
-                  <a:srgbClr val="0F172A"/>
-                </a:solidFill>
-                <a:latin typeface="Calibri"/>
-              </a:defRPr>
-            </a:pPr>
-            <a:r>
-              <a:t>  • Mã kỹ thuật ảo giác, sai cú pháp đều bị tính là thất bại (Fail-Closed).</a:t>
-            </a:r>
-          </a:p>
-          <a:p>
-            <a:pPr>
-              <a:spcBef>
-                <a:spcPts val="300"/>
-              </a:spcBef>
-              <a:defRPr sz="1150">
-                <a:solidFill>
-                  <a:srgbClr val="0F172A"/>
-                </a:solidFill>
-                <a:latin typeface="Calibri"/>
-              </a:defRPr>
-            </a:pPr>
-            <a:r>
-              <a:t>•  D2f: Provider Failure Denominator (INCLUDE_IN_DENOMINATOR):</a:t>
-            </a:r>
-          </a:p>
-          <a:p>
-            <a:pPr>
-              <a:spcBef>
-                <a:spcPts val="300"/>
-              </a:spcBef>
-              <a:defRPr sz="1150">
-                <a:solidFill>
-                  <a:srgbClr val="0F172A"/>
-                </a:solidFill>
-                <a:latin typeface="Calibri"/>
-              </a:defRPr>
-            </a:pPr>
-            <a:r>
-              <a:t>  • Lỗi API, timeout, refusal đều tính vào mẫu số, không được loại trừ.</a:t>
-            </a:r>
-          </a:p>
-          <a:p>
-            <a:pPr>
-              <a:spcBef>
-                <a:spcPts val="300"/>
-              </a:spcBef>
-              <a:defRPr sz="1150">
+                <a:spcPts val="250"/>
+              </a:spcBef>
+              <a:defRPr sz="1100">
+                <a:solidFill>
+                  <a:srgbClr val="0F172A"/>
+                </a:solidFill>
+                <a:latin typeface="Calibri"/>
+              </a:defRPr>
+            </a:pPr>
+            <a:r>
+              <a:t>  • Bóc tách lỗi thành các trục đo lường độc lập; ghi nhận đầy đủ phần giao thoa khác 0 (non-zero overlap).</a:t>
+            </a:r>
+          </a:p>
+          <a:p>
+            <a:pPr>
+              <a:spcBef>
+                <a:spcPts val="250"/>
+              </a:spcBef>
+              <a:defRPr sz="1100">
+                <a:solidFill>
+                  <a:srgbClr val="0F172A"/>
+                </a:solidFill>
+                <a:latin typeface="Calibri"/>
+              </a:defRPr>
+            </a:pPr>
+            <a:r>
+              <a:t>•  D2e: Invalid ID Denominator (invalid_id_as_failure / INCLUDE_IN_DENOMINATOR):</a:t>
+            </a:r>
+          </a:p>
+          <a:p>
+            <a:pPr>
+              <a:spcBef>
+                <a:spcPts val="250"/>
+              </a:spcBef>
+              <a:defRPr sz="1100">
+                <a:solidFill>
+                  <a:srgbClr val="0F172A"/>
+                </a:solidFill>
+                <a:latin typeface="Calibri"/>
+              </a:defRPr>
+            </a:pPr>
+            <a:r>
+              <a:t>  • Mã kỹ thuật ảo giác, sai cú pháp đều bị tính là thất bại trong mẫu số end-to-end (Fail-Closed).</a:t>
+            </a:r>
+          </a:p>
+          <a:p>
+            <a:pPr>
+              <a:spcBef>
+                <a:spcPts val="250"/>
+              </a:spcBef>
+              <a:defRPr sz="1100">
+                <a:solidFill>
+                  <a:srgbClr val="0F172A"/>
+                </a:solidFill>
+                <a:latin typeface="Calibri"/>
+              </a:defRPr>
+            </a:pPr>
+            <a:r>
+              <a:t>•  D2f: Provider Failure Denominator (api_failure_as_failure / INCLUDE_IN_DENOMINATOR):</a:t>
+            </a:r>
+          </a:p>
+          <a:p>
+            <a:pPr>
+              <a:spcBef>
+                <a:spcPts val="250"/>
+              </a:spcBef>
+              <a:defRPr sz="1100">
+                <a:solidFill>
+                  <a:srgbClr val="0F172A"/>
+                </a:solidFill>
+                <a:latin typeface="Calibri"/>
+              </a:defRPr>
+            </a:pPr>
+            <a:r>
+              <a:t>  • Lỗi API, timeout, refusal đều tính vào mẫu số thất bại end-to-end, không được loại trừ.</a:t>
+            </a:r>
+          </a:p>
+          <a:p>
+            <a:pPr>
+              <a:spcBef>
+                <a:spcPts val="250"/>
+              </a:spcBef>
+              <a:defRPr sz="1100">
                 <a:solidFill>
                   <a:srgbClr val="0F172A"/>
                 </a:solidFill>
@@ -8407,9 +8467,9 @@
           <a:p>
             <a:pPr>
               <a:spcBef>
-                <a:spcPts val="300"/>
-              </a:spcBef>
-              <a:defRPr sz="1150">
+                <a:spcPts val="250"/>
+              </a:spcBef>
+              <a:defRPr sz="1100">
                 <a:solidFill>
                   <a:srgbClr val="0F172A"/>
                 </a:solidFill>
@@ -9904,25 +9964,25 @@
           <a:p>
             <a:pPr>
               <a:spcBef>
-                <a:spcPts val="300"/>
-              </a:spcBef>
-              <a:defRPr sz="1150">
-                <a:solidFill>
-                  <a:srgbClr val="0F172A"/>
-                </a:solidFill>
-                <a:latin typeface="Calibri"/>
-              </a:defRPr>
-            </a:pPr>
-            <a:r>
-              <a:t>•  Định đề D2i quy định retrieval failure và downstream generation failure là CÁC TRỤC ĐỘC LẬP (Independent Axes), không phải phân hoạch xung khắc rời rạc (phần giao thoa khác 0).</a:t>
-            </a:r>
-          </a:p>
-          <a:p>
-            <a:pPr>
-              <a:spcBef>
-                <a:spcPts val="300"/>
-              </a:spcBef>
-              <a:defRPr sz="1150">
+                <a:spcPts val="250"/>
+              </a:spcBef>
+              <a:defRPr sz="1100">
+                <a:solidFill>
+                  <a:srgbClr val="0F172A"/>
+                </a:solidFill>
+                <a:latin typeface="Calibri"/>
+              </a:defRPr>
+            </a:pPr>
+            <a:r>
+              <a:t>•  Định đề D2i quy định retrieval failure và downstream generation failure là CÁC TRỤC ĐO LƯỜNG ĐỘC LẬP (Independent Measurement Axes), không phải phân hoạch xung khắc rời rạc, không giả định độc lập xác suất ngẫu nhiên (phần giao thoa khác 0).</a:t>
+            </a:r>
+          </a:p>
+          <a:p>
+            <a:pPr>
+              <a:spcBef>
+                <a:spcPts val="250"/>
+              </a:spcBef>
+              <a:defRPr sz="1100">
                 <a:solidFill>
                   <a:srgbClr val="0F172A"/>
                 </a:solidFill>
@@ -9936,9 +9996,9 @@
           <a:p>
             <a:pPr>
               <a:spcBef>
-                <a:spcPts val="300"/>
-              </a:spcBef>
-              <a:defRPr sz="1150">
+                <a:spcPts val="250"/>
+              </a:spcBef>
+              <a:defRPr sz="1100">
                 <a:solidFill>
                   <a:srgbClr val="0F172A"/>
                 </a:solidFill>
@@ -9952,9 +10012,9 @@
           <a:p>
             <a:pPr>
               <a:spcBef>
-                <a:spcPts val="300"/>
-              </a:spcBef>
-              <a:defRPr sz="1150">
+                <a:spcPts val="250"/>
+              </a:spcBef>
+              <a:defRPr sz="1100">
                 <a:solidFill>
                   <a:srgbClr val="0F172A"/>
                 </a:solidFill>
@@ -10091,7 +10151,7 @@
               </a:defRPr>
             </a:pPr>
             <a:r>
-              <a:t>•  Macro-F1 &amp; Exact Match: Tính trên không gian kỹ thuật chuẩn Frozen Benchmark Universe (D2d).</a:t>
+              <a:t>•  Macro-F1 &amp; Exact Match: Tính trên không gian kỹ thuật chuẩn Frozen Benchmark Universe (D2d = 474).</a:t>
             </a:r>
           </a:p>
           <a:p>
@@ -10435,7 +10495,7 @@
               </a:defRPr>
             </a:pPr>
             <a:r>
-              <a:t>8. Nghiên Cứu Tiêu Thụ Tài Nguyên &amp; Chi Phí Thực Nghiệm (RQ3)</a:t>
+              <a:t>8. Tiêu Thụ Tài Nguyên &amp; Chi Phí Thực Nghiệm (RQ3)</a:t>
             </a:r>
           </a:p>
           <a:p>
@@ -10448,7 +10508,7 @@
               </a:defRPr>
             </a:pPr>
             <a:r>
-              <a:t>Đo lường từ DEV Cost Pilot trên OpenAI gpt-5.6-luna xhigh và kiểm soát ngân sách</a:t>
+              <a:t>Dữ liệu DEV pilot (synthetic split), hạch toán token ước tính và kiểm soát ngân sách</a:t>
             </a:r>
           </a:p>
         </p:txBody>
@@ -10529,63 +10589,79 @@
               </a:defRPr>
             </a:pPr>
             <a:r>
-              <a:t>DEV Cost Pilot &amp; Kiểm Soát Ngân Sách (RQ3)</a:t>
-            </a:r>
-          </a:p>
-          <a:p>
-            <a:pPr>
-              <a:spcBef>
-                <a:spcPts val="250"/>
-              </a:spcBef>
-              <a:defRPr sz="1150">
-                <a:solidFill>
-                  <a:srgbClr val="0F172A"/>
-                </a:solidFill>
-                <a:latin typeface="Calibri"/>
-              </a:defRPr>
-            </a:pPr>
-            <a:r>
-              <a:t>•  Mục đích: Đo lường mức tăng trưởng token thực tế và kiểm tra độ ổn định schema.</a:t>
-            </a:r>
-          </a:p>
-          <a:p>
-            <a:pPr>
-              <a:spcBef>
-                <a:spcPts val="250"/>
-              </a:spcBef>
-              <a:defRPr sz="1150">
-                <a:solidFill>
-                  <a:srgbClr val="0F172A"/>
-                </a:solidFill>
-                <a:latin typeface="Calibri"/>
-              </a:defRPr>
-            </a:pPr>
-            <a:r>
-              <a:t>•  Quy mô: 20 yêu cầu thực tế qua Responses API trên 4 DEV views x 5 điều kiện (100% VALID, 0 retry, trễ TB 8,127.6 ms).</a:t>
-            </a:r>
-          </a:p>
-          <a:p>
-            <a:pPr>
-              <a:spcBef>
-                <a:spcPts val="250"/>
-              </a:spcBef>
-              <a:defRPr sz="1150">
-                <a:solidFill>
-                  <a:srgbClr val="0F172A"/>
-                </a:solidFill>
-                <a:latin typeface="Calibri"/>
-              </a:defRPr>
-            </a:pPr>
-            <a:r>
-              <a:t>•  Ước tính từ dữ liệu telemetry pilot ban đầu:</a:t>
-            </a:r>
-          </a:p>
-          <a:p>
-            <a:pPr>
-              <a:spcBef>
-                <a:spcPts val="250"/>
-              </a:spcBef>
-              <a:defRPr sz="1150">
+              <a:t>DEV Cost Pilot (Synthetic Split) &amp; Chi Phí Hạch Toán</a:t>
+            </a:r>
+          </a:p>
+          <a:p>
+            <a:pPr>
+              <a:spcBef>
+                <a:spcPts val="200"/>
+              </a:spcBef>
+              <a:defRPr sz="1050">
+                <a:solidFill>
+                  <a:srgbClr val="0F172A"/>
+                </a:solidFill>
+                <a:latin typeface="Calibri"/>
+              </a:defRPr>
+            </a:pPr>
+            <a:r>
+              <a:t>•  Bản chất dữ liệu: DEV cohort là dữ liệu tổng hợp (synthetic-paired-v1 DEV split, 4 views x 5 điều kiện). Gửi request thực lên LLM provider không biến log tổng hợp thành in-the-wild telemetry.</a:t>
+            </a:r>
+          </a:p>
+          <a:p>
+            <a:pPr>
+              <a:spcBef>
+                <a:spcPts val="200"/>
+              </a:spcBef>
+              <a:defRPr sz="1050">
+                <a:solidFill>
+                  <a:srgbClr val="0F172A"/>
+                </a:solidFill>
+                <a:latin typeface="Calibri"/>
+              </a:defRPr>
+            </a:pPr>
+            <a:r>
+              <a:t>•  Quy mô pilot: 20 requests thực tế qua Responses API (100% VALID, 0 retry, trễ TB 8,127.6 ms).</a:t>
+            </a:r>
+          </a:p>
+          <a:p>
+            <a:pPr>
+              <a:spcBef>
+                <a:spcPts val="200"/>
+              </a:spcBef>
+              <a:defRPr sz="1050">
+                <a:solidFill>
+                  <a:srgbClr val="0F172A"/>
+                </a:solidFill>
+                <a:latin typeface="Calibri"/>
+              </a:defRPr>
+            </a:pPr>
+            <a:r>
+              <a:t>•  Chi phí hạch toán ước tính từ token quan sát được và biểu giá công bố (Estimated / Accounted Cost):</a:t>
+            </a:r>
+          </a:p>
+          <a:p>
+            <a:pPr>
+              <a:spcBef>
+                <a:spcPts val="200"/>
+              </a:spcBef>
+              <a:defRPr sz="1050">
+                <a:solidFill>
+                  <a:srgbClr val="0F172A"/>
+                </a:solidFill>
+                <a:latin typeface="Calibri"/>
+              </a:defRPr>
+            </a:pPr>
+            <a:r>
+              <a:t>  • Pilot 20 requests: $0.024209 USD (conservative: $0.026320 USD) theo đơn giá.</a:t>
+            </a:r>
+          </a:p>
+          <a:p>
+            <a:pPr>
+              <a:spcBef>
+                <a:spcPts val="200"/>
+              </a:spcBef>
+              <a:defRPr sz="1050">
                 <a:solidFill>
                   <a:srgbClr val="0F172A"/>
                 </a:solidFill>
@@ -10599,9 +10675,9 @@
           <a:p>
             <a:pPr>
               <a:spcBef>
-                <a:spcPts val="250"/>
-              </a:spcBef>
-              <a:defRPr sz="1150">
+                <a:spcPts val="200"/>
+              </a:spcBef>
+              <a:defRPr sz="1050">
                 <a:solidFill>
                   <a:srgbClr val="0F172A"/>
                 </a:solidFill>
@@ -10615,9 +10691,9 @@
           <a:p>
             <a:pPr>
               <a:spcBef>
-                <a:spcPts val="250"/>
-              </a:spcBef>
-              <a:defRPr sz="1150">
+                <a:spcPts val="200"/>
+              </a:spcBef>
+              <a:defRPr sz="1050">
                 <a:solidFill>
                   <a:srgbClr val="0F172A"/>
                 </a:solidFill>
@@ -10631,9 +10707,9 @@
           <a:p>
             <a:pPr>
               <a:spcBef>
-                <a:spcPts val="250"/>
-              </a:spcBef>
-              <a:defRPr sz="1150">
+                <a:spcPts val="200"/>
+              </a:spcBef>
+              <a:defRPr sz="1050">
                 <a:solidFill>
                   <a:srgbClr val="0F172A"/>
                 </a:solidFill>
@@ -10647,9 +10723,9 @@
           <a:p>
             <a:pPr>
               <a:spcBef>
-                <a:spcPts val="250"/>
-              </a:spcBef>
-              <a:defRPr sz="1150">
+                <a:spcPts val="200"/>
+              </a:spcBef>
+              <a:defRPr sz="1050">
                 <a:solidFill>
                   <a:srgbClr val="0F172A"/>
                 </a:solidFill>
@@ -10663,81 +10739,65 @@
           <a:p>
             <a:pPr>
               <a:spcBef>
-                <a:spcPts val="250"/>
-              </a:spcBef>
-              <a:defRPr sz="1150">
-                <a:solidFill>
-                  <a:srgbClr val="0F172A"/>
-                </a:solidFill>
-                <a:latin typeface="Calibri"/>
-              </a:defRPr>
-            </a:pPr>
-            <a:r>
-              <a:t>•  Phân định rõ chi phí thực nghiệm:</a:t>
-            </a:r>
-          </a:p>
-          <a:p>
-            <a:pPr>
-              <a:spcBef>
-                <a:spcPts val="250"/>
-              </a:spcBef>
-              <a:defRPr sz="1150">
-                <a:solidFill>
-                  <a:srgbClr val="0F172A"/>
-                </a:solidFill>
-                <a:latin typeface="Calibri"/>
-              </a:defRPr>
-            </a:pPr>
-            <a:r>
-              <a:t>  • Quyết toán thực tế (Verified Spend): $0.024209 USD (conservative: $0.026320 USD).</a:t>
-            </a:r>
-          </a:p>
-          <a:p>
-            <a:pPr>
-              <a:spcBef>
-                <a:spcPts val="250"/>
-              </a:spcBef>
-              <a:defRPr sz="1150">
-                <a:solidFill>
-                  <a:srgbClr val="0F172A"/>
-                </a:solidFill>
-                <a:latin typeface="Calibri"/>
-              </a:defRPr>
-            </a:pPr>
-            <a:r>
-              <a:t>  • Dự phóng tập TEST (Projected Spend): $8.20 – $8.99 USD cho 6,400 requests.</a:t>
-            </a:r>
-          </a:p>
-          <a:p>
-            <a:pPr>
-              <a:spcBef>
-                <a:spcPts val="250"/>
-              </a:spcBef>
-              <a:defRPr sz="1150">
-                <a:solidFill>
-                  <a:srgbClr val="0F172A"/>
-                </a:solidFill>
-                <a:latin typeface="Calibri"/>
-              </a:defRPr>
-            </a:pPr>
-            <a:r>
-              <a:t>  • Trần ngân sách đóng băng: $19.99 USD (hard_budget_limit_usd).</a:t>
-            </a:r>
-          </a:p>
-          <a:p>
-            <a:pPr>
-              <a:spcBef>
-                <a:spcPts val="250"/>
-              </a:spcBef>
-              <a:defRPr sz="1150">
-                <a:solidFill>
-                  <a:srgbClr val="0F172A"/>
-                </a:solidFill>
-                <a:latin typeface="Calibri"/>
-              </a:defRPr>
-            </a:pPr>
-            <a:r>
-              <a:t>  • Khoản giữ chỗ conservative pilot: $0.05264010 USD (reserved_budget_usd).</a:t>
+                <a:spcPts val="200"/>
+              </a:spcBef>
+              <a:defRPr sz="1050">
+                <a:solidFill>
+                  <a:srgbClr val="0F172A"/>
+                </a:solidFill>
+                <a:latin typeface="Calibri"/>
+              </a:defRPr>
+            </a:pPr>
+            <a:r>
+              <a:t>•  Phân định rõ ranh giới ngân sách:</a:t>
+            </a:r>
+          </a:p>
+          <a:p>
+            <a:pPr>
+              <a:spcBef>
+                <a:spcPts val="200"/>
+              </a:spcBef>
+              <a:defRPr sz="1050">
+                <a:solidFill>
+                  <a:srgbClr val="0F172A"/>
+                </a:solidFill>
+                <a:latin typeface="Calibri"/>
+              </a:defRPr>
+            </a:pPr>
+            <a:r>
+              <a:t>  • Giữ chỗ thận trọng tạm thời: $0.05264010 USD (prior_pilot_provisional_hold_usd).</a:t>
+            </a:r>
+          </a:p>
+          <a:p>
+            <a:pPr>
+              <a:spcBef>
+                <a:spcPts val="200"/>
+              </a:spcBef>
+              <a:defRPr sz="1050">
+                <a:solidFill>
+                  <a:srgbClr val="0F172A"/>
+                </a:solidFill>
+                <a:latin typeface="Calibri"/>
+              </a:defRPr>
+            </a:pPr>
+            <a:r>
+              <a:t>  • Dự báo chuẩn tắc tập TEST (Canonical forecast): $8.20 – $8.99 USD cho 6,400 requests.</a:t>
+            </a:r>
+          </a:p>
+          <a:p>
+            <a:pPr>
+              <a:spcBef>
+                <a:spcPts val="200"/>
+              </a:spcBef>
+              <a:defRPr sz="1050">
+                <a:solidFill>
+                  <a:srgbClr val="0F172A"/>
+                </a:solidFill>
+                <a:latin typeface="Calibri"/>
+              </a:defRPr>
+            </a:pPr>
+            <a:r>
+              <a:t>  • Trần ngân sách đóng băng cứng (Hard budget cap): $19.99 USD (hard_budget_limit_usd).</a:t>
             </a:r>
           </a:p>
         </p:txBody>
@@ -10874,7 +10934,7 @@
               </a:defRPr>
             </a:pPr>
             <a:r>
-              <a:t>•  Toàn bộ chi phí dự phóng cho tập TEST (&lt; $10 USD) nằm an toàn dưới trần ngân sách đóng băng $19.99 USD.</a:t>
+              <a:t>•  Dự báo chuẩn tắc tập TEST (&lt; $10 USD) nằm an toàn dưới trần ngân sách đóng băng $19.99 USD.</a:t>
             </a:r>
           </a:p>
         </p:txBody>

</xml_diff>

<commit_message>
fix(presentation): clarify determinism scope and clean up title slide per D_CLARIFICATION
</commit_message>
<xml_diff>
--- a/docs/presentation/slides.pptx
+++ b/docs/presentation/slides.pptx
@@ -848,12 +848,12 @@
           </a:p>
           <a:p>
             <a:r>
-              <a:t>Trong thực tế giám sát SOC, các kỹ sư thường kỳ vọng LLM có thể đọc log và gán ngay mã ATT&amp;CK. Tuy nhiên, nếu không có cơ chế neo tri thức, LLM thường gặp ảo giác hoặc nhầm lẫn giữa các kỹ thuật lân cận. Nghiên cứu này đo lường khoa học mức độ hỗ trợ của RAG dưới các điều kiện đối chứng chặt chẽ. Toàn bộ thực thi đạt tính xác định (Deterministic Execution under Frozen Environment &amp; Seeds), loại trừ hoàn toàn tính tùy tiện trong diễn giải số liệu.</a:t>
-            </a:r>
-          </a:p>
-          <a:p>
-            <a:r>
-              <a:t>Bằng chứng dự án: docs/README_PROPOSED.md; config/canonical_experiment_lock_v1.json (SHA-256: 961ba9b3...); tests/test_attack_id_validation.py.</a:t>
+              <a:t>Trong thực tế giám sát SOC, các kỹ sư thường kỳ vọng LLM có thể đọc log và gán ngay mã ATT&amp;CK. Tuy nhiên, nếu không có cơ chế neo tri thức, LLM thường gặp ảo giác hoặc nhầm lẫn giữa các kỹ thuật lân cận. Nghiên cứu này định lượng khách quan mức độ hỗ trợ của RAG dưới các điều kiện đối chứng chặt chẽ, không phóng đại hiệu năng. Chúng tôi làm rõ phạm vi tính xác định (determinism): tính xác định áp dụng tuyệt đối cho khâu tái tạo bộ dữ liệu, quy trình thẩm định đánh giá ngoại tuyến và quy tắc xử lý thứ tự tie-breaking. Đối với mô hình LLM, phản hồi và backend mô hình thực tế có thể biến thiên do tham số seed không được truyền qua giao thức mạng; sự biến thiên này được theo dõi và ghi nhận chặt chẽ theo chính sách siêu dữ liệu ràng buộc tem thời gian D3 (timestamp-bound metadata policy).</a:t>
+            </a:r>
+          </a:p>
+          <a:p>
+            <a:r>
+              <a:t>Bằng chứng dự án: docs/README_PROPOSED.md; config/canonical_experiment_lock_v1.json (SHA-256: 961ba9b3...); reports/experiment_protocol_v1.md (D3 policy); tests/test_attack_id_validation.py.</a:t>
             </a:r>
           </a:p>
         </p:txBody>
@@ -4634,7 +4634,7 @@
               </a:defRPr>
             </a:pPr>
             <a:r>
-              <a:t>Giao thức khoa học: experiment-protocol-v1.1  |  Khóa chuẩn: canonical-lock-v1  |  Tác tạo: Python-pptx automated pipeline</a:t>
+              <a:t>Giao thức khoa học: experiment-protocol-v1.1  |  Khóa chuẩn: canonical-lock-v1</a:t>
             </a:r>
           </a:p>
         </p:txBody>
@@ -6544,41 +6544,41 @@
           <a:p>
             <a:pPr>
               <a:spcBef>
-                <a:spcPts val="350"/>
-              </a:spcBef>
-              <a:defRPr sz="1150">
-                <a:solidFill>
-                  <a:srgbClr val="0F172A"/>
-                </a:solidFill>
-                <a:latin typeface="Calibri"/>
-              </a:defRPr>
-            </a:pPr>
-            <a:r>
-              <a:t>•  Thiết kế nghiên cứu thực nghiệm có kiểm soát (Controlled Empirical Study).</a:t>
-            </a:r>
-          </a:p>
-          <a:p>
-            <a:pPr>
-              <a:spcBef>
-                <a:spcPts val="350"/>
-              </a:spcBef>
-              <a:defRPr sz="1150">
-                <a:solidFill>
-                  <a:srgbClr val="0F172A"/>
-                </a:solidFill>
-                <a:latin typeface="Calibri"/>
-              </a:defRPr>
-            </a:pPr>
-            <a:r>
-              <a:t>•  Đo lường chính xác delta hiệu năng do RAG mang lại trên cùng mô hình LLM.</a:t>
-            </a:r>
-          </a:p>
-          <a:p>
-            <a:pPr>
-              <a:spcBef>
-                <a:spcPts val="350"/>
-              </a:spcBef>
-              <a:defRPr sz="1150">
+                <a:spcPts val="250"/>
+              </a:spcBef>
+              <a:defRPr sz="1000">
+                <a:solidFill>
+                  <a:srgbClr val="0F172A"/>
+                </a:solidFill>
+                <a:latin typeface="Calibri"/>
+              </a:defRPr>
+            </a:pPr>
+            <a:r>
+              <a:t>•  Thiết kế nghiên cứu thực nghiệm đối chứng có kiểm soát (Controlled Empirical Study).</a:t>
+            </a:r>
+          </a:p>
+          <a:p>
+            <a:pPr>
+              <a:spcBef>
+                <a:spcPts val="250"/>
+              </a:spcBef>
+              <a:defRPr sz="1000">
+                <a:solidFill>
+                  <a:srgbClr val="0F172A"/>
+                </a:solidFill>
+                <a:latin typeface="Calibri"/>
+              </a:defRPr>
+            </a:pPr>
+            <a:r>
+              <a:t>•  Đo lường khách quan delta hiệu năng do RAG mang lại trên cùng mô hình LLM.</a:t>
+            </a:r>
+          </a:p>
+          <a:p>
+            <a:pPr>
+              <a:spcBef>
+                <a:spcPts val="250"/>
+              </a:spcBef>
+              <a:defRPr sz="1000">
                 <a:solidFill>
                   <a:srgbClr val="0F172A"/>
                 </a:solidFill>
@@ -6592,33 +6592,49 @@
           <a:p>
             <a:pPr>
               <a:spcBef>
-                <a:spcPts val="350"/>
-              </a:spcBef>
-              <a:defRPr sz="1150">
-                <a:solidFill>
-                  <a:srgbClr val="0F172A"/>
-                </a:solidFill>
-                <a:latin typeface="Calibri"/>
-              </a:defRPr>
-            </a:pPr>
-            <a:r>
-              <a:t>•  Đóng băng giao thức v1.1: Thực thi xác định (Deterministic Execution under Frozen Environment &amp; Seeds).</a:t>
-            </a:r>
-          </a:p>
-          <a:p>
-            <a:pPr>
-              <a:spcBef>
-                <a:spcPts val="350"/>
-              </a:spcBef>
-              <a:defRPr sz="1150">
-                <a:solidFill>
-                  <a:srgbClr val="0F172A"/>
-                </a:solidFill>
-                <a:latin typeface="Calibri"/>
-              </a:defRPr>
-            </a:pPr>
-            <a:r>
-              <a:t>•  Tái lập ngoại tuyến chi phí 0 đồng với bộ offline_guard chặn các kết nối mạng ngoài ý muốn.</a:t>
+                <a:spcPts val="250"/>
+              </a:spcBef>
+              <a:defRPr sz="1000">
+                <a:solidFill>
+                  <a:srgbClr val="0F172A"/>
+                </a:solidFill>
+                <a:latin typeface="Calibri"/>
+              </a:defRPr>
+            </a:pPr>
+            <a:r>
+              <a:t>•  Phạm vi tính xác định (Determinism): Áp dụng cho tái tạo dataset, đánh giá ngoại tuyến và thứ tự tie-breaking.</a:t>
+            </a:r>
+          </a:p>
+          <a:p>
+            <a:pPr>
+              <a:spcBef>
+                <a:spcPts val="250"/>
+              </a:spcBef>
+              <a:defRPr sz="1000">
+                <a:solidFill>
+                  <a:srgbClr val="0F172A"/>
+                </a:solidFill>
+                <a:latin typeface="Calibri"/>
+              </a:defRPr>
+            </a:pPr>
+            <a:r>
+              <a:t>•  Biến thiên backend LLM: Phản hồi LLM có thể biến thiên (không gửi seed qua mạng), được quản lý bởi chính sách siêu dữ liệu D3 (timestamp-bound).</a:t>
+            </a:r>
+          </a:p>
+          <a:p>
+            <a:pPr>
+              <a:spcBef>
+                <a:spcPts val="250"/>
+              </a:spcBef>
+              <a:defRPr sz="1000">
+                <a:solidFill>
+                  <a:srgbClr val="0F172A"/>
+                </a:solidFill>
+                <a:latin typeface="Calibri"/>
+              </a:defRPr>
+            </a:pPr>
+            <a:r>
+              <a:t>•  Tái lập ngoại tuyến chi phí 0 đồng với bộ offline_guard can thiệp tầng socket.</a:t>
             </a:r>
           </a:p>
         </p:txBody>

</xml_diff>

<commit_message>
feat(slides): canonical consumer adapter, dynamic metric bundle injection, and 0.4219 McNemar alignment
</commit_message>
<xml_diff>
--- a/docs/presentation/slides.pptx
+++ b/docs/presentation/slides.pptx
@@ -528,7 +528,7 @@
           </a:p>
           <a:p>
             <a:r>
-              <a:t>Bằng chứng dự án: config/canonical_experiment_lock_v1.json (SHA-256: 961ba9b3e9e1b459a6694a5c8c76424d36c89d65bd4d88b14d0b0de7e4c017ac); reports/experiment_protocol_v1.md (SHA-256: d3bf3d31ad307100ac437a7daecc470bf12de9ada49f19de3d77592d5a21974c); scripts/reproduce_study.py.</a:t>
+              <a:t>Bằng chứng dự án: config/canonical_experiment_lock_v1.json (SHA-256: 961ba9b3e9e1b459a6694a5c8c76424d36c89d65bd4d88b14d0b0de7e4c017ac); reports/experiment_protocol_v1.md (SHA-256: d3bf3d31ad307100ac437a7daecc470bf12de9ada49f19de3d77592d5a21974c); artifacts/results/canonical_metric_bundle_v2.json (SHA-256: 442b5933858caafc9da3c06ee9398637213ed30d7a7db80195c0babb1195ef34); scripts/reproduce_study.py.</a:t>
             </a:r>
           </a:p>
         </p:txBody>
@@ -603,7 +603,7 @@
           </a:p>
           <a:p>
             <a:r>
-              <a:t>Nghiên cứu công khai các giới hạn khoa học: Dữ liệu hiện tại nằm trong phạm vi kịch bản có cấu trúc synthetic-paired-v1; bộ nhúng dense đơn tầng chưa kết nối được từ vựng kỹ thuật hệ thống (Event ID số); và mô hình đánh giá là gpt-5.6-luna. Để đảm bảo an toàn, mọi quy trình kiểm thử tái lập phải thực thi qua runner offline scripts/run_offline_tests.py nhằm đánh chặn các kết nối mạng ngẫu nhiên ở tầng socket Python.</a:t>
+              <a:t>Nghiên cứu công khai các giới hạn khoa học: Dữ liệu hiện tại nằm trong phạm vi kịch bản có cấu trúc synthetic-paired-v1; bộ nhúng dense đơn tầng chưa kết nối được từ vựng kỹ thuật hệ thống (Event ID số); và mô hình đánh giá là gpt-5.6-luna. Khoảng tin cậy delta chứa 0, kiểm định McNemar p = 0.4219 / 0.422 &gt; 0.05. Để đảm bảo an toàn, mọi quy trình kiểm thử tái lập phải thực thi qua runner offline scripts/run_offline_tests.py nhằm đánh chặn các kết nối mạng ngẫu nhiên ở tầng socket Python.</a:t>
             </a:r>
           </a:p>
           <a:p>
@@ -688,7 +688,7 @@
           </a:p>
           <a:p>
             <a:r>
-              <a:t>Bằng chứng dự án: config/canonical_experiment_lock_v1.json (SHA-256: 961ba9b3...); scripts/reproduce_study.py; scripts/run_offline_tests.py; tests/test_smoke_cases.py.</a:t>
+              <a:t>Bằng chứng dự án: config/canonical_experiment_lock_v1.json (SHA-256: 961ba9b3...); artifacts/results/canonical_metric_bundle_v2.json; scripts/reproduce_study.py; scripts/run_offline_tests.py; tests/test_smoke_cases.py.</a:t>
             </a:r>
           </a:p>
         </p:txBody>
@@ -763,7 +763,7 @@
           </a:p>
           <a:p>
             <a:r>
-              <a:t>Tóm lại, RAG2ATT&amp;CK đo lường thực nghiệm đối chứng vai trò của RAG trong bài toán ánh xạ log Windows sang ATT&amp;CK techniques. Các phát hiện hiện tại phản ánh phạm vi đo lường thực nghiệm và các giả thuyết đang chờ hoàn tất ma trận TEST. Chúng tôi nhấn mạnh tính trung thực khoa học: phân rã lỗi D2i theo các trục đo lường độc lập không giả định độc lập xác suất ngẫu nhiên, và quy trình tái lập sử dụng runner can thiệp socket tầng ứng dụng.</a:t>
+              <a:t>Tóm lại, RAG2ATT&amp;CK đo lường thực nghiệm đối chứng vai trò của RAG trong bài toán ánh xạ log Windows sang ATT&amp;CK techniques: No-RAG đạt 77.99% (560/718), RAG k=10 đạt 79.53% (571/718, Delta = +1.532 pp, McNemar p = 0.4219 / 0.422 &gt; 0.05). Ghi nhận 0 terminal provider failures trên 3,590 scorable records. Chúng tôi nhấn mạnh tính trung thực khoa học: phân rã lỗi D2i theo các trục đo lường độc lập không giả định độc lập xác suất ngẫu nhiên, và quy trình tái lập sử dụng runner can thiệp socket tầng ứng dụng.</a:t>
             </a:r>
           </a:p>
           <a:p>
@@ -773,7 +773,7 @@
           </a:p>
           <a:p>
             <a:r>
-              <a:t>Bằng chứng dự án: PR #26 (https://github.com/habachcp6/RAG2ATTCK/pull/26); docs/sanitized_evidence_manifest.json; reports/evidence/reproducibility_package_manifest.md.</a:t>
+              <a:t>Bằng chứng dự án: PR #26 (https://github.com/habachcp6/RAG2ATTCK/pull/26); docs/sanitized_evidence_manifest.json; artifacts/results/canonical_metric_bundle_v2.json; reports/evidence/reproducibility_package_manifest.md.</a:t>
             </a:r>
           </a:p>
         </p:txBody>
@@ -1198,7 +1198,7 @@
           </a:p>
           <a:p>
             <a:r>
-              <a:t>Chẩn đoán độc lập khâu tìm kiếm (RQ2) trên 756 positive views cho thấy Hit@10 chỉ đạt 45.11%, nghĩa là trong 54.89% trường hợp, kỹ thuật đúng hoàn toàn vắng bóng trong Top-10 gửi cho LLM. Điển hình là kỹ thuật T1136.001 với 0/99 lần trúng Top-10 do khoảng cách ngữ nghĩa giữa Event ID 4720 và STIX description. Chúng tôi đặt ra giả thuyết Context Scaling &amp; Dilution (k=1,3,5,10): tăng k cải thiện độ phủ nhưng tăng nguy cơ nhiễu distractor; giả thuyết này đang được kiểm chứng thực nghiệm đối chứng end-to-end.</a:t>
+              <a:t>Chẩn đoán độc lập khâu tìm kiếm (RQ2) trên tập scorable N=718 cho thấy Hit@10 đạt 44.71% (321/718), nghĩa là trong 55.29% trường hợp (397/718), kỹ thuật đúng hoàn toàn vắng bóng trong Top-10 gửi cho LLM. Điển hình là kỹ thuật T1136.001 với 0/95 lần trúng Top-10 do khoảng cách ngữ nghĩa giữa Event ID 4720 và STIX description. Chúng tôi ghi nhận giả thuyết Context Scaling &amp; Dilution (k=1,3,5,10): tăng k cải thiện độ phủ nhưng tăng nguy cơ nhiễu distractor; giả thuyết này đã được kiểm chứng thực nghiệm đối chứng end-to-end trên ma trận TEST.</a:t>
             </a:r>
           </a:p>
           <a:p>
@@ -1278,7 +1278,7 @@
           </a:p>
           <a:p>
             <a:r>
-              <a:t>So sánh đối ứng trên 296 cặp anchor chuẩn chỉ ra rằng biểu diễn Single-event đạt thứ hạng tìm kiếm tốt hơn Contextual-event (65 cặp vs 23 cặp), và hơn 70% có thứ hạng tương đương (phần lớn do cả hai cùng trượt Top-10). Điều này cho thấy việc đưa thêm log nền gây hiện tượng benign drift. Chúng tôi thiết lập schema so sánh đối chứng scaffold giữa Zero-Shot No-RAG, Zero-Shot RAG và các prompt scaffold, hiện đang được gắn nhãn [PENDING EXECUTION] chờ toàn bộ ma trận TEST hoàn tất để đưa ra kết luận khoa học chính thức.</a:t>
+              <a:t>So sánh đối ứng trên 296 cặp anchor chuẩn chỉ ra rằng biểu diễn Single-event đạt thứ hạng tìm kiếm tốt hơn Contextual-event (65 cặp vs 23 cặp), và hơn 70% có thứ hạng tương đương (phần lớn do cả hai cùng trượt Top-10). Điều này cho thấy việc đưa thêm log nền gây hiện tượng benign drift. Chúng tôi thiết lập schema so sánh đối chứng scaffold giữa Zero-Shot No-RAG, Zero-Shot RAG và các prompt scaffold. Ở điều kiện RAG k=10 trên 278 cặp đầy đủ nhãn GT, cả Single và Contextual view đều đạt 83.81% (paired delta = 0.0 pp, McNemar p = 1.0), nghiêm cấm suy diễn quan hệ nhân quả thuần túy khi hình thức biểu diễn thay đổi.</a:t>
             </a:r>
           </a:p>
           <a:p>
@@ -1358,12 +1358,27 @@
           </a:p>
           <a:p>
             <a:r>
-              <a:t>Khung đánh giá RQ1 &amp; RQ2 được xây dựng trên định đề D2i (Independent Measurement Axes). Chúng tôi bác bỏ hoàn toàn công thức cộng xác suất rời rạc sai lầm, bởi retrieval failure và downstream generation failure không hề xung khắc nhau mà có phần giao thoa rõ ràng; chúng tôi cũng không giả định độc lập xác suất ngẫu nhiên. Các chỉ số có điều kiện P(Correct | GT in Top-k) và P(Correct | GT NOT in Top-k) cho phép định lượng xem LLM có bị đánh lừa bởi distractor hay có khả năng tự sửa sai. Toàn bộ ma trận chính thức 6,400 bản ghi đang chạy; tính đúng đắn toán học của Evaluator đã được chứng minh qua 5 test fixtures.</a:t>
-            </a:r>
-          </a:p>
-          <a:p>
-            <a:r>
-              <a:t>Bằng chứng dự án: reports/experiment_protocol_v1.md (D2e, D2f, D2h, D2i; SHA-256: d3bf3d31...); tests/test_experiment_evaluation.py (94 tests pass).</a:t>
+              <a:t>Khung đánh giá RQ1 &amp; RQ2 được xây dựng trên định đề D2i (Independent Measurement Axes). Chúng tôi bác bỏ hoàn toàn công thức cộng xác suất rời rạc sai lầm, bởi retrieval failure và downstream generation failure không hề xung khắc nhau mà có phần giao thoa rõ ràng; chúng tôi cũng không giả định độc lập xác suất ngẫu nhiên.</a:t>
+            </a:r>
+          </a:p>
+          <a:p>
+            <a:r>
+              <a:t>Bảng đối chứng RQ1 ghi nhận RAG k=10 đạt độ chính xác quan sát được cao nhất là 79.53% (571/718) so với No-RAG 77.99% (560/718), tức Delta = +1.532 pp (+1.96% relative gain; 95% CI [-2.355, +5.300] pp chứa 0; kiểm định McNemar chính xác p = 0.4219 / hiển thị 0.422 &gt; 0.05). Do đó, nghiên cứu khẳng định đây là độ chính xác quan sát được cao nhất trong thử nghiệm kèm độ bất định, tuyệt đối không tuyên bố chiến thắng có ý nghĩa thống kê hay lợi ích vượt trội trong production.</a:t>
+            </a:r>
+          </a:p>
+          <a:p>
+            <a:r>
+              <a:t>Ranh giới lỗi phân định độc lập: 1 physical retry thành công sau sự cố mạng API_FAILURE; ghi nhận 0 terminal provider failure trên toàn bộ 3,590 scorable records (13 incomplete records ghi nhận trên toàn campaign 6,400 requests đều thuộc nhóm unmapped/ambiguous).</a:t>
+            </a:r>
+          </a:p>
+          <a:p>
+            <a:r>
+              <a:t>Về các thước đo có điều kiện tại k=10: P(Correct | GT in Top-k) = 91.28% (293/321), trong khi P(Correct | GT NOT in Top-k) = 70.03% (278/397); tỷ lệ này không cho phép suy diễn mô hình tự sửa sai nội tại.</a:t>
+            </a:r>
+          </a:p>
+          <a:p>
+            <a:r>
+              <a:t>Bằng chứng dự án: reports/experiment_protocol_v1.md (D2e, D2f, D2h, D2i; SHA-256: d3bf3d31ad307100ac437a7daecc470bf12de9ada49f19de3d77592d5a21974c); artifacts/results/canonical_metric_bundle_v2.json; tests/test_experiment_evaluation.py.</a:t>
             </a:r>
           </a:p>
         </p:txBody>
@@ -1438,32 +1453,32 @@
           </a:p>
           <a:p>
             <a:r>
-              <a:t>Trong phân tích RQ3, chúng tôi làm rõ các khái niệm chi phí và dữ liệu:</a:t>
-            </a:r>
-          </a:p>
-          <a:p>
-            <a:r>
-              <a:t>1. Dữ liệu DEV là dữ liệu tổng hợp (synthetic-paired-v1 DEV split, 4 views x 5 nhánh). Việc gửi request lên OpenAI không biến log tổng hợp thành dữ liệu thực địa in-the-wild.</a:t>
-            </a:r>
-          </a:p>
-          <a:p>
-            <a:r>
-              <a:t>2. Toàn bộ nghiên cứu tính trên mẫu số 1,280 queries / điều kiện (tổng 6,400 logical requests, 6,401 physical attempts bao gồm 1 retry lỗi API).</a:t>
-            </a:r>
-          </a:p>
-          <a:p>
-            <a:r>
-              <a:t>3. Hạch toán tài chính chính xác: trần ngân sách đóng băng cứng $19.99 USD (hard_budget_limit_usd), chi phí quyết toán thực tế 5 điều kiện chính thức là $6.58 settled spend ($6.57575890 USD), cộng giữ chỗ thận trọng pilot $0.05264010 USD tổng chi phí cam kết là $6.63 committed spend ($6.62839900 USD), ngân sách khả dụng còn lại là $13.36 net remaining ($13.36160100 USD; 0 holds, 0 breach).</a:t>
-            </a:r>
-          </a:p>
-          <a:p>
-            <a:r>
-              <a:t>4. Phân biệt rõ khoản giữ chỗ thận trọng tạm thời ($0.05264010 USD prior_pilot_provisional_hold_usd), dự báo chuẩn tắc tập TEST ($8.20 – $8.99 USD cho 6,400 requests), và trần ngân sách đóng băng cứng $19.99 USD (hard_budget_limit_usd).</a:t>
-            </a:r>
-          </a:p>
-          <a:p>
-            <a:r>
-              <a:t>Bằng chứng dự án: config/experiment_config.json (hard_budget_limit_usd: 19.99); reports/evidence/dev_cost_pilot_20261001/summary.json (SHA-256: f8dfe994...); tests/test_monetary_guard.py.</a:t>
+              <a:t>Trong phân tích RQ3, chúng tôi làm rõ các khái niệm chi phí, dữ liệu và kiểm soát ngân sách:</a:t>
+            </a:r>
+          </a:p>
+          <a:p>
+            <a:r>
+              <a:t>1. Dữ liệu DEV là dữ liệu tổng hợp (synthetic-paired-v1 DEV split). Việc gửi request lên OpenAI không biến log tổng hợp thành dữ liệu thực địa in-the-wild.</a:t>
+            </a:r>
+          </a:p>
+          <a:p>
+            <a:r>
+              <a:t>2. Toàn bộ nghiên cứu tính trên mẫu số N=1,280 queries / điều kiện (tổng 6,400 logical requests, 6,401 physical attempts bao gồm 1 physical retry thành công do lỗi mạng API_FAILURE với 1,540 cached tokens; ghi nhận 0 terminal provider failure trên 3,590 scorable records).</a:t>
+            </a:r>
+          </a:p>
+          <a:p>
+            <a:r>
+              <a:t>3. Hạch toán tài chính chính xác: trần ngân sách đóng băng cứng $19.99 USD (hard_budget_limit_usd = $19.99000000). Chi phí quyết toán thực tế 5 điều kiện chính thức là $6.58 settled spend ($6.57575890 USD).</a:t>
+            </a:r>
+          </a:p>
+          <a:p>
+            <a:r>
+              <a:t>4. Phân biệt rạch ròi: Khoản giữ chỗ thận trọng pilot $0.05264010 USD (prior_pilot_provisional_hold_usd) được phân tách minh bạch khỏi chi phí quyết toán thực tế $6.57575890 USD. Tổng chi phí cam kết là $6.63 committed spend ($6.62839900 USD), ngân sách khả dụng còn lại là $13.36 net remaining ($13.36160100 USD; 0 active holds, 0 breach).</a:t>
+            </a:r>
+          </a:p>
+          <a:p>
+            <a:r>
+              <a:t>Bằng chứng dự án: config/experiment_config.json (hard_budget_limit_usd: 19.99); artifacts/results/canonical_metric_bundle_v2.json; tests/test_monetary_guard.py.</a:t>
             </a:r>
           </a:p>
         </p:txBody>
@@ -4650,7 +4665,7 @@
               </a:defRPr>
             </a:pPr>
             <a:r>
-              <a:t>[FIXTURE — PRE-CANONICAL RENDER TEST]</a:t>
+              <a:t>[CANONICAL CANDIDATE — PENDING ROOT FINAL REVIEW]</a:t>
             </a:r>
           </a:p>
         </p:txBody>
@@ -4846,7 +4861,7 @@
               </a:defRPr>
             </a:pPr>
             <a:r>
-              <a:t>Đánh giá khách quan các hạn chế kỹ thuật và phạm vi khoa học  |  [FIXTURE — PRE-CANONICAL RENDER TEST]</a:t>
+              <a:t>Đánh giá khách quan các hạn chế kỹ thuật và phạm vi khoa học  |  [CANONICAL CANDIDATE — PENDING ROOT FINAL REVIEW]</a:t>
             </a:r>
           </a:p>
         </p:txBody>
@@ -5413,7 +5428,7 @@
               </a:defRPr>
             </a:pPr>
             <a:r>
-              <a:t>Toàn bộ nghiên cứu có thể kiểm chứng ngoại tuyến với chi phí 0 đồng  |  [FIXTURE — PRE-CANONICAL RENDER TEST]</a:t>
+              <a:t>Toàn bộ nghiên cứu có thể kiểm chứng ngoại tuyến với chi phí 0 đồng  |  [CANONICAL CANDIDATE — PENDING ROOT FINAL REVIEW]</a:t>
             </a:r>
           </a:p>
         </p:txBody>
@@ -5939,7 +5954,7 @@
               </a:defRPr>
             </a:pPr>
             <a:r>
-              <a:t>•  RAG cung cấp tri thức nền tảng quan trọng; giả thuyết RQ2 về mức độ ảnh hưởng nhân quả của retrieval đang được kiểm chứng đối chứng trên ma trận TEST.</a:t>
+              <a:t>•  RAG cung cấp tri thức nền tảng quan trọng; kết quả đối chứng ghi nhận No-RAG đạt 77.99% (560/718) vs RAG k=10 quan sát thấy 79.53% (571/718, Delta = +1.532 pp, 95% CI [-2.355, +5.300] pp chứa 0, McNemar p = 0.4219 / 0.422 &gt; 0.05).</a:t>
             </a:r>
           </a:p>
           <a:p>
@@ -5955,7 +5970,7 @@
               </a:defRPr>
             </a:pPr>
             <a:r>
-              <a:t>•  Phân rã lỗi D2i theo 3 trục đo lường độc lập (retrieval miss, downstream generation failure, joint overlap), ghi nhận phần giao thoa khác 0, không giả định độc lập xác suất ngẫu nhiên.</a:t>
+              <a:t>•  Phân rã lỗi D2i theo 3 trục đo lường độc lập (retrieval miss, downstream generation failure, joint overlap), ghi nhận phần giao thoa khác 0; ghi nhận 0 terminal provider failures trên 3,590 scorable records.</a:t>
             </a:r>
           </a:p>
           <a:p>
@@ -6035,7 +6050,7 @@
               </a:defRPr>
             </a:pPr>
             <a:r>
-              <a:t>[FIXTURE — PRE-CANONICAL RENDER TEST]</a:t>
+              <a:t>[CANONICAL CANDIDATE — PENDING ROOT FINAL REVIEW]</a:t>
             </a:r>
           </a:p>
         </p:txBody>
@@ -6231,7 +6246,7 @@
               </a:defRPr>
             </a:pPr>
             <a:r>
-              <a:t>Khoảng cách giữa nhật ký cấp thấp (Telemetry) và ma trận kỹ thuật ATT&amp;CK  |  [FIXTURE — PRE-CANONICAL RENDER TEST]</a:t>
+              <a:t>Khoảng cách giữa nhật ký cấp thấp (Telemetry) và ma trận kỹ thuật ATT&amp;CK  |  [CANONICAL CANDIDATE — PENDING ROOT FINAL REVIEW]</a:t>
             </a:r>
           </a:p>
         </p:txBody>
@@ -6862,7 +6877,7 @@
               </a:defRPr>
             </a:pPr>
             <a:r>
-              <a:t>So sánh đối đầu giữa Baseline (No-RAG) và Experimental (RAG)  |  [FIXTURE — PRE-CANONICAL RENDER TEST]</a:t>
+              <a:t>So sánh đối đầu giữa Baseline (No-RAG) và Experimental (RAG)  |  [CANONICAL CANDIDATE — PENDING ROOT FINAL REVIEW]</a:t>
             </a:r>
           </a:p>
         </p:txBody>
@@ -7493,7 +7508,7 @@
               </a:defRPr>
             </a:pPr>
             <a:r>
-              <a:t>Bộ dữ liệu chuẩn đóng băng Stage B (670 cặp kịch bản, 1,340 views)  |  [FIXTURE — PRE-CANONICAL RENDER TEST]</a:t>
+              <a:t>Bộ dữ liệu chuẩn đóng băng Stage B (670 cặp kịch bản, 1,340 views)  |  [CANONICAL CANDIDATE — PENDING ROOT FINAL REVIEW]</a:t>
             </a:r>
           </a:p>
         </p:txBody>
@@ -8059,7 +8074,7 @@
               </a:defRPr>
             </a:pPr>
             <a:r>
-              <a:t>Tách bạch rõ ràng 7 quyết định giao thức khoa học D1-D7 đóng băng  |  [FIXTURE — PRE-CANONICAL RENDER TEST]</a:t>
+              <a:t>Tách bạch rõ ràng 7 quyết định giao thức khoa học D1-D7 đóng băng  |  [CANONICAL CANDIDATE — PENDING ROOT FINAL REVIEW]</a:t>
             </a:r>
           </a:p>
         </p:txBody>
@@ -8721,7 +8736,7 @@
               </a:defRPr>
             </a:pPr>
             <a:r>
-              <a:t>Đánh giá độc lập bộ tìm kiếm trên 756 positive views của benchmark  |  [FIXTURE — PRE-CANONICAL RENDER TEST]</a:t>
+              <a:t>Đánh giá độc lập bộ tìm kiếm trên 718 positive scorable views của benchmark  |  [CANONICAL CANDIDATE — PENDING ROOT FINAL REVIEW]</a:t>
             </a:r>
           </a:p>
         </p:txBody>
@@ -8802,7 +8817,7 @@
               </a:defRPr>
             </a:pPr>
             <a:r>
-              <a:t>Số Liệu Chẩn Đoán Cốt Lõi (T20 Overall)</a:t>
+              <a:t>Số Liệu Chẩn Đoán Cốt Lõi (TEST N=718)</a:t>
             </a:r>
           </a:p>
           <a:p>
@@ -8818,7 +8833,7 @@
               </a:defRPr>
             </a:pPr>
             <a:r>
-              <a:t>•  Số mẫu dương tính đánh giá: 756 / 1,340 views.</a:t>
+              <a:t>•  Số mẫu dương tính đánh giá: 718 / 1,280 views.</a:t>
             </a:r>
           </a:p>
           <a:p>
@@ -8850,7 +8865,7 @@
               </a:defRPr>
             </a:pPr>
             <a:r>
-              <a:t>  • Hit@1:   4.23% (32 / 756)</a:t>
+              <a:t>  • Hit@1:   3.76% (27 / 718)</a:t>
             </a:r>
           </a:p>
           <a:p>
@@ -8866,7 +8881,7 @@
               </a:defRPr>
             </a:pPr>
             <a:r>
-              <a:t>  • Hit@3:  16.80% (127 / 756)</a:t>
+              <a:t>  • Hit@3:  16.43% (118 / 718)</a:t>
             </a:r>
           </a:p>
           <a:p>
@@ -8882,7 +8897,7 @@
               </a:defRPr>
             </a:pPr>
             <a:r>
-              <a:t>  • Hit@5:  24.21% (183 / 756)</a:t>
+              <a:t>  • Hit@5:  24.09% (173 / 718)</a:t>
             </a:r>
           </a:p>
           <a:p>
@@ -8898,7 +8913,7 @@
               </a:defRPr>
             </a:pPr>
             <a:r>
-              <a:t>  • Hit@10: 45.11% (341 / 756)</a:t>
+              <a:t>  • Hit@10: 44.71% (321 / 718)</a:t>
             </a:r>
           </a:p>
           <a:p>
@@ -8914,7 +8929,7 @@
               </a:defRPr>
             </a:pPr>
             <a:r>
-              <a:t>•  Tỷ lệ vắng mặt trong Top-10 (Retrieval Failure): 54.89% (415 / 756).</a:t>
+              <a:t>•  Tỷ lệ vắng mặt trong Top-10 (Retrieval Miss): 55.29% (397 / 718).</a:t>
             </a:r>
           </a:p>
           <a:p>
@@ -8930,7 +8945,7 @@
               </a:defRPr>
             </a:pPr>
             <a:r>
-              <a:t>•  Macro Recall@10: 43.14%  |  Mean Rank khi trúng: 5.21.</a:t>
+              <a:t>•  Macro Recall@10: 42.80%  |  Bối cảnh lịch sử T20 pilot: Hit@10=45.11%.</a:t>
             </a:r>
           </a:p>
           <a:p>
@@ -8946,7 +8961,7 @@
               </a:defRPr>
             </a:pPr>
             <a:r>
-              <a:t>•  Phát hiện: Trong hơn 54% trường hợp, kỹ thuật đúng hoàn toàn vắng bóng trong Top-10 gửi cho LLM!</a:t>
+              <a:t>•  Phát hiện: Trong hơn 55% trường hợp (397/718), kỹ thuật đúng hoàn toàn vắng bóng trong Top-10 gửi cho LLM!</a:t>
             </a:r>
           </a:p>
         </p:txBody>
@@ -9067,7 +9082,7 @@
               </a:defRPr>
             </a:pPr>
             <a:r>
-              <a:t>•  Khoảng cách ngữ nghĩa tại T1136.001 (Local Account): 0/99 lượt trúng Top-10 do log Event ID 4720 lệch từ vựng so với STIX persistence.</a:t>
+              <a:t>•  Khoảng cách ngữ nghĩa tại T1136.001 (Local Account): 0/95 lượt trúng Top-10 do log Event ID 4720 lệch từ vựng so với STIX persistence.</a:t>
             </a:r>
           </a:p>
           <a:p>
@@ -9279,7 +9294,7 @@
               </a:defRPr>
             </a:pPr>
             <a:r>
-              <a:t>So sánh thực nghiệm Single vs Contextual trên 670 cặp kịch bản đối ứng  |  [FIXTURE — PRE-CANONICAL RENDER TEST]</a:t>
+              <a:t>So sánh thực nghiệm Single vs Contextual trên 670 cặp kịch bản đối ứng  |  [CANONICAL CANDIDATE — PENDING ROOT FINAL REVIEW]</a:t>
             </a:r>
           </a:p>
         </p:txBody>
@@ -9601,7 +9616,7 @@
               </a:defRPr>
             </a:pPr>
             <a:r>
-              <a:t>Hiện Tượng Quan Sát &amp; Schema So Sánh [FIXTURE — PRE-CANONICAL RENDER TEST]</a:t>
+              <a:t>Hiện Tượng Quan Sát &amp; Schema So Sánh [CANONICAL CANDIDATE — PENDING ROOT FINAL REVIEW]</a:t>
             </a:r>
           </a:p>
           <a:p>
@@ -9665,7 +9680,7 @@
               </a:defRPr>
             </a:pPr>
             <a:r>
-              <a:t>•  Schema So Sánh Đối Chứng Scaffold [FIXTURE — PRE-CANONICAL RENDER TEST]:</a:t>
+              <a:t>•  Schema So Sánh Đối Chứng Scaffold [CANONICAL CANDIDATE — PENDING ROOT FINAL REVIEW]:</a:t>
             </a:r>
           </a:p>
           <a:p>
@@ -9697,6 +9712,22 @@
               </a:defRPr>
             </a:pPr>
             <a:r>
+              <a:t>  • Tại RAG k=10: Single và Contextual view đều đạt 83.81% (Paired Delta = 0.0 pp, McNemar p = 1.0).</a:t>
+            </a:r>
+          </a:p>
+          <a:p>
+            <a:pPr>
+              <a:spcBef>
+                <a:spcPts val="300"/>
+              </a:spcBef>
+              <a:defRPr sz="1150">
+                <a:solidFill>
+                  <a:srgbClr val="0F172A"/>
+                </a:solidFill>
+                <a:latin typeface="Calibri"/>
+              </a:defRPr>
+            </a:pPr>
+            <a:r>
               <a:t>  • Giả thuyết: Khối tri thức RAG bổ trợ cần đi kèm tiền lọc sự kiện nghi vấn thay vì nhúng thô.</a:t>
             </a:r>
           </a:p>
@@ -9713,7 +9744,7 @@
               </a:defRPr>
             </a:pPr>
             <a:r>
-              <a:t>  • Trạng thái: Thử nghiệm sơ bộ trên fixture đối chứng; kết luận chính thức cần ma trận TEST đầy đủ.</a:t>
+              <a:t>  • Trạng thái: Kiểm chứng đối chứng trên ma trận TEST.</a:t>
             </a:r>
           </a:p>
           <a:p>
@@ -9925,7 +9956,7 @@
               </a:defRPr>
             </a:pPr>
             <a:r>
-              <a:t>Bóc tách độc lập giữa năng lực truy xuất và phân loại theo định đề D2i (Independent Axes)  |  [FIXTURE — PRE-CANONICAL RENDER TEST]</a:t>
+              <a:t>Bóc tách độc lập giữa năng lực truy xuất và phân loại theo định đề D2i (Independent Axes)  |  [CANONICAL CANDIDATE — PENDING ROOT FINAL REVIEW]</a:t>
             </a:r>
           </a:p>
         </p:txBody>
@@ -10231,7 +10262,7 @@
               </a:defRPr>
             </a:pPr>
             <a:r>
-              <a:t>•  So sánh đối chứng RAG k=10 vs No-RAG: Chênh lệch cặp 95% CI [-2.355, +5.300] pp (chứa 0), McNemar p = 0.4223 &gt; 0.05.</a:t>
+              <a:t>•  So sánh đối chứng RAG k=10 vs No-RAG: Delta +1.532 pp (79.53% [571/718] vs 77.99% [560/718]), 95% CI [-2.355, +5.300] pp (chứa 0), McNemar p = 0.4219 (hiển thị 0.422).</a:t>
             </a:r>
           </a:p>
           <a:p>
@@ -10328,71 +10359,71 @@
               </a:defRPr>
             </a:pPr>
             <a:r>
-              <a:t>[FIXTURE — PRE-CANONICAL RENDER TEST] Trạng Thái Thực Nghiệm RQ1 &amp; RQ2</a:t>
-            </a:r>
-          </a:p>
-          <a:p>
-            <a:pPr>
-              <a:spcBef>
-                <a:spcPts val="350"/>
-              </a:spcBef>
-              <a:defRPr sz="1150">
-                <a:solidFill>
-                  <a:srgbClr val="0F172A"/>
-                </a:solidFill>
-                <a:latin typeface="Calibri"/>
-              </a:defRPr>
-            </a:pPr>
-            <a:r>
-              <a:t>•  Ma trận TEST chuẩn: N=718 scorable views x 5 nhánh (No-RAG, k=1, 3, 5, 10).</a:t>
-            </a:r>
-          </a:p>
-          <a:p>
-            <a:pPr>
-              <a:spcBef>
-                <a:spcPts val="350"/>
-              </a:spcBef>
-              <a:defRPr sz="1150">
-                <a:solidFill>
-                  <a:srgbClr val="0F172A"/>
-                </a:solidFill>
-                <a:latin typeface="Calibri"/>
-              </a:defRPr>
-            </a:pPr>
-            <a:r>
-              <a:t>•  Nguyên tắc Fail-Closed: Evaluator ghi nhận đầy đủ 13 INCOMPLETE records trên 6,400 requests.</a:t>
-            </a:r>
-          </a:p>
-          <a:p>
-            <a:pPr>
-              <a:spcBef>
-                <a:spcPts val="350"/>
-              </a:spcBef>
-              <a:defRPr sz="1150">
-                <a:solidFill>
-                  <a:srgbClr val="0F172A"/>
-                </a:solidFill>
-                <a:latin typeface="Calibri"/>
-              </a:defRPr>
-            </a:pPr>
-            <a:r>
-              <a:t>•  Kiểm định toán học Evaluator: Đã xác thực ngoại tuyến qua các bộ test fixtures.</a:t>
-            </a:r>
-          </a:p>
-          <a:p>
-            <a:pPr>
-              <a:spcBef>
-                <a:spcPts val="350"/>
-              </a:spcBef>
-              <a:defRPr sz="1150">
-                <a:solidFill>
-                  <a:srgbClr val="0F172A"/>
-                </a:solidFill>
-                <a:latin typeface="Calibri"/>
-              </a:defRPr>
-            </a:pPr>
-            <a:r>
-              <a:t>•  Đầu ra chuẩn: 6 metric JSON artifacts kèm _fixture_metadata.json.</a:t>
+              <a:t>[CANONICAL CANDIDATE — PENDING ROOT FINAL REVIEW] Trạng Thái Thực Nghiệm RQ1 &amp; RQ2</a:t>
+            </a:r>
+          </a:p>
+          <a:p>
+            <a:pPr>
+              <a:spcBef>
+                <a:spcPts val="250"/>
+              </a:spcBef>
+              <a:defRPr sz="1050">
+                <a:solidFill>
+                  <a:srgbClr val="0F172A"/>
+                </a:solidFill>
+                <a:latin typeface="Calibri"/>
+              </a:defRPr>
+            </a:pPr>
+            <a:r>
+              <a:t>•  Ma trận TEST chuẩn: N=718 scorable views x 5 điều kiện (No-RAG, k=1, 3, 5, 10; tổng 3,590 scorable records).</a:t>
+            </a:r>
+          </a:p>
+          <a:p>
+            <a:pPr>
+              <a:spcBef>
+                <a:spcPts val="250"/>
+              </a:spcBef>
+              <a:defRPr sz="1050">
+                <a:solidFill>
+                  <a:srgbClr val="0F172A"/>
+                </a:solidFill>
+                <a:latin typeface="Calibri"/>
+              </a:defRPr>
+            </a:pPr>
+            <a:r>
+              <a:t>•  Ranh giới lỗi phân định: 1 physical API_FAILURE retry thành công; 0 terminal provider failure trên 3,590 scorable records.</a:t>
+            </a:r>
+          </a:p>
+          <a:p>
+            <a:pPr>
+              <a:spcBef>
+                <a:spcPts val="250"/>
+              </a:spcBef>
+              <a:defRPr sz="1050">
+                <a:solidFill>
+                  <a:srgbClr val="0F172A"/>
+                </a:solidFill>
+                <a:latin typeface="Calibri"/>
+              </a:defRPr>
+            </a:pPr>
+            <a:r>
+              <a:t>•  Tổng thể campaign: 13 terminal incomplete trên 6,400 requests (đều thuộc các view loại trừ/unmapped).</a:t>
+            </a:r>
+          </a:p>
+          <a:p>
+            <a:pPr>
+              <a:spcBef>
+                <a:spcPts val="250"/>
+              </a:spcBef>
+              <a:defRPr sz="1050">
+                <a:solidFill>
+                  <a:srgbClr val="0F172A"/>
+                </a:solidFill>
+                <a:latin typeface="Calibri"/>
+              </a:defRPr>
+            </a:pPr>
+            <a:r>
+              <a:t>•  Khóa toàn vẹn: Bundle v2 SHA-256 đã thẩm định; 0 invalid ID cú pháp; tính toán ngoại tuyến xác thực.</a:t>
             </a:r>
           </a:p>
         </p:txBody>
@@ -10588,7 +10619,7 @@
               </a:defRPr>
             </a:pPr>
             <a:r>
-              <a:t>Dữ liệu DEV pilot (synthetic split), hạch toán token ước tính và kiểm soát ngân sách  |  [FIXTURE — PRE-CANONICAL RENDER TEST]</a:t>
+              <a:t>Hạch toán tài chính toàn nghiên cứu, đánh đổi token-chi phí và kiểm soát ngân sách  |  [CANONICAL CANDIDATE — PENDING ROOT FINAL REVIEW]</a:t>
             </a:r>
           </a:p>
         </p:txBody>
@@ -10669,13 +10700,13 @@
               </a:defRPr>
             </a:pPr>
             <a:r>
-              <a:t>DEV Cost Pilot &amp; Hạch Toán Tài Chính Toàn Nghiên Cứu</a:t>
-            </a:r>
-          </a:p>
-          <a:p>
-            <a:pPr>
-              <a:spcBef>
-                <a:spcPts val="200"/>
+              <a:t>Hạch Toán Tài Chính Toàn Nghiên Cứu (RQ3)</a:t>
+            </a:r>
+          </a:p>
+          <a:p>
+            <a:pPr>
+              <a:spcBef>
+                <a:spcPts val="180"/>
               </a:spcBef>
               <a:defRPr sz="1050">
                 <a:solidFill>
@@ -10685,13 +10716,13 @@
               </a:defRPr>
             </a:pPr>
             <a:r>
-              <a:t>•  Bản chất dữ liệu: DEV cohort là dữ liệu tổng hợp (synthetic-paired-v1 DEV split, 4 views x 5 điều kiện). Gửi request thực không biến log tổng hợp thành in-the-wild telemetry.</a:t>
-            </a:r>
-          </a:p>
-          <a:p>
-            <a:pPr>
-              <a:spcBef>
-                <a:spcPts val="200"/>
+              <a:t>•  Bản chất dữ liệu: DEV cohort là dữ liệu tổng hợp (synthetic split). Gửi request thực không biến log tổng hợp thành in-the-wild telemetry.</a:t>
+            </a:r>
+          </a:p>
+          <a:p>
+            <a:pPr>
+              <a:spcBef>
+                <a:spcPts val="180"/>
               </a:spcBef>
               <a:defRPr sz="1050">
                 <a:solidFill>
@@ -10701,13 +10732,13 @@
               </a:defRPr>
             </a:pPr>
             <a:r>
-              <a:t>•  Quy mô khảo sát: N=1,280 queries / điều kiện; 6,400 logical requests; 6,401 physical attempts (1 retry do lỗi API).</a:t>
-            </a:r>
-          </a:p>
-          <a:p>
-            <a:pPr>
-              <a:spcBef>
-                <a:spcPts val="200"/>
+              <a:t>•  Quy mô khảo sát: N=1,280 queries/điều kiện; 6,400 logical requests; 6,401 physical attempts (1 physical API_FAILURE retry thành công với 1,540 cached tokens; 0 terminal provider failure trên 3,590 scorable records).</a:t>
+            </a:r>
+          </a:p>
+          <a:p>
+            <a:pPr>
+              <a:spcBef>
+                <a:spcPts val="180"/>
               </a:spcBef>
               <a:defRPr sz="1050">
                 <a:solidFill>
@@ -10717,13 +10748,13 @@
               </a:defRPr>
             </a:pPr>
             <a:r>
-              <a:t>•  Chi phí hạch toán ước tính (Accounted Cost) &amp; Bảng giá đóng băng:</a:t>
-            </a:r>
-          </a:p>
-          <a:p>
-            <a:pPr>
-              <a:spcBef>
-                <a:spcPts val="200"/>
+              <a:t>•  Ngoại lệ &amp; Trần tokens: 13 requests đạt trần context/output tokens (8,192 max tokens) đều thuộc nhóm unmapped/ambiguous.</a:t>
+            </a:r>
+          </a:p>
+          <a:p>
+            <a:pPr>
+              <a:spcBef>
+                <a:spcPts val="180"/>
               </a:spcBef>
               <a:defRPr sz="1050">
                 <a:solidFill>
@@ -10733,13 +10764,13 @@
               </a:defRPr>
             </a:pPr>
             <a:r>
-              <a:t>  • Pilot lịch sử 20 requests: $0.0242 USD theo đơn giá; DEV baseline.</a:t>
-            </a:r>
-          </a:p>
-          <a:p>
-            <a:pPr>
-              <a:spcBef>
-                <a:spcPts val="200"/>
+              <a:t>•  Hạch toán tài chính toàn thể nghiên cứu (6,400 Requests):</a:t>
+            </a:r>
+          </a:p>
+          <a:p>
+            <a:pPr>
+              <a:spcBef>
+                <a:spcPts val="180"/>
               </a:spcBef>
               <a:defRPr sz="1050">
                 <a:solidFill>
@@ -10749,13 +10780,13 @@
               </a:defRPr>
             </a:pPr>
             <a:r>
-              <a:t>  • no_rag (k=0): 643 in / 224 out (~$0.000365 / query)</a:t>
-            </a:r>
-          </a:p>
-          <a:p>
-            <a:pPr>
-              <a:spcBef>
-                <a:spcPts val="200"/>
+              <a:t>  • Trần ngân sách đóng băng cứng (Hard budget cap): $19.99 USD ($19.99000000).</a:t>
+            </a:r>
+          </a:p>
+          <a:p>
+            <a:pPr>
+              <a:spcBef>
+                <a:spcPts val="180"/>
               </a:spcBef>
               <a:defRPr sz="1050">
                 <a:solidFill>
@@ -10765,13 +10796,13 @@
               </a:defRPr>
             </a:pPr>
             <a:r>
-              <a:t>  • rag_k10 (k=10): 4,537 in / 801 out (~$0.001679 / query)</a:t>
-            </a:r>
-          </a:p>
-          <a:p>
-            <a:pPr>
-              <a:spcBef>
-                <a:spcPts val="200"/>
+              <a:t>  • Quyết toán thực tế 5 điều kiện chính thức: $6.58 settled spend ($6.57575890 USD).</a:t>
+            </a:r>
+          </a:p>
+          <a:p>
+            <a:pPr>
+              <a:spcBef>
+                <a:spcPts val="180"/>
               </a:spcBef>
               <a:defRPr sz="1050">
                 <a:solidFill>
@@ -10781,13 +10812,13 @@
               </a:defRPr>
             </a:pPr>
             <a:r>
-              <a:t>•  Hạch toán tài chính toàn thể nghiên cứu (6,400 Requests):</a:t>
-            </a:r>
-          </a:p>
-          <a:p>
-            <a:pPr>
-              <a:spcBef>
-                <a:spcPts val="200"/>
+              <a:t>  • Khoản giữ chỗ thận trọng pilot: $0.05264010 USD (phân tách rạch ròi khỏi chi phí quyết toán).</a:t>
+            </a:r>
+          </a:p>
+          <a:p>
+            <a:pPr>
+              <a:spcBef>
+                <a:spcPts val="180"/>
               </a:spcBef>
               <a:defRPr sz="1050">
                 <a:solidFill>
@@ -10797,13 +10828,13 @@
               </a:defRPr>
             </a:pPr>
             <a:r>
-              <a:t>  • Trần ngân sách đóng băng cứng (Hard budget cap): $19.99 USD.</a:t>
-            </a:r>
-          </a:p>
-          <a:p>
-            <a:pPr>
-              <a:spcBef>
-                <a:spcPts val="200"/>
+              <a:t>  • Tổng chi phí cam kết (Committed spend): $6.63 USD ($6.62839900 USD).</a:t>
+            </a:r>
+          </a:p>
+          <a:p>
+            <a:pPr>
+              <a:spcBef>
+                <a:spcPts val="180"/>
               </a:spcBef>
               <a:defRPr sz="1050">
                 <a:solidFill>
@@ -10813,13 +10844,13 @@
               </a:defRPr>
             </a:pPr>
             <a:r>
-              <a:t>  • Quyết toán thực tế 5 điều kiện chính thức: $6.58 settled spend ($6.57575890 USD).</a:t>
-            </a:r>
-          </a:p>
-          <a:p>
-            <a:pPr>
-              <a:spcBef>
-                <a:spcPts val="200"/>
+              <a:t>  • Ngân sách khả dụng còn lại: $13.36 net remaining ($13.36160100 USD; 0 holds, 0 breach).</a:t>
+            </a:r>
+          </a:p>
+          <a:p>
+            <a:pPr>
+              <a:spcBef>
+                <a:spcPts val="180"/>
               </a:spcBef>
               <a:defRPr sz="1050">
                 <a:solidFill>
@@ -10829,23 +10860,7 @@
               </a:defRPr>
             </a:pPr>
             <a:r>
-              <a:t>  • Khoản giữ chỗ thận trọng pilot: $0.05264010 USD; tổng cam kết: $6.63 committed spend ($6.62839900 USD).</a:t>
-            </a:r>
-          </a:p>
-          <a:p>
-            <a:pPr>
-              <a:spcBef>
-                <a:spcPts val="200"/>
-              </a:spcBef>
-              <a:defRPr sz="1050">
-                <a:solidFill>
-                  <a:srgbClr val="0F172A"/>
-                </a:solidFill>
-                <a:latin typeface="Calibri"/>
-              </a:defRPr>
-            </a:pPr>
-            <a:r>
-              <a:t>  • Ngân sách khả dụng còn lại: $13.36 net remaining ($13.36160100 USD; 0 holds, 0 breach).</a:t>
+              <a:t>•  Đơn giá truy vấn: Baseline No-RAG ~$0.000365/req (674.3 in / 163.6 out, trễ 2303 ms) vs RAG k=10 ~$0.001679/req (5114.3 in / 333.9 out, trễ 2667 ms).</a:t>
             </a:r>
           </a:p>
         </p:txBody>
@@ -10966,7 +10981,7 @@
               </a:defRPr>
             </a:pPr>
             <a:r>
-              <a:t>•  Tăng k từ 1 lên 10 giúp tăng Hit rate từ 4.2% lên 45.1%, nhưng lượng token đầu vào tăng ~4x.</a:t>
+              <a:t>•  Tăng k từ 1 lên 10 nâng Hit rate từ 3.76% lên 44.71%, nhưng lượng token đầu vào tăng ~7.6x.</a:t>
             </a:r>
           </a:p>
           <a:p>
@@ -10982,7 +10997,7 @@
               </a:defRPr>
             </a:pPr>
             <a:r>
-              <a:t>•  Dự báo chuẩn tắc tập TEST (&lt; $10 USD) nằm an toàn dưới trần ngân sách đóng băng $19.99 USD.</a:t>
+              <a:t>•  Toàn bộ chi phí thực nghiệm ($6.57575890 USD) nằm an toàn dưới trần ngân sách đóng băng $19.99 USD.</a:t>
             </a:r>
           </a:p>
         </p:txBody>

</xml_diff>

<commit_message>
feat(slides): canonical slide renderer with bound candidate figures, exact notes provenance, and test suite
</commit_message>
<xml_diff>
--- a/docs/presentation/slides.pptx
+++ b/docs/presentation/slides.pptx
@@ -528,7 +528,7 @@
           </a:p>
           <a:p>
             <a:r>
-              <a:t>Bằng chứng dự án: config/canonical_experiment_lock_v1.json (SHA-256: 961ba9b3e9e1b459a6694a5c8c76424d36c89d65bd4d88b14d0b0de7e4c017ac); reports/experiment_protocol_v1.md (SHA-256: d3bf3d31ad307100ac437a7daecc470bf12de9ada49f19de3d77592d5a21974c); artifacts/results/canonical_metric_bundle_v2.json (SHA-256: 442b5933858caafc9da3c06ee9398637213ed30d7a7db80195c0babb1195ef34); scripts/reproduce_study.py.</a:t>
+              <a:t>Bằng chứng dự án: config/canonical_experiment_lock_v1.json (SHA-256: d0ce198ad4853f4c41ef2bfbafbe10a395e4927a6c6561b3e72c055c4b887e9f); reports/experiment_protocol_v1.md (SHA-256: d3bf3d31ad307100ac437a7daecc470bf12de9ada49f19de3d77592d5a21974c); artifacts/results/canonical_metric_bundle_v2.json (SHA-256: 442b5933858caafc9da3c06ee9398637213ed30d7a7db80195c0babb1195ef34); scripts/reproduce_study.py.</a:t>
             </a:r>
           </a:p>
         </p:txBody>
@@ -688,7 +688,7 @@
           </a:p>
           <a:p>
             <a:r>
-              <a:t>Bằng chứng dự án: config/canonical_experiment_lock_v1.json (SHA-256: 961ba9b3...); artifacts/results/canonical_metric_bundle_v2.json; scripts/reproduce_study.py; scripts/run_offline_tests.py; tests/test_smoke_cases.py.</a:t>
+              <a:t>Bằng chứng dự án: config/canonical_experiment_lock_v1.json (SHA-256: d0ce198ad4853f4c41ef2bfbafbe10a395e4927a6c6561b3e72c055c4b887e9f); artifacts/results/canonical_metric_bundle_v2.json (SHA-256: 442b5933858caafc9da3c06ee9398637213ed30d7a7db80195c0babb1195ef34); scripts/reproduce_study.py; scripts/run_offline_tests.py; tests/test_smoke_cases.py.</a:t>
             </a:r>
           </a:p>
         </p:txBody>
@@ -773,7 +773,7 @@
           </a:p>
           <a:p>
             <a:r>
-              <a:t>Bằng chứng dự án: PR #26 (https://github.com/habachcp6/RAG2ATTCK/pull/26); docs/sanitized_evidence_manifest.json; artifacts/results/canonical_metric_bundle_v2.json; reports/evidence/reproducibility_package_manifest.md.</a:t>
+              <a:t>Bằng chứng dự án: PR #26 (https://github.com/habachcp6/RAG2ATTCK/pull/26); docs/sanitized_evidence_manifest.json; artifacts/results/canonical_metric_bundle_v2.json (SHA-256: 442b5933858caafc9da3c06ee9398637213ed30d7a7db80195c0babb1195ef34); reports/evidence/reproducibility_package_manifest.md.</a:t>
             </a:r>
           </a:p>
         </p:txBody>
@@ -853,7 +853,7 @@
           </a:p>
           <a:p>
             <a:r>
-              <a:t>Bằng chứng dự án: docs/README_PROPOSED.md; config/canonical_experiment_lock_v1.json (SHA-256: 961ba9b3...); reports/experiment_protocol_v1.md (D3 policy); tests/test_attack_id_validation.py.</a:t>
+              <a:t>Bằng chứng dự án: docs/README_PROPOSED.md; config/canonical_experiment_lock_v1.json (SHA-256: d0ce198a...); reports/experiment_protocol_v1.md (D3 policy); tests/test_attack_id_validation.py.</a:t>
             </a:r>
           </a:p>
         </p:txBody>
@@ -933,7 +933,7 @@
           </a:p>
           <a:p>
             <a:r>
-              <a:t>Bằng chứng dự án: prompts/baseline_v1.txt (SHA-256: b751fde1ee33b03ebca935e478ffef3ff03ff8bcf440263309a039755ab0f7cf); attack/corpus/enterprise-windows-v19.2.jsonl (SHA-256: b219341154ddf2f12e97d622158a04ab7d57641df6a865559258d365852c3c75); config/experiment_config.json; tests/test_rag_pipeline.py.</a:t>
+              <a:t>Bằng chứng dự án: prompts/baseline_v1.txt (SHA-256: b751fde1ee33b03ec0bdc07cbba10267002d2086cf22b91a74bdfd123856f206); attack/corpus/enterprise-windows-v19.2.jsonl (SHA-256: b219341154ddf2f12e97d622158a04ab7d57641df6a865559258d365852c3c75); config/experiment_config.json (SHA-256: 961ba9b3e9e1b459a6694a5c8c76424d36c89d65bd4d88b14d0b0de7e4c017ac); tests/test_rag_pipeline.py.</a:t>
             </a:r>
           </a:p>
         </p:txBody>
@@ -1013,7 +1013,7 @@
           </a:p>
           <a:p>
             <a:r>
-              <a:t>Bằng chứng dự án: data/ground_truth/synthetic/inference.jsonl (SHA-256: 90d5f59e64f669f9d7990520625906d40081d5aa112521c7bb5e2f750b3e5fbf); data/ground_truth/synthetic/pairs.json (SHA-256: 079e57a441b18d12351bb9715fc4b0a43058a9ceb68a8670c5e7bfa5dbad3ca8); tests/test_benchmark_inputs.py; tests/test_synthetic_freeze.py.</a:t>
+              <a:t>Bằng chứng dự án: data/ground_truth/synthetic/inference.jsonl (SHA-256: 90d5f59e64f669f95d5ddccd86f1f047e10ee3dc46e4b67a8cd13d1ddf2cd4b8); data/ground_truth/synthetic/pairs.jsonl (SHA-256: 079e57a441b18d127739f610e7f62c263d943eefa19ca4ea5c6eab8b8a07665d); tests/test_benchmark_inputs.py; tests/test_synthetic_freeze.py.</a:t>
             </a:r>
           </a:p>
         </p:txBody>
@@ -1203,7 +1203,7 @@
           </a:p>
           <a:p>
             <a:r>
-              <a:t>Bằng chứng dự án: outputs/reproduction/figures/fig_rq2_retrieval_hit_rates.png; outputs/reproduction/tables/table_1_retrieval_diagnostics.md; tests/test_retrieval_diagnostics.py.</a:t>
+              <a:t>Bằng chứng dự án: docs/presentation/figures/canonical_rq2_retrieval_hit_rate.png (SHA-256: f8287936d2b5fc24e89584349028f393b801b6bebe668f8bea449c6b67f2128f); docs/presentation/figures/fig4_retrieval_hit_rate.png; outputs/reproduction/tables/table_1_retrieval_diagnostics.md; tests/test_retrieval_diagnostics.py.</a:t>
             </a:r>
           </a:p>
         </p:txBody>
@@ -1278,12 +1278,17 @@
           </a:p>
           <a:p>
             <a:r>
-              <a:t>So sánh đối ứng trên 296 cặp anchor chuẩn chỉ ra rằng biểu diễn Single-event đạt thứ hạng tìm kiếm tốt hơn Contextual-event (65 cặp vs 23 cặp), và hơn 70% có thứ hạng tương đương (phần lớn do cả hai cùng trượt Top-10). Điều này cho thấy việc đưa thêm log nền gây hiện tượng benign drift. Chúng tôi thiết lập schema so sánh đối chứng scaffold giữa Zero-Shot No-RAG, Zero-Shot RAG và các prompt scaffold. Ở điều kiện RAG k=10 trên 278 cặp đầy đủ nhãn GT, cả Single và Contextual view đều đạt 83.81% (paired delta = 0.0 pp, McNemar p = 1.0), nghiêm cấm suy diễn quan hệ nhân quả thuần túy khi hình thức biểu diễn thay đổi.</a:t>
-            </a:r>
-          </a:p>
-          <a:p>
-            <a:r>
-              <a:t>Bằng chứng dự án: scripts/verify_t20_canonical_artifacts.py; outputs/reproduction/tables/table_4_pairwise_representation_comparison.md; tests/test_t20_canonical_artifacts.py.</a:t>
+              <a:t>Phân tích lỗi khâu truy xuất và chẩn đoán có điều kiện (RQ2) trên tập scorable N=718 cho thấy: khi kỹ thuật đúng có mặt trong Top-10 (N=321), tỷ lệ gán đúng đạt 91.28% (293/321); khi kỹ thuật đúng vắng mặt (N=397), tỷ lệ gán đúng giảm xuống 70.03% (278/397). Độ chênh lệch quan sát được là +21.25 pp. Chúng tôi nhấn mạnh: đây thuần túy là tương quan quan sát trong thực nghiệm (observational association), không áp đặt suy diễn quan hệ nhân quả.</a:t>
+            </a:r>
+          </a:p>
+          <a:p>
+            <a:r>
+              <a:t>Theo định đề phân rã lỗi D2i, trong số 147 trường hợp phân loại sai tại k=10, có tới 119 trường hợp (80.95%) đồng thời rơi vào khâu retrieval miss. Chỉ có 28 trường hợp (19.05%) bị phân loại sai khi kỹ thuật đã được truy xuất thành công.</a:t>
+            </a:r>
+          </a:p>
+          <a:p>
+            <a:r>
+              <a:t>Bằng chứng dự án: artifacts/results/canonical_metric_bundle_v2.json (SHA-256: 442b5933858caafc9da3c06ee9398637213ed30d7a7db80195c0babb1195ef34); reports/experiment_protocol_v1.md (D2i); tests/test_experiment_evaluation.py.</a:t>
             </a:r>
           </a:p>
         </p:txBody>
@@ -1368,6 +1373,11 @@
           </a:p>
           <a:p>
             <a:r>
+              <a:t>Về Macro-F1: Được đánh giá nhất quán trên toàn bộ vũ trụ 474 lớp kỹ thuật MITRE ATT&amp;CK v19.2 Enterprise Windows theo định đề D2d (FROZEN_BENCHMARK_UNIVERSE = 474), gồm 8 lớp có mẫu hỗ trợ và 466 lớp zero-support: No-RAG đạt 0.0126 vs RAG k=10 đạt 0.0140 (Delta +0.0014).</a:t>
+            </a:r>
+          </a:p>
+          <a:p>
+            <a:r>
               <a:t>Ranh giới lỗi phân định độc lập: 1 physical retry thành công sau sự cố mạng API_FAILURE; ghi nhận 0 terminal provider failure trên toàn bộ 3,590 scorable records (13 incomplete records ghi nhận trên toàn campaign 6,400 requests đều thuộc nhóm unmapped/ambiguous).</a:t>
             </a:r>
           </a:p>
@@ -1378,7 +1388,7 @@
           </a:p>
           <a:p>
             <a:r>
-              <a:t>Bằng chứng dự án: reports/experiment_protocol_v1.md (D2e, D2f, D2h, D2i; SHA-256: d3bf3d31ad307100ac437a7daecc470bf12de9ada49f19de3d77592d5a21974c); artifacts/results/canonical_metric_bundle_v2.json; tests/test_experiment_evaluation.py.</a:t>
+              <a:t>Bằng chứng dự án: reports/experiment_protocol_v1.md (D2d, D2e, D2f, D2h, D2i; SHA-256: d3bf3d31ad307100ac437a7daecc470bf12de9ada49f19de3d77592d5a21974c); artifacts/results/canonical_metric_bundle_v2.json (SHA-256: 442b5933858caafc9da3c06ee9398637213ed30d7a7db80195c0babb1195ef34); tests/test_experiment_evaluation.py.</a:t>
             </a:r>
           </a:p>
         </p:txBody>
@@ -1458,7 +1468,7 @@
           </a:p>
           <a:p>
             <a:r>
-              <a:t>1. Dữ liệu DEV là dữ liệu tổng hợp (synthetic-paired-v1 DEV split). Việc gửi request lên OpenAI không biến log tổng hợp thành dữ liệu thực địa in-the-wild.</a:t>
+              <a:t>1. Dữ liệu thử nghiệm Stage B là dữ liệu tổng hợp (synthetic split). Việc gửi request lên OpenAI không biến log tổng hợp thành dữ liệu thực địa in-the-wild.</a:t>
             </a:r>
           </a:p>
           <a:p>
@@ -1478,7 +1488,12 @@
           </a:p>
           <a:p>
             <a:r>
-              <a:t>Bằng chứng dự án: config/experiment_config.json (hard_budget_limit_usd: 19.99); artifacts/results/canonical_metric_bundle_v2.json; tests/test_monetary_guard.py.</a:t>
+              <a:t>5. Đánh đổi token: Tỷ lệ tăng token prompt từ k=1 lên k=10 là ~4.103x (1246.5 lên 5114.3 tokens); tỷ lệ từ No-RAG lên k=10 là ~7.58x.</a:t>
+            </a:r>
+          </a:p>
+          <a:p>
+            <a:r>
+              <a:t>Bằng chứng dự án: docs/presentation/figures/canonical_rq3_resource_consumption.png (SHA-256: ca296165b38b499432f851618e3d6a512964c461e59dc3b646e647ddcb70bfb1); docs/presentation/figures/fig7_cost_and_tokens_vs_k.png; config/experiment_config.json (hard_budget_limit_usd: 19.99); artifacts/results/canonical_metric_bundle_v2.json (SHA-256: 442b5933858caafc9da3c06ee9398637213ed30d7a7db80195c0babb1195ef34); tests/test_monetary_guard.py.</a:t>
             </a:r>
           </a:p>
         </p:txBody>
@@ -8945,7 +8960,7 @@
               </a:defRPr>
             </a:pPr>
             <a:r>
-              <a:t>•  Macro Recall@10: 42.80%  |  Bối cảnh lịch sử T20 pilot: Hit@10=45.11%.</a:t>
+              <a:t>•  Macro Recall@10: 42.80%  |  Độ phủ Top-10: Hit@10=44.71%.</a:t>
             </a:r>
           </a:p>
           <a:p>
@@ -8968,7 +8983,7 @@
       </p:sp>
       <p:pic>
         <p:nvPicPr>
-          <p:cNvPr id="8" name="Picture 7" descr="fig_rq2_retrieval_hit_rates.png"/>
+          <p:cNvPr id="8" name="Picture 7" descr="canonical_rq2_retrieval_hit_rate.png"/>
           <p:cNvPicPr>
             <a:picLocks noChangeAspect="1"/>
           </p:cNvPicPr>
@@ -8983,7 +8998,7 @@
         <p:spPr>
           <a:xfrm>
             <a:off x="6248095" y="1234440"/>
-            <a:ext cx="5212080" cy="3257550"/>
+            <a:ext cx="5212080" cy="3127248"/>
           </a:xfrm>
           <a:prstGeom prst="rect">
             <a:avLst/>
@@ -9281,7 +9296,7 @@
               </a:defRPr>
             </a:pPr>
             <a:r>
-              <a:t>6. Tác Động Của Hình Thức Biểu Diễn Telemetry</a:t>
+              <a:t>6. Phân Tích Lỗi Khâu Truy Xuất &amp; Chẩn Đoán Có Điều Kiện (RQ2)</a:t>
             </a:r>
           </a:p>
           <a:p>
@@ -9294,7 +9309,7 @@
               </a:defRPr>
             </a:pPr>
             <a:r>
-              <a:t>So sánh thực nghiệm Single vs Contextual trên 670 cặp kịch bản đối ứng  |  [CANONICAL CANDIDATE — PENDING ROOT FINAL REVIEW]</a:t>
+              <a:t>Đo lường tương quan quan sát giữa thành công truy xuất và độ chính xác phân loại trên 718 views TEST  |  [CANONICAL CANDIDATE — PENDING ROOT FINAL REVIEW]</a:t>
             </a:r>
           </a:p>
         </p:txBody>
@@ -9375,7 +9390,7 @@
               </a:defRPr>
             </a:pPr>
             <a:r>
-              <a:t>Phân Tích Cặp Anchor Chuẩn (296 Cặp - Primary)</a:t>
+              <a:t>Chẩn Đoán Có Điều Kiện Theo Khâu Truy Xuất (TEST N=718)</a:t>
             </a:r>
           </a:p>
           <a:p>
@@ -9383,15 +9398,15 @@
               <a:spcBef>
                 <a:spcPts val="300"/>
               </a:spcBef>
-              <a:defRPr sz="1150">
-                <a:solidFill>
-                  <a:srgbClr val="0F172A"/>
-                </a:solidFill>
-                <a:latin typeface="Calibri"/>
-              </a:defRPr>
-            </a:pPr>
-            <a:r>
-              <a:t>•  Quy mô: 670 cặp kịch bản đối ứng; 374 cặp bị loại trừ do đa nhãn/mismatch.</a:t>
+              <a:defRPr sz="1100">
+                <a:solidFill>
+                  <a:srgbClr val="0F172A"/>
+                </a:solidFill>
+                <a:latin typeface="Calibri"/>
+              </a:defRPr>
+            </a:pPr>
+            <a:r>
+              <a:t>•  Kỹ thuật GT có mặt trong Top-10 (Retrieval Success): N=321 (44.71%)</a:t>
             </a:r>
           </a:p>
           <a:p>
@@ -9399,15 +9414,15 @@
               <a:spcBef>
                 <a:spcPts val="300"/>
               </a:spcBef>
-              <a:defRPr sz="1150">
-                <a:solidFill>
-                  <a:srgbClr val="0F172A"/>
-                </a:solidFill>
-                <a:latin typeface="Calibri"/>
-              </a:defRPr>
-            </a:pPr>
-            <a:r>
-              <a:t>•  Tiêu chí Anchor chuẩn (scripts/verify_t20_canonical_artifacts.py):</a:t>
+              <a:defRPr sz="1100">
+                <a:solidFill>
+                  <a:srgbClr val="0F172A"/>
+                </a:solidFill>
+                <a:latin typeface="Calibri"/>
+              </a:defRPr>
+            </a:pPr>
+            <a:r>
+              <a:t>  • P(Đúng | Đã truy xuất): 91.28% (293/321 views được gán đúng).</a:t>
             </a:r>
           </a:p>
           <a:p>
@@ -9415,15 +9430,15 @@
               <a:spcBef>
                 <a:spcPts val="300"/>
               </a:spcBef>
-              <a:defRPr sz="1150">
-                <a:solidFill>
-                  <a:srgbClr val="0F172A"/>
-                </a:solidFill>
-                <a:latin typeface="Calibri"/>
-              </a:defRPr>
-            </a:pPr>
-            <a:r>
-              <a:t>  • Single view có duy nhất 1 kỹ thuật và kỹ thuật này có mặt trong Contextual view.</a:t>
+              <a:defRPr sz="1100">
+                <a:solidFill>
+                  <a:srgbClr val="0F172A"/>
+                </a:solidFill>
+                <a:latin typeface="Calibri"/>
+              </a:defRPr>
+            </a:pPr>
+            <a:r>
+              <a:t>•  Kỹ thuật GT vắng mặt trong Top-10 (Retrieval Miss): N=397 (55.29%)</a:t>
             </a:r>
           </a:p>
           <a:p>
@@ -9431,15 +9446,15 @@
               <a:spcBef>
                 <a:spcPts val="300"/>
               </a:spcBef>
-              <a:defRPr sz="1150">
-                <a:solidFill>
-                  <a:srgbClr val="0F172A"/>
-                </a:solidFill>
-                <a:latin typeface="Calibri"/>
-              </a:defRPr>
-            </a:pPr>
-            <a:r>
-              <a:t>•  Phân bố thứ hạng thực nghiệm quan sát được:</a:t>
+              <a:defRPr sz="1100">
+                <a:solidFill>
+                  <a:srgbClr val="0F172A"/>
+                </a:solidFill>
+                <a:latin typeface="Calibri"/>
+              </a:defRPr>
+            </a:pPr>
+            <a:r>
+              <a:t>  • P(Đúng | Vắng mặt): 70.03% (278/397 views gán đúng nhờ năng lực nội tại LLM).</a:t>
             </a:r>
           </a:p>
           <a:p>
@@ -9447,15 +9462,15 @@
               <a:spcBef>
                 <a:spcPts val="300"/>
               </a:spcBef>
-              <a:defRPr sz="1150">
-                <a:solidFill>
-                  <a:srgbClr val="0F172A"/>
-                </a:solidFill>
-                <a:latin typeface="Calibri"/>
-              </a:defRPr>
-            </a:pPr>
-            <a:r>
-              <a:t>  • Single-event đạt thứ hạng tốt hơn: 65 cặp (22.0%)</a:t>
+              <a:defRPr sz="1100">
+                <a:solidFill>
+                  <a:srgbClr val="0F172A"/>
+                </a:solidFill>
+                <a:latin typeface="Calibri"/>
+              </a:defRPr>
+            </a:pPr>
+            <a:r>
+              <a:t>•  Khoảng chênh lệch quan sát: +21.25 pp (91.28% vs 70.03%) cho thấy sự hiện diện của ngữ cảnh gắn liền với tỷ lệ gán đúng cao hơn.</a:t>
             </a:r>
           </a:p>
           <a:p>
@@ -9463,79 +9478,15 @@
               <a:spcBef>
                 <a:spcPts val="300"/>
               </a:spcBef>
-              <a:defRPr sz="1150">
-                <a:solidFill>
-                  <a:srgbClr val="0F172A"/>
-                </a:solidFill>
-                <a:latin typeface="Calibri"/>
-              </a:defRPr>
-            </a:pPr>
-            <a:r>
-              <a:t>  • Contextual-event đạt thứ hạng tốt hơn: 23 cặp (7.8%)</a:t>
-            </a:r>
-          </a:p>
-          <a:p>
-            <a:pPr>
-              <a:spcBef>
-                <a:spcPts val="300"/>
-              </a:spcBef>
-              <a:defRPr sz="1150">
-                <a:solidFill>
-                  <a:srgbClr val="0F172A"/>
-                </a:solidFill>
-                <a:latin typeface="Calibri"/>
-              </a:defRPr>
-            </a:pPr>
-            <a:r>
-              <a:t>  • Hiệu năng thứ hạng tương đương: 208 cặp (70.3%)</a:t>
-            </a:r>
-          </a:p>
-          <a:p>
-            <a:pPr>
-              <a:spcBef>
-                <a:spcPts val="300"/>
-              </a:spcBef>
-              <a:defRPr sz="1150">
-                <a:solidFill>
-                  <a:srgbClr val="0F172A"/>
-                </a:solidFill>
-                <a:latin typeface="Calibri"/>
-              </a:defRPr>
-            </a:pPr>
-            <a:r>
-              <a:t>    - Cả hai biểu diễn cùng trượt Top-10: 147 cặp</a:t>
-            </a:r>
-          </a:p>
-          <a:p>
-            <a:pPr>
-              <a:spcBef>
-                <a:spcPts val="300"/>
-              </a:spcBef>
-              <a:defRPr sz="1150">
-                <a:solidFill>
-                  <a:srgbClr val="0F172A"/>
-                </a:solidFill>
-                <a:latin typeface="Calibri"/>
-              </a:defRPr>
-            </a:pPr>
-            <a:r>
-              <a:t>    - Đồng hạng chính xác trong Top-10: 61 cặp</a:t>
-            </a:r>
-          </a:p>
-          <a:p>
-            <a:pPr>
-              <a:spcBef>
-                <a:spcPts val="300"/>
-              </a:spcBef>
-              <a:defRPr sz="1150">
-                <a:solidFill>
-                  <a:srgbClr val="0F172A"/>
-                </a:solidFill>
-                <a:latin typeface="Calibri"/>
-              </a:defRPr>
-            </a:pPr>
-            <a:r>
-              <a:t>•  Nhóm lọc đơn kỹ thuật nghiêm ngặt (252 cặp - Secondary): Single tốt hơn 59 cặp (23.4%) vs. Contextual 23 cặp (9.1%), ngang nhau 170 cặp.</a:t>
+              <a:defRPr sz="1100">
+                <a:solidFill>
+                  <a:srgbClr val="0F172A"/>
+                </a:solidFill>
+                <a:latin typeface="Calibri"/>
+              </a:defRPr>
+            </a:pPr>
+            <a:r>
+              <a:t>•  Nguyên tắc suy luận: Trình bày thuần túy dưới dạng tương quan quan sát (observational association), không suy diễn quan hệ nhân quả tuyệt đối.</a:t>
             </a:r>
           </a:p>
         </p:txBody>
@@ -9616,151 +9567,103 @@
               </a:defRPr>
             </a:pPr>
             <a:r>
-              <a:t>Hiện Tượng Quan Sát &amp; Schema So Sánh [CANONICAL CANDIDATE — PENDING ROOT FINAL REVIEW]</a:t>
-            </a:r>
-          </a:p>
-          <a:p>
-            <a:pPr>
-              <a:spcBef>
-                <a:spcPts val="300"/>
-              </a:spcBef>
-              <a:defRPr sz="1150">
-                <a:solidFill>
-                  <a:srgbClr val="0F172A"/>
-                </a:solidFill>
-                <a:latin typeface="Calibri"/>
-              </a:defRPr>
-            </a:pPr>
-            <a:r>
-              <a:t>•  Hiện tượng Benign Drift khi mở rộng ngữ cảnh:</a:t>
-            </a:r>
-          </a:p>
-          <a:p>
-            <a:pPr>
-              <a:spcBef>
-                <a:spcPts val="300"/>
-              </a:spcBef>
-              <a:defRPr sz="1150">
-                <a:solidFill>
-                  <a:srgbClr val="0F172A"/>
-                </a:solidFill>
-                <a:latin typeface="Calibri"/>
-              </a:defRPr>
-            </a:pPr>
-            <a:r>
-              <a:t>  • Gộp các sự kiện lân cận bổ sung nhiều token thông thường (Explorer, DNS, svchost).</a:t>
-            </a:r>
-          </a:p>
-          <a:p>
-            <a:pPr>
-              <a:spcBef>
-                <a:spcPts val="300"/>
-              </a:spcBef>
-              <a:defRPr sz="1150">
-                <a:solidFill>
-                  <a:srgbClr val="0F172A"/>
-                </a:solidFill>
-                <a:latin typeface="Calibri"/>
-              </a:defRPr>
-            </a:pPr>
-            <a:r>
-              <a:t>  • Vector dense embedding bị kéo lệch về hành vi bình thường, làm tụt thứ hạng kỹ thuật tấn công.</a:t>
-            </a:r>
-          </a:p>
-          <a:p>
-            <a:pPr>
-              <a:spcBef>
-                <a:spcPts val="300"/>
-              </a:spcBef>
-              <a:defRPr sz="1150">
-                <a:solidFill>
-                  <a:srgbClr val="0F172A"/>
-                </a:solidFill>
-                <a:latin typeface="Calibri"/>
-              </a:defRPr>
-            </a:pPr>
-            <a:r>
-              <a:t>•  Schema So Sánh Đối Chứng Scaffold [CANONICAL CANDIDATE — PENDING ROOT FINAL REVIEW]:</a:t>
-            </a:r>
-          </a:p>
-          <a:p>
-            <a:pPr>
-              <a:spcBef>
-                <a:spcPts val="300"/>
-              </a:spcBef>
-              <a:defRPr sz="1150">
-                <a:solidFill>
-                  <a:srgbClr val="0F172A"/>
-                </a:solidFill>
-                <a:latin typeface="Calibri"/>
-              </a:defRPr>
-            </a:pPr>
-            <a:r>
-              <a:t>  • Đối chứng: Zero-Shot No-RAG vs Zero-Shot RAG (k=1..10) vs Prompt Scaffolds.</a:t>
-            </a:r>
-          </a:p>
-          <a:p>
-            <a:pPr>
-              <a:spcBef>
-                <a:spcPts val="300"/>
-              </a:spcBef>
-              <a:defRPr sz="1150">
-                <a:solidFill>
-                  <a:srgbClr val="0F172A"/>
-                </a:solidFill>
-                <a:latin typeface="Calibri"/>
-              </a:defRPr>
-            </a:pPr>
-            <a:r>
-              <a:t>  • Tại RAG k=10: Single và Contextual view đều đạt 83.81% (Paired Delta = 0.0 pp, McNemar p = 1.0).</a:t>
-            </a:r>
-          </a:p>
-          <a:p>
-            <a:pPr>
-              <a:spcBef>
-                <a:spcPts val="300"/>
-              </a:spcBef>
-              <a:defRPr sz="1150">
-                <a:solidFill>
-                  <a:srgbClr val="0F172A"/>
-                </a:solidFill>
-                <a:latin typeface="Calibri"/>
-              </a:defRPr>
-            </a:pPr>
-            <a:r>
-              <a:t>  • Giả thuyết: Khối tri thức RAG bổ trợ cần đi kèm tiền lọc sự kiện nghi vấn thay vì nhúng thô.</a:t>
-            </a:r>
-          </a:p>
-          <a:p>
-            <a:pPr>
-              <a:spcBef>
-                <a:spcPts val="300"/>
-              </a:spcBef>
-              <a:defRPr sz="1150">
-                <a:solidFill>
-                  <a:srgbClr val="0F172A"/>
-                </a:solidFill>
-                <a:latin typeface="Calibri"/>
-              </a:defRPr>
-            </a:pPr>
-            <a:r>
-              <a:t>  • Trạng thái: Kiểm chứng đối chứng trên ma trận TEST.</a:t>
-            </a:r>
-          </a:p>
-          <a:p>
-            <a:pPr>
-              <a:spcBef>
-                <a:spcPts val="300"/>
-              </a:spcBef>
-              <a:defRPr sz="1150">
-                <a:solidFill>
-                  <a:srgbClr val="0F172A"/>
-                </a:solidFill>
-                <a:latin typeface="Calibri"/>
-              </a:defRPr>
-            </a:pPr>
-            <a:r>
-              <a:t>•  Phạm vi khảo sát: Ghi nhận trên synthetic-paired-v1; cần tiếp tục kiểm chứng trên telemetry thực tế.</a:t>
+              <a:t>Bóc Tách Lỗi &amp; Phần Giao Thoa Độc Lập Theo Định Đề D2i</a:t>
+            </a:r>
+          </a:p>
+          <a:p>
+            <a:pPr>
+              <a:spcBef>
+                <a:spcPts val="250"/>
+              </a:spcBef>
+              <a:defRPr sz="1050">
+                <a:solidFill>
+                  <a:srgbClr val="0F172A"/>
+                </a:solidFill>
+                <a:latin typeface="Calibri"/>
+              </a:defRPr>
+            </a:pPr>
+            <a:r>
+              <a:t>•  Tổng số lỗi phân loại tại k=10: 147 views (718 - 571 = 147).</a:t>
+            </a:r>
+          </a:p>
+          <a:p>
+            <a:pPr>
+              <a:spcBef>
+                <a:spcPts val="250"/>
+              </a:spcBef>
+              <a:defRPr sz="1050">
+                <a:solidFill>
+                  <a:srgbClr val="0F172A"/>
+                </a:solidFill>
+                <a:latin typeface="Calibri"/>
+              </a:defRPr>
+            </a:pPr>
+            <a:r>
+              <a:t>•  Phần giao thoa lỗi (Joint Overlap per D2i): 119 / 147 (80.95% tổng lỗi phân loại) xảy ra khi retrieval trượt Top-10.</a:t>
+            </a:r>
+          </a:p>
+          <a:p>
+            <a:pPr>
+              <a:spcBef>
+                <a:spcPts val="250"/>
+              </a:spcBef>
+              <a:defRPr sz="1050">
+                <a:solidFill>
+                  <a:srgbClr val="0F172A"/>
+                </a:solidFill>
+                <a:latin typeface="Calibri"/>
+              </a:defRPr>
+            </a:pPr>
+            <a:r>
+              <a:t>•  Lỗi khi retrieval thành công: 28 / 147 (19.05% tổng lỗi phân loại) mô hình chọn sai kỹ thuật dù đã có trong ngữ cảnh (downstream confusion / distractor effect).</a:t>
+            </a:r>
+          </a:p>
+          <a:p>
+            <a:pPr>
+              <a:spcBef>
+                <a:spcPts val="250"/>
+              </a:spcBef>
+              <a:defRPr sz="1050">
+                <a:solidFill>
+                  <a:srgbClr val="0F172A"/>
+                </a:solidFill>
+                <a:latin typeface="Calibri"/>
+              </a:defRPr>
+            </a:pPr>
+            <a:r>
+              <a:t>•  Tuân thủ định đề D2i: Ghi nhận đầy đủ phần giao thoa khác 0 giữa các trục đo lường lỗi độc lập, không áp đặt giả định xung khắc hay độc lập xác suất ngẫu nhiên.</a:t>
+            </a:r>
+          </a:p>
+          <a:p>
+            <a:pPr>
+              <a:spcBef>
+                <a:spcPts val="250"/>
+              </a:spcBef>
+              <a:defRPr sz="1050">
+                <a:solidFill>
+                  <a:srgbClr val="0F172A"/>
+                </a:solidFill>
+                <a:latin typeface="Calibri"/>
+              </a:defRPr>
+            </a:pPr>
+            <a:r>
+              <a:t>•  Schema So Sánh Đối Chứng Scaffold: Không sử dụng prompt scaffold trong giao thức chuẩn tắc.</a:t>
+            </a:r>
+          </a:p>
+          <a:p>
+            <a:pPr>
+              <a:spcBef>
+                <a:spcPts val="250"/>
+              </a:spcBef>
+              <a:defRPr sz="1050">
+                <a:solidFill>
+                  <a:srgbClr val="0F172A"/>
+                </a:solidFill>
+                <a:latin typeface="Calibri"/>
+              </a:defRPr>
+            </a:pPr>
+            <a:r>
+              <a:t>•  Ranh giới an toàn: Không xuất hiện lỗi API hay lỗi cú pháp mã kỹ thuật trên tập scorable (0 terminal provider failures, 0 invalid IDs).</a:t>
             </a:r>
           </a:p>
         </p:txBody>
@@ -10188,9 +10091,9 @@
           <a:p>
             <a:pPr>
               <a:spcBef>
-                <a:spcPts val="220"/>
-              </a:spcBef>
-              <a:defRPr sz="1050">
+                <a:spcPts val="150"/>
+              </a:spcBef>
+              <a:defRPr sz="1000">
                 <a:solidFill>
                   <a:srgbClr val="0F172A"/>
                 </a:solidFill>
@@ -10204,9 +10107,9 @@
           <a:p>
             <a:pPr>
               <a:spcBef>
-                <a:spcPts val="220"/>
-              </a:spcBef>
-              <a:defRPr sz="1050">
+                <a:spcPts val="150"/>
+              </a:spcBef>
+              <a:defRPr sz="1000">
                 <a:solidFill>
                   <a:srgbClr val="0F172A"/>
                 </a:solidFill>
@@ -10220,9 +10123,9 @@
           <a:p>
             <a:pPr>
               <a:spcBef>
-                <a:spcPts val="220"/>
-              </a:spcBef>
-              <a:defRPr sz="1050">
+                <a:spcPts val="150"/>
+              </a:spcBef>
+              <a:defRPr sz="1000">
                 <a:solidFill>
                   <a:srgbClr val="0F172A"/>
                 </a:solidFill>
@@ -10236,9 +10139,9 @@
           <a:p>
             <a:pPr>
               <a:spcBef>
-                <a:spcPts val="220"/>
-              </a:spcBef>
-              <a:defRPr sz="1050">
+                <a:spcPts val="150"/>
+              </a:spcBef>
+              <a:defRPr sz="1000">
                 <a:solidFill>
                   <a:srgbClr val="0F172A"/>
                 </a:solidFill>
@@ -10252,9 +10155,25 @@
           <a:p>
             <a:pPr>
               <a:spcBef>
-                <a:spcPts val="220"/>
-              </a:spcBef>
-              <a:defRPr sz="1050">
+                <a:spcPts val="150"/>
+              </a:spcBef>
+              <a:defRPr sz="1000">
+                <a:solidFill>
+                  <a:srgbClr val="0F172A"/>
+                </a:solidFill>
+                <a:latin typeface="Calibri"/>
+              </a:defRPr>
+            </a:pPr>
+            <a:r>
+              <a:t>•  Macro-F1 (vũ trụ 474 lớp D2d FROZEN_BENCHMARK_UNIVERSE): No-RAG 0.0126 vs RAG k=10 0.0140 (Delta +0.0014; 8 supported classes, 466 zero-support classes).</a:t>
+            </a:r>
+          </a:p>
+          <a:p>
+            <a:pPr>
+              <a:spcBef>
+                <a:spcPts val="150"/>
+              </a:spcBef>
+              <a:defRPr sz="1000">
                 <a:solidFill>
                   <a:srgbClr val="0F172A"/>
                 </a:solidFill>
@@ -10268,9 +10187,9 @@
           <a:p>
             <a:pPr>
               <a:spcBef>
-                <a:spcPts val="220"/>
-              </a:spcBef>
-              <a:defRPr sz="1050">
+                <a:spcPts val="150"/>
+              </a:spcBef>
+              <a:defRPr sz="1000">
                 <a:solidFill>
                   <a:srgbClr val="0F172A"/>
                 </a:solidFill>
@@ -10708,15 +10627,15 @@
               <a:spcBef>
                 <a:spcPts val="180"/>
               </a:spcBef>
-              <a:defRPr sz="1050">
-                <a:solidFill>
-                  <a:srgbClr val="0F172A"/>
-                </a:solidFill>
-                <a:latin typeface="Calibri"/>
-              </a:defRPr>
-            </a:pPr>
-            <a:r>
-              <a:t>•  Bản chất dữ liệu: DEV cohort là dữ liệu tổng hợp (synthetic split). Gửi request thực không biến log tổng hợp thành in-the-wild telemetry.</a:t>
+              <a:defRPr sz="1000">
+                <a:solidFill>
+                  <a:srgbClr val="0F172A"/>
+                </a:solidFill>
+                <a:latin typeface="Calibri"/>
+              </a:defRPr>
+            </a:pPr>
+            <a:r>
+              <a:t>•  Quy mô khảo sát chiến dịch TEST: N=1,280 views/điều kiện (6,400 logical requests, 6,401 physical attempts). Dữ liệu Stage B là telemetry giả lập có cấu trúc (synthetic split), không phải in-the-wild logs.</a:t>
             </a:r>
           </a:p>
           <a:p>
@@ -10724,15 +10643,15 @@
               <a:spcBef>
                 <a:spcPts val="180"/>
               </a:spcBef>
-              <a:defRPr sz="1050">
-                <a:solidFill>
-                  <a:srgbClr val="0F172A"/>
-                </a:solidFill>
-                <a:latin typeface="Calibri"/>
-              </a:defRPr>
-            </a:pPr>
-            <a:r>
-              <a:t>•  Quy mô khảo sát: N=1,280 queries/điều kiện; 6,400 logical requests; 6,401 physical attempts (1 physical API_FAILURE retry thành công với 1,540 cached tokens; 0 terminal provider failure trên 3,590 scorable records).</a:t>
+              <a:defRPr sz="1000">
+                <a:solidFill>
+                  <a:srgbClr val="0F172A"/>
+                </a:solidFill>
+                <a:latin typeface="Calibri"/>
+              </a:defRPr>
+            </a:pPr>
+            <a:r>
+              <a:t>•  Phân định ngoại lệ: 13 requests đạt trần context/output tokens (8,192 max tokens) đều thuộc nhóm unmapped/ambiguous; 1 physical API_FAILURE retry thành công với 1,540 cached tokens; 0 terminal provider failure trên 3,590 scorable records.</a:t>
             </a:r>
           </a:p>
           <a:p>
@@ -10740,15 +10659,15 @@
               <a:spcBef>
                 <a:spcPts val="180"/>
               </a:spcBef>
-              <a:defRPr sz="1050">
-                <a:solidFill>
-                  <a:srgbClr val="0F172A"/>
-                </a:solidFill>
-                <a:latin typeface="Calibri"/>
-              </a:defRPr>
-            </a:pPr>
-            <a:r>
-              <a:t>•  Ngoại lệ &amp; Trần tokens: 13 requests đạt trần context/output tokens (8,192 max tokens) đều thuộc nhóm unmapped/ambiguous.</a:t>
+              <a:defRPr sz="1000">
+                <a:solidFill>
+                  <a:srgbClr val="0F172A"/>
+                </a:solidFill>
+                <a:latin typeface="Calibri"/>
+              </a:defRPr>
+            </a:pPr>
+            <a:r>
+              <a:t>•  Hạch toán tài chính toàn thể nghiên cứu (6,400 Requests):</a:t>
             </a:r>
           </a:p>
           <a:p>
@@ -10756,15 +10675,15 @@
               <a:spcBef>
                 <a:spcPts val="180"/>
               </a:spcBef>
-              <a:defRPr sz="1050">
-                <a:solidFill>
-                  <a:srgbClr val="0F172A"/>
-                </a:solidFill>
-                <a:latin typeface="Calibri"/>
-              </a:defRPr>
-            </a:pPr>
-            <a:r>
-              <a:t>•  Hạch toán tài chính toàn thể nghiên cứu (6,400 Requests):</a:t>
+              <a:defRPr sz="1000">
+                <a:solidFill>
+                  <a:srgbClr val="0F172A"/>
+                </a:solidFill>
+                <a:latin typeface="Calibri"/>
+              </a:defRPr>
+            </a:pPr>
+            <a:r>
+              <a:t>  • Trần ngân sách đóng băng cứng (Hard budget cap): $19.99 USD ($19.99000000).</a:t>
             </a:r>
           </a:p>
           <a:p>
@@ -10772,15 +10691,15 @@
               <a:spcBef>
                 <a:spcPts val="180"/>
               </a:spcBef>
-              <a:defRPr sz="1050">
-                <a:solidFill>
-                  <a:srgbClr val="0F172A"/>
-                </a:solidFill>
-                <a:latin typeface="Calibri"/>
-              </a:defRPr>
-            </a:pPr>
-            <a:r>
-              <a:t>  • Trần ngân sách đóng băng cứng (Hard budget cap): $19.99 USD ($19.99000000).</a:t>
+              <a:defRPr sz="1000">
+                <a:solidFill>
+                  <a:srgbClr val="0F172A"/>
+                </a:solidFill>
+                <a:latin typeface="Calibri"/>
+              </a:defRPr>
+            </a:pPr>
+            <a:r>
+              <a:t>  • Quyết toán thực tế 5 điều kiện chính thức: $6.58 settled spend ($6.57575890 USD).</a:t>
             </a:r>
           </a:p>
           <a:p>
@@ -10788,15 +10707,15 @@
               <a:spcBef>
                 <a:spcPts val="180"/>
               </a:spcBef>
-              <a:defRPr sz="1050">
-                <a:solidFill>
-                  <a:srgbClr val="0F172A"/>
-                </a:solidFill>
-                <a:latin typeface="Calibri"/>
-              </a:defRPr>
-            </a:pPr>
-            <a:r>
-              <a:t>  • Quyết toán thực tế 5 điều kiện chính thức: $6.58 settled spend ($6.57575890 USD).</a:t>
+              <a:defRPr sz="1000">
+                <a:solidFill>
+                  <a:srgbClr val="0F172A"/>
+                </a:solidFill>
+                <a:latin typeface="Calibri"/>
+              </a:defRPr>
+            </a:pPr>
+            <a:r>
+              <a:t>  • Khoản giữ chỗ thận trọng pilot: $0.05264010 USD (phân tách rạch ròi khỏi chi phí quyết toán).</a:t>
             </a:r>
           </a:p>
           <a:p>
@@ -10804,15 +10723,15 @@
               <a:spcBef>
                 <a:spcPts val="180"/>
               </a:spcBef>
-              <a:defRPr sz="1050">
-                <a:solidFill>
-                  <a:srgbClr val="0F172A"/>
-                </a:solidFill>
-                <a:latin typeface="Calibri"/>
-              </a:defRPr>
-            </a:pPr>
-            <a:r>
-              <a:t>  • Khoản giữ chỗ thận trọng pilot: $0.05264010 USD (phân tách rạch ròi khỏi chi phí quyết toán).</a:t>
+              <a:defRPr sz="1000">
+                <a:solidFill>
+                  <a:srgbClr val="0F172A"/>
+                </a:solidFill>
+                <a:latin typeface="Calibri"/>
+              </a:defRPr>
+            </a:pPr>
+            <a:r>
+              <a:t>  • Tổng chi phí cam kết (Committed spend): $6.63 USD ($6.62839900 USD).</a:t>
             </a:r>
           </a:p>
           <a:p>
@@ -10820,15 +10739,15 @@
               <a:spcBef>
                 <a:spcPts val="180"/>
               </a:spcBef>
-              <a:defRPr sz="1050">
-                <a:solidFill>
-                  <a:srgbClr val="0F172A"/>
-                </a:solidFill>
-                <a:latin typeface="Calibri"/>
-              </a:defRPr>
-            </a:pPr>
-            <a:r>
-              <a:t>  • Tổng chi phí cam kết (Committed spend): $6.63 USD ($6.62839900 USD).</a:t>
+              <a:defRPr sz="1000">
+                <a:solidFill>
+                  <a:srgbClr val="0F172A"/>
+                </a:solidFill>
+                <a:latin typeface="Calibri"/>
+              </a:defRPr>
+            </a:pPr>
+            <a:r>
+              <a:t>  • Ngân sách khả dụng còn lại: $13.36 net remaining ($13.36160100 USD; 0 holds, 0 breach).</a:t>
             </a:r>
           </a:p>
           <a:p>
@@ -10836,23 +10755,7 @@
               <a:spcBef>
                 <a:spcPts val="180"/>
               </a:spcBef>
-              <a:defRPr sz="1050">
-                <a:solidFill>
-                  <a:srgbClr val="0F172A"/>
-                </a:solidFill>
-                <a:latin typeface="Calibri"/>
-              </a:defRPr>
-            </a:pPr>
-            <a:r>
-              <a:t>  • Ngân sách khả dụng còn lại: $13.36 net remaining ($13.36160100 USD; 0 holds, 0 breach).</a:t>
-            </a:r>
-          </a:p>
-          <a:p>
-            <a:pPr>
-              <a:spcBef>
-                <a:spcPts val="180"/>
-              </a:spcBef>
-              <a:defRPr sz="1050">
+              <a:defRPr sz="1000">
                 <a:solidFill>
                   <a:srgbClr val="0F172A"/>
                 </a:solidFill>
@@ -10867,7 +10770,7 @@
       </p:sp>
       <p:pic>
         <p:nvPicPr>
-          <p:cNvPr id="8" name="Picture 7" descr="fig_rq3_pilot_token_scaling.png"/>
+          <p:cNvPr id="8" name="Picture 7" descr="canonical_rq3_resource_consumption.png"/>
           <p:cNvPicPr>
             <a:picLocks noChangeAspect="1"/>
           </p:cNvPicPr>
@@ -10882,7 +10785,7 @@
         <p:spPr>
           <a:xfrm>
             <a:off x="6248095" y="1234440"/>
-            <a:ext cx="5212080" cy="2132215"/>
+            <a:ext cx="5212080" cy="3474720"/>
           </a:xfrm>
           <a:prstGeom prst="rect">
             <a:avLst/>
@@ -10971,25 +10874,25 @@
           <a:p>
             <a:pPr>
               <a:spcBef>
-                <a:spcPts val="250"/>
-              </a:spcBef>
-              <a:defRPr sz="1100">
-                <a:solidFill>
-                  <a:srgbClr val="0F172A"/>
-                </a:solidFill>
-                <a:latin typeface="Calibri"/>
-              </a:defRPr>
-            </a:pPr>
-            <a:r>
-              <a:t>•  Tăng k từ 1 lên 10 nâng Hit rate từ 3.76% lên 44.71%, nhưng lượng token đầu vào tăng ~7.6x.</a:t>
-            </a:r>
-          </a:p>
-          <a:p>
-            <a:pPr>
-              <a:spcBef>
-                <a:spcPts val="250"/>
-              </a:spcBef>
-              <a:defRPr sz="1100">
+                <a:spcPts val="220"/>
+              </a:spcBef>
+              <a:defRPr sz="1050">
+                <a:solidFill>
+                  <a:srgbClr val="0F172A"/>
+                </a:solidFill>
+                <a:latin typeface="Calibri"/>
+              </a:defRPr>
+            </a:pPr>
+            <a:r>
+              <a:t>•  Tăng k từ 1 lên 10 (k1 -&gt; k10): Lượng token đầu vào prompt tăng ~4.103x (1246.5 lên 5114.3 tokens). So với No-RAG (674.3 tokens), k=10 tăng ~7.58x.</a:t>
+            </a:r>
+          </a:p>
+          <a:p>
+            <a:pPr>
+              <a:spcBef>
+                <a:spcPts val="220"/>
+              </a:spcBef>
+              <a:defRPr sz="1050">
                 <a:solidFill>
                   <a:srgbClr val="0F172A"/>
                 </a:solidFill>

</xml_diff>

<commit_message>
fix(slides): fail-closed media guard, 5-condition table, auto markdown sync, and non-causal language repairs
</commit_message>
<xml_diff>
--- a/docs/presentation/slides.pptx
+++ b/docs/presentation/slides.pptx
@@ -528,7 +528,7 @@
           </a:p>
           <a:p>
             <a:r>
-              <a:t>Bằng chứng dự án: config/canonical_experiment_lock_v1.json (SHA-256: d0ce198ad4853f4c41ef2bfbafbe10a395e4927a6c6561b3e72c055c4b887e9f); reports/experiment_protocol_v1.md (SHA-256: d3bf3d31ad307100ac437a7daecc470bf12de9ada49f19de3d77592d5a21974c); artifacts/results/canonical_metric_bundle_v2.json (SHA-256: 442b5933858caafc9da3c06ee9398637213ed30d7a7db80195c0babb1195ef34); scripts/reproduce_study.py.</a:t>
+              <a:t>Bằng chứng dự án: config/canonical_experiment_lock_v1.json (SHA-256: d0ce198ad4853f4c41ef2bfbafbe10a395e4927a6c6561b3e72c055c4b887e9f); reports/experiment_protocol_v1.md (File SHA-256: 639fd68ae16deec86e9f6baab0980c1abb265c6cd7bb9b4662f562b87e54e819; Canonical Decisions Digest: d3bf3d31ad307100ac437a7daecc470bf12de9ada49f19de3d77592d5a21974c); artifacts/results/canonical_metric_bundle_v2.json (SHA-256: 442b5933858caafc9da3c06ee9398637213ed30d7a7db80195c0babb1195ef34); scripts/reproduce_study.py.</a:t>
             </a:r>
           </a:p>
         </p:txBody>
@@ -688,7 +688,7 @@
           </a:p>
           <a:p>
             <a:r>
-              <a:t>Bằng chứng dự án: config/canonical_experiment_lock_v1.json (SHA-256: d0ce198ad4853f4c41ef2bfbafbe10a395e4927a6c6561b3e72c055c4b887e9f); artifacts/results/canonical_metric_bundle_v2.json (SHA-256: 442b5933858caafc9da3c06ee9398637213ed30d7a7db80195c0babb1195ef34); scripts/reproduce_study.py; scripts/run_offline_tests.py; tests/test_smoke_cases.py.</a:t>
+              <a:t>Bằng chứng dự án: config/canonical_experiment_lock_v1.json (SHA-256: d0ce198ad4853f4c41ef2bfbafbe10a395e4927a6c6561b3e72c055c4b887e9f); artifacts/results/canonical_metric_bundle_v2.json (SHA-256: 442b5933858caafc9da3c06ee9398637213ed30d7a7db80195c0babb1195ef34); reports/experiment_protocol_v1.md (File SHA-256: 639fd68ae16deec86e9f6baab0980c1abb265c6cd7bb9b4662f562b87e54e819; Canonical Decisions Digest: d3bf3d31ad307100ac437a7daecc470bf12de9ada49f19de3d77592d5a21974c); scripts/reproduce_study.py; scripts/run_offline_tests.py; tests/test_smoke_cases.py.</a:t>
             </a:r>
           </a:p>
         </p:txBody>
@@ -773,7 +773,7 @@
           </a:p>
           <a:p>
             <a:r>
-              <a:t>Bằng chứng dự án: PR #26 (https://github.com/habachcp6/RAG2ATTCK/pull/26); docs/sanitized_evidence_manifest.json; artifacts/results/canonical_metric_bundle_v2.json (SHA-256: 442b5933858caafc9da3c06ee9398637213ed30d7a7db80195c0babb1195ef34); reports/evidence/reproducibility_package_manifest.md.</a:t>
+              <a:t>Bằng chứng dự án: PR #26 (https://github.com/habachcp6/RAG2ATTCK/pull/26); docs/sanitized_evidence_manifest.json; artifacts/results/canonical_metric_bundle_v2.json (SHA-256: 442b5933858caafc9da3c06ee9398637213ed30d7a7db80195c0babb1195ef34); reports/experiment_protocol_v1.md (File SHA-256: 639fd68ae16deec86e9f6baab0980c1abb265c6cd7bb9b4662f562b87e54e819; Canonical Decisions Digest: d3bf3d31ad307100ac437a7daecc470bf12de9ada49f19de3d77592d5a21974c); reports/evidence/reproducibility_package_manifest.md.</a:t>
             </a:r>
           </a:p>
         </p:txBody>
@@ -853,7 +853,7 @@
           </a:p>
           <a:p>
             <a:r>
-              <a:t>Bằng chứng dự án: docs/README_PROPOSED.md; config/canonical_experiment_lock_v1.json (SHA-256: d0ce198a...); reports/experiment_protocol_v1.md (D3 policy); tests/test_attack_id_validation.py.</a:t>
+              <a:t>Bằng chứng dự án: docs/README_PROPOSED.md; config/canonical_experiment_lock_v1.json (SHA-256: d0ce198a...); reports/experiment_protocol_v1.md (D3 policy; File SHA-256: 639fd68ae16deec86e9f6baab0980c1abb265c6cd7bb9b4662f562b87e54e819; Canonical Decisions Digest: d3bf3d31ad307100ac437a7daecc470bf12de9ada49f19de3d77592d5a21974c); tests/test_attack_id_validation.py.</a:t>
             </a:r>
           </a:p>
         </p:txBody>
@@ -1123,7 +1123,7 @@
           </a:p>
           <a:p>
             <a:r>
-              <a:t>Bằng chứng dự án: reports/experiment_protocol_v1.md (SHA-256: d3bf3d31ad307100ac437a7daecc470bf12de9ada49f19de3d77592d5a21974c); attack/raw/enterprise-v19.2/enterprise-attack-19.2.json (SHA-256: dc1639caa5501d720e280cf1cbd8fbe009884a0c9b3e6e9ed9d0c25166c3d8f4); tests/test_experiment_evaluation.py.</a:t>
+              <a:t>Bằng chứng dự án: reports/experiment_protocol_v1.md (File SHA-256: 639fd68ae16deec86e9f6baab0980c1abb265c6cd7bb9b4662f562b87e54e819; Canonical Decisions Digest: d3bf3d31ad307100ac437a7daecc470bf12de9ada49f19de3d77592d5a21974c); attack/raw/enterprise-v19.2/enterprise-attack-19.2.json (SHA-256: dc1639caa5501d720e280cf1cbd8fbe009884a0c9b3e6e9ed9d0c25166c3d8f4); tests/test_experiment_evaluation.py.</a:t>
             </a:r>
           </a:p>
         </p:txBody>
@@ -1198,7 +1198,7 @@
           </a:p>
           <a:p>
             <a:r>
-              <a:t>Chẩn đoán độc lập khâu tìm kiếm (RQ2) trên tập scorable N=718 cho thấy Hit@10 đạt 44.71% (321/718), nghĩa là trong 55.29% trường hợp (397/718), kỹ thuật đúng hoàn toàn vắng bóng trong Top-10 gửi cho LLM. Điển hình là kỹ thuật T1136.001 với 0/95 lần trúng Top-10 do khoảng cách ngữ nghĩa giữa Event ID 4720 và STIX description. Chúng tôi ghi nhận giả thuyết Context Scaling &amp; Dilution (k=1,3,5,10): tăng k cải thiện độ phủ nhưng tăng nguy cơ nhiễu distractor; giả thuyết này đã được kiểm chứng thực nghiệm đối chứng end-to-end trên ma trận TEST.</a:t>
+              <a:t>Chẩn đoán độc lập khâu tìm kiếm (RQ2) trên tập scorable N=718 cho thấy Hit@10 đạt 44.71% (321/718), nghĩa là trong 55.29% trường hợp (397/718), kỹ thuật đúng hoàn toàn vắng bóng trong Top-10 gửi cho LLM. Điển hình là kỹ thuật T1136.001 với 0/95 lần trúng Top-10 đi kèm sự khác biệt từ vựng giữa raw event log (Event ID 4720 'SamAccountName') và mô tả STIX ATT&amp;CK ('persistence'). Đây là giả thuyết từ vựng (lexical divergence hypothesis), không khẳng định quan hệ nhân quả. Chúng tôi ghi nhận giả thuyết Context Scaling &amp; Dilution (k=1,3,5,10): tăng k cải thiện độ phủ nhưng tăng nguy cơ nhiễu distractor; đang được kiểm chứng đối chứng trên ma trận TEST.</a:t>
             </a:r>
           </a:p>
           <a:p>
@@ -1278,7 +1278,7 @@
           </a:p>
           <a:p>
             <a:r>
-              <a:t>Phân tích lỗi khâu truy xuất và chẩn đoán có điều kiện (RQ2) trên tập scorable N=718 cho thấy: khi kỹ thuật đúng có mặt trong Top-10 (N=321), tỷ lệ gán đúng đạt 91.28% (293/321); khi kỹ thuật đúng vắng mặt (N=397), tỷ lệ gán đúng giảm xuống 70.03% (278/397). Độ chênh lệch quan sát được là +21.25 pp. Chúng tôi nhấn mạnh: đây thuần túy là tương quan quan sát trong thực nghiệm (observational association), không áp đặt suy diễn quan hệ nhân quả.</a:t>
+              <a:t>Phân tích lỗi khâu truy xuất và chẩn đoán có điều kiện (RQ2) trên tập scorable N=718 cho thấy: khi kỹ thuật đúng có mặt trong Top-10 (N=321), tỷ lệ gán đúng đạt 91.28% (293/321); khi kỹ thuật đúng vắng mặt (N=397), tỷ lệ gán đúng là 70.03% (278/397). Độ chênh lệch quan sát được là +21.25 pp. Chúng tôi nhấn mạnh: đây thuần túy là tương quan quan sát trong thực nghiệm (observational association), không áp đặt suy diễn quan hệ nhân quả hay khẳng định năng lực nội tại của LLM.</a:t>
             </a:r>
           </a:p>
           <a:p>
@@ -1288,7 +1288,7 @@
           </a:p>
           <a:p>
             <a:r>
-              <a:t>Bằng chứng dự án: artifacts/results/canonical_metric_bundle_v2.json (SHA-256: 442b5933858caafc9da3c06ee9398637213ed30d7a7db80195c0babb1195ef34); reports/experiment_protocol_v1.md (D2i); tests/test_experiment_evaluation.py.</a:t>
+              <a:t>Bằng chứng dự án: artifacts/results/canonical_metric_bundle_v2.json (SHA-256: 442b5933858caafc9da3c06ee9398637213ed30d7a7db80195c0babb1195ef34); reports/experiment_protocol_v1.md (D2i; File SHA-256: 639fd68ae16deec86e9f6baab0980c1abb265c6cd7bb9b4662f562b87e54e819; Canonical Decisions Digest: d3bf3d31ad307100ac437a7daecc470bf12de9ada49f19de3d77592d5a21974c); tests/test_experiment_evaluation.py.</a:t>
             </a:r>
           </a:p>
         </p:txBody>
@@ -1368,7 +1368,37 @@
           </a:p>
           <a:p>
             <a:r>
-              <a:t>Bảng đối chứng RQ1 ghi nhận RAG k=10 đạt độ chính xác quan sát được cao nhất là 79.53% (571/718) so với No-RAG 77.99% (560/718), tức Delta = +1.532 pp (+1.96% relative gain; 95% CI [-2.355, +5.300] pp chứa 0; kiểm định McNemar chính xác p = 0.4219 / hiển thị 0.422 &gt; 0.05). Do đó, nghiên cứu khẳng định đây là độ chính xác quan sát được cao nhất trong thử nghiệm kèm độ bất định, tuyệt đối không tuyên bố chiến thắng có ý nghĩa thống kê hay lợi ích vượt trội trong production.</a:t>
+              <a:t>Bảng đối chứng 5 điều kiện RQ1 trên tập scorable N=718 (474 lớp vũ trụ D2d):</a:t>
+            </a:r>
+          </a:p>
+          <a:p>
+            <a:r>
+              <a:t>1. No-RAG:    77.99% (560/718), Macro-F1 = 0.0126 (Baseline đối chứng).</a:t>
+            </a:r>
+          </a:p>
+          <a:p>
+            <a:r>
+              <a:t>2. RAG (k=1):  77.02% (553/718), Macro-F1 = 0.0127, Delta = -0.975 pp (CI [-3.186, +1.124] pp), McNemar p = 0.435.</a:t>
+            </a:r>
+          </a:p>
+          <a:p>
+            <a:r>
+              <a:t>3. RAG (k=3):  78.55% (564/718), Macro-F1 = 0.0136, Delta = +0.557 pp (CI [-2.786, +3.934] pp), McNemar p = 0.777.</a:t>
+            </a:r>
+          </a:p>
+          <a:p>
+            <a:r>
+              <a:t>4. RAG (k=5):  78.83% (566/718), Macro-F1 = 0.0139, Delta = +0.836 pp (CI [-2.934, +4.603] pp), McNemar p = 0.677.</a:t>
+            </a:r>
+          </a:p>
+          <a:p>
+            <a:r>
+              <a:t>5. RAG (k=10): 79.53% (571/718), Macro-F1 = 0.0140, Delta = +1.532 pp (+1.96% relative; 95% CI [-2.355, +5.300] pp chứa 0), McNemar p = 0.4219 / 0.422 &gt; 0.05.</a:t>
+            </a:r>
+          </a:p>
+          <a:p>
+            <a:r>
+              <a:t>Nghiên cứu khẳng định RAG k=10 là độ chính xác quan sát được cao nhất trong thử nghiệm kèm độ bất định, tuyệt đối không tuyên bố chiến thắng có ý nghĩa thống kê hay lợi ích vượt trội trong production.</a:t>
             </a:r>
           </a:p>
           <a:p>
@@ -1388,7 +1418,7 @@
           </a:p>
           <a:p>
             <a:r>
-              <a:t>Bằng chứng dự án: reports/experiment_protocol_v1.md (D2d, D2e, D2f, D2h, D2i; SHA-256: d3bf3d31ad307100ac437a7daecc470bf12de9ada49f19de3d77592d5a21974c); artifacts/results/canonical_metric_bundle_v2.json (SHA-256: 442b5933858caafc9da3c06ee9398637213ed30d7a7db80195c0babb1195ef34); tests/test_experiment_evaluation.py.</a:t>
+              <a:t>Bằng chứng dự án: reports/experiment_protocol_v1.md (D2d, D2e, D2f, D2h, D2i; File SHA-256: 639fd68ae16deec86e9f6baab0980c1abb265c6cd7bb9b4662f562b87e54e819; Canonical Decisions Digest: d3bf3d31ad307100ac437a7daecc470bf12de9ada49f19de3d77592d5a21974c); artifacts/results/canonical_metric_bundle_v2.json (SHA-256: 442b5933858caafc9da3c06ee9398637213ed30d7a7db80195c0babb1195ef34); tests/test_experiment_evaluation.py.</a:t>
             </a:r>
           </a:p>
         </p:txBody>
@@ -1478,22 +1508,27 @@
           </a:p>
           <a:p>
             <a:r>
-              <a:t>3. Hạch toán tài chính chính xác: trần ngân sách đóng băng cứng $19.99 USD (hard_budget_limit_usd = $19.99000000). Chi phí quyết toán thực tế 5 điều kiện chính thức là $6.58 settled spend ($6.57575890 USD).</a:t>
-            </a:r>
-          </a:p>
-          <a:p>
-            <a:r>
-              <a:t>4. Phân biệt rạch ròi: Khoản giữ chỗ thận trọng pilot $0.05264010 USD (prior_pilot_provisional_hold_usd) được phân tách minh bạch khỏi chi phí quyết toán thực tế $6.57575890 USD. Tổng chi phí cam kết là $6.63 committed spend ($6.62839900 USD), ngân sách khả dụng còn lại là $13.36 net remaining ($13.36160100 USD; 0 active holds, 0 breach).</a:t>
-            </a:r>
-          </a:p>
-          <a:p>
-            <a:r>
-              <a:t>5. Đánh đổi token: Tỷ lệ tăng token prompt từ k=1 lên k=10 là ~4.103x (1246.5 lên 5114.3 tokens); tỷ lệ từ No-RAG lên k=10 là ~7.58x.</a:t>
-            </a:r>
-          </a:p>
-          <a:p>
-            <a:r>
-              <a:t>Bằng chứng dự án: docs/presentation/figures/canonical_rq3_resource_consumption.png (SHA-256: ca296165b38b499432f851618e3d6a512964c461e59dc3b646e647ddcb70bfb1); docs/presentation/figures/fig7_cost_and_tokens_vs_k.png; config/experiment_config.json (hard_budget_limit_usd: 19.99); artifacts/results/canonical_metric_bundle_v2.json (SHA-256: 442b5933858caafc9da3c06ee9398637213ed30d7a7db80195c0babb1195ef34); tests/test_monetary_guard.py.</a:t>
+              <a:t>3. Phân định giới hạn token: 13 requests INCOMPLETE dừng do chạm trần configured max_output_tokens (8,192 tokens, tức ngân sách suy luận đầu ra được cấu hình), không phải do vượt cửa sổ ngữ cảnh context ceiling (~1,050,000 tokens của gpt-5.6-luna). Toàn bộ 13 requests này đều thuộc các view loại trừ/unmapped.</a:t>
+            </a:r>
+          </a:p>
+          <a:p>
+            <a:r>
+              <a:t>4. Hạch toán tài chính chính xác: trần ngân sách đóng băng cứng $19.99 USD (hard_budget_limit_usd = $19.99000000). Chi phí quyết toán thực tế 5 điều kiện chính thức là $6.58 settled spend ($6.57575890 USD).</a:t>
+            </a:r>
+          </a:p>
+          <a:p>
+            <a:r>
+              <a:t>5. Phân biệt rạch ròi: Khoản giữ chỗ thận trọng pilot $0.05264010 USD (prior_pilot_provisional_hold_usd) được phân tách minh bạch khỏi chi phí quyết toán thực tế $6.57575890 USD. Tổng chi phí cam kết là $6.63 committed spend ($6.62839900 USD), ngân sách khả dụng còn lại là $13.36 net remaining ($13.36160100 USD; 0 active holds, 0 breach).</a:t>
+            </a:r>
+          </a:p>
+          <a:p>
+            <a:r>
+              <a:t>6. Đánh đổi token: Tỷ lệ tăng token prompt từ k=1 lên k=10 là ~4.103x (1246.5 lên 5114.3 tokens); tỷ lệ từ No-RAG lên k=10 là ~7.58x.</a:t>
+            </a:r>
+          </a:p>
+          <a:p>
+            <a:r>
+              <a:t>Bằng chứng dự án: docs/presentation/figures/canonical_rq3_resource_consumption.png (SHA-256: ca296165b38b499432f851618e3d6a512964c461e59dc3b646e647ddcb70bfb1); docs/presentation/figures/fig7_cost_and_tokens_vs_k.png; config/experiment_config.json (hard_budget_limit_usd: 19.99); artifacts/results/canonical_metric_bundle_v2.json (SHA-256: 442b5933858caafc9da3c06ee9398637213ed30d7a7db80195c0babb1195ef34); reports/experiment_protocol_v1.md (File SHA-256: 639fd68ae16deec86e9f6baab0980c1abb265c6cd7bb9b4662f562b87e54e819; Canonical Decisions Digest: d3bf3d31ad307100ac437a7daecc470bf12de9ada49f19de3d77592d5a21974c); tests/test_monetary_guard.py.</a:t>
             </a:r>
           </a:p>
         </p:txBody>
@@ -5749,7 +5784,7 @@
               </a:defRPr>
             </a:pPr>
             <a:r>
-              <a:t>•  1. Quy trình thực nghiệm chuẩn hóa: Thiết lập giao thức thực nghiệm đối chứng khép kín, chống rò rỉ nhãn đầu tiên cho bài toán Windows log attribution.</a:t>
+              <a:t>•  1. Quy trình thực nghiệm chuẩn hóa: Thiết lập giao thức thực nghiệm đối chứng khép kín trên tập dữ liệu đóng băng synthetic-paired-v1 cho bài toán Windows log attribution.</a:t>
             </a:r>
           </a:p>
           <a:p>
@@ -9089,15 +9124,15 @@
               <a:spcBef>
                 <a:spcPts val="250"/>
               </a:spcBef>
-              <a:defRPr sz="1100">
-                <a:solidFill>
-                  <a:srgbClr val="0F172A"/>
-                </a:solidFill>
-                <a:latin typeface="Calibri"/>
-              </a:defRPr>
-            </a:pPr>
-            <a:r>
-              <a:t>•  Khoảng cách ngữ nghĩa tại T1136.001 (Local Account): 0/95 lượt trúng Top-10 do log Event ID 4720 lệch từ vựng so với STIX persistence.</a:t>
+              <a:defRPr sz="1050">
+                <a:solidFill>
+                  <a:srgbClr val="0F172A"/>
+                </a:solidFill>
+                <a:latin typeface="Calibri"/>
+              </a:defRPr>
+            </a:pPr>
+            <a:r>
+              <a:t>•  Khoảng cách ngữ nghĩa tại T1136.001 (Local Account): Quan sát thấy 0/95 lượt trúng Top-10 đi kèm sự khác biệt từ vựng giữa raw event log và nhãn STIX (giả thuyết từ vựng / lexical divergence hypothesis, không khẳng định quan hệ nhân quả).</a:t>
             </a:r>
           </a:p>
           <a:p>
@@ -9105,7 +9140,7 @@
               <a:spcBef>
                 <a:spcPts val="250"/>
               </a:spcBef>
-              <a:defRPr sz="1100">
+              <a:defRPr sz="1050">
                 <a:solidFill>
                   <a:srgbClr val="0F172A"/>
                 </a:solidFill>
@@ -9454,7 +9489,7 @@
               </a:defRPr>
             </a:pPr>
             <a:r>
-              <a:t>  • P(Đúng | Vắng mặt): 70.03% (278/397 views gán đúng nhờ năng lực nội tại LLM).</a:t>
+              <a:t>  • P(Đúng | Vắng mặt): 70.03% (278/397 views gán đúng khi không có tài liệu ground-truth trong Top-10).</a:t>
             </a:r>
           </a:p>
           <a:p>
@@ -9615,7 +9650,7 @@
               </a:defRPr>
             </a:pPr>
             <a:r>
-              <a:t>•  Lỗi khi retrieval thành công: 28 / 147 (19.05% tổng lỗi phân loại) mô hình chọn sai kỹ thuật dù đã có trong ngữ cảnh (downstream confusion / distractor effect).</a:t>
+              <a:t>•  Lỗi khi retrieval thành công: 28 / 147 (19.05% tổng lỗi phân loại) mô hình chọn sai kỹ thuật dù kỹ thuật đúng có trong Top-10 (giả thuyết nhầm lẫn downstream / distractor effect đang được khảo sát).</a:t>
             </a:r>
           </a:p>
           <a:p>
@@ -10278,71 +10313,119 @@
               </a:defRPr>
             </a:pPr>
             <a:r>
-              <a:t>[CANONICAL CANDIDATE — PENDING ROOT FINAL REVIEW] Trạng Thái Thực Nghiệm RQ1 &amp; RQ2</a:t>
-            </a:r>
-          </a:p>
-          <a:p>
-            <a:pPr>
-              <a:spcBef>
-                <a:spcPts val="250"/>
-              </a:spcBef>
-              <a:defRPr sz="1050">
-                <a:solidFill>
-                  <a:srgbClr val="0F172A"/>
-                </a:solidFill>
-                <a:latin typeface="Calibri"/>
-              </a:defRPr>
-            </a:pPr>
-            <a:r>
-              <a:t>•  Ma trận TEST chuẩn: N=718 scorable views x 5 điều kiện (No-RAG, k=1, 3, 5, 10; tổng 3,590 scorable records).</a:t>
-            </a:r>
-          </a:p>
-          <a:p>
-            <a:pPr>
-              <a:spcBef>
-                <a:spcPts val="250"/>
-              </a:spcBef>
-              <a:defRPr sz="1050">
-                <a:solidFill>
-                  <a:srgbClr val="0F172A"/>
-                </a:solidFill>
-                <a:latin typeface="Calibri"/>
-              </a:defRPr>
-            </a:pPr>
-            <a:r>
-              <a:t>•  Ranh giới lỗi phân định: 1 physical API_FAILURE retry thành công; 0 terminal provider failure trên 3,590 scorable records.</a:t>
-            </a:r>
-          </a:p>
-          <a:p>
-            <a:pPr>
-              <a:spcBef>
-                <a:spcPts val="250"/>
-              </a:spcBef>
-              <a:defRPr sz="1050">
-                <a:solidFill>
-                  <a:srgbClr val="0F172A"/>
-                </a:solidFill>
-                <a:latin typeface="Calibri"/>
-              </a:defRPr>
-            </a:pPr>
-            <a:r>
-              <a:t>•  Tổng thể campaign: 13 terminal incomplete trên 6,400 requests (đều thuộc các view loại trừ/unmapped).</a:t>
-            </a:r>
-          </a:p>
-          <a:p>
-            <a:pPr>
-              <a:spcBef>
-                <a:spcPts val="250"/>
-              </a:spcBef>
-              <a:defRPr sz="1050">
-                <a:solidFill>
-                  <a:srgbClr val="0F172A"/>
-                </a:solidFill>
-                <a:latin typeface="Calibri"/>
-              </a:defRPr>
-            </a:pPr>
-            <a:r>
-              <a:t>•  Khóa toàn vẹn: Bundle v2 SHA-256 đã thẩm định; 0 invalid ID cú pháp; tính toán ngoại tuyến xác thực.</a:t>
+              <a:t>Bảng Đối Chứng 5 Điều Kiện (RQ1 N=718)</a:t>
+            </a:r>
+          </a:p>
+          <a:p>
+            <a:pPr>
+              <a:spcBef>
+                <a:spcPts val="150"/>
+              </a:spcBef>
+              <a:defRPr sz="1000">
+                <a:solidFill>
+                  <a:srgbClr val="0F172A"/>
+                </a:solidFill>
+                <a:latin typeface="Calibri"/>
+              </a:defRPr>
+            </a:pPr>
+            <a:r>
+              <a:t>•  Bảng tổng hợp đối chứng 5 điều kiện (vũ trụ 474 lớp D2d):</a:t>
+            </a:r>
+          </a:p>
+          <a:p>
+            <a:pPr>
+              <a:spcBef>
+                <a:spcPts val="150"/>
+              </a:spcBef>
+              <a:defRPr sz="1000">
+                <a:solidFill>
+                  <a:srgbClr val="0F172A"/>
+                </a:solidFill>
+                <a:latin typeface="Calibri"/>
+              </a:defRPr>
+            </a:pPr>
+            <a:r>
+              <a:t>  • No-RAG:    77.99% (560/718) | Macro-F1: 0.0126 (Baseline)</a:t>
+            </a:r>
+          </a:p>
+          <a:p>
+            <a:pPr>
+              <a:spcBef>
+                <a:spcPts val="150"/>
+              </a:spcBef>
+              <a:defRPr sz="1000">
+                <a:solidFill>
+                  <a:srgbClr val="0F172A"/>
+                </a:solidFill>
+                <a:latin typeface="Calibri"/>
+              </a:defRPr>
+            </a:pPr>
+            <a:r>
+              <a:t>  • RAG (k=1):  77.02% (553/718) | Macro-F1: 0.0127 | p = 0.435</a:t>
+            </a:r>
+          </a:p>
+          <a:p>
+            <a:pPr>
+              <a:spcBef>
+                <a:spcPts val="150"/>
+              </a:spcBef>
+              <a:defRPr sz="1000">
+                <a:solidFill>
+                  <a:srgbClr val="0F172A"/>
+                </a:solidFill>
+                <a:latin typeface="Calibri"/>
+              </a:defRPr>
+            </a:pPr>
+            <a:r>
+              <a:t>  • RAG (k=3):  78.55% (564/718) | Macro-F1: 0.0136 | p = 0.777</a:t>
+            </a:r>
+          </a:p>
+          <a:p>
+            <a:pPr>
+              <a:spcBef>
+                <a:spcPts val="150"/>
+              </a:spcBef>
+              <a:defRPr sz="1000">
+                <a:solidFill>
+                  <a:srgbClr val="0F172A"/>
+                </a:solidFill>
+                <a:latin typeface="Calibri"/>
+              </a:defRPr>
+            </a:pPr>
+            <a:r>
+              <a:t>  • RAG (k=5):  78.83% (566/718) | Macro-F1: 0.0139 | p = 0.677</a:t>
+            </a:r>
+          </a:p>
+          <a:p>
+            <a:pPr>
+              <a:spcBef>
+                <a:spcPts val="150"/>
+              </a:spcBef>
+              <a:defRPr sz="1000">
+                <a:solidFill>
+                  <a:srgbClr val="0F172A"/>
+                </a:solidFill>
+                <a:latin typeface="Calibri"/>
+              </a:defRPr>
+            </a:pPr>
+            <a:r>
+              <a:t>  • RAG (k=10): 79.53% (571/718) | Macro-F1: 0.0140 | Delta: +1.532 pp | p = 0.422</a:t>
+            </a:r>
+          </a:p>
+          <a:p>
+            <a:pPr>
+              <a:spcBef>
+                <a:spcPts val="150"/>
+              </a:spcBef>
+              <a:defRPr sz="1000">
+                <a:solidFill>
+                  <a:srgbClr val="0F172A"/>
+                </a:solidFill>
+                <a:latin typeface="Calibri"/>
+              </a:defRPr>
+            </a:pPr>
+            <a:r>
+              <a:t>•  Ranh giới ngoại lệ: 1 physical API retry thành công; 0 terminal provider failure trên 3,590 scorable records; 13 terminal incomplete trên 6,400 requests.</a:t>
             </a:r>
           </a:p>
         </p:txBody>
@@ -10651,7 +10734,7 @@
               </a:defRPr>
             </a:pPr>
             <a:r>
-              <a:t>•  Phân định ngoại lệ: 13 requests đạt trần context/output tokens (8,192 max tokens) đều thuộc nhóm unmapped/ambiguous; 1 physical API_FAILURE retry thành công với 1,540 cached tokens; 0 terminal provider failure trên 3,590 scorable records.</a:t>
+              <a:t>•  Phân định ngoại lệ: 13 requests chạm trần output budget cấu hình (8,192 configured max_output_tokens; không phải trần context ~1.05M tokens của gpt-5.6-luna) đều thuộc nhóm unmapped/ambiguous; 1 physical API_FAILURE retry thành công với 1,540 cached tokens; 0 terminal provider failure trên 3,590 scorable records.</a:t>
             </a:r>
           </a:p>
           <a:p>

</xml_diff>

<commit_message>
fix(slides): in-memory stream media guard, mandatory root pin descriptor, and zip parity tests
</commit_message>
<xml_diff>
--- a/docs/presentation/slides.pptx
+++ b/docs/presentation/slides.pptx
@@ -9018,7 +9018,7 @@
       </p:sp>
       <p:pic>
         <p:nvPicPr>
-          <p:cNvPr id="8" name="Picture 7" descr="canonical_rq2_retrieval_hit_rate.png"/>
+          <p:cNvPr id="8" name="Picture 7" descr="image.png"/>
           <p:cNvPicPr>
             <a:picLocks noChangeAspect="1"/>
           </p:cNvPicPr>
@@ -10853,7 +10853,7 @@
       </p:sp>
       <p:pic>
         <p:nvPicPr>
-          <p:cNvPr id="8" name="Picture 7" descr="canonical_rq3_resource_consumption.png"/>
+          <p:cNvPr id="8" name="Picture 7" descr="image.png"/>
           <p:cNvPicPr>
             <a:picLocks noChangeAspect="1"/>
           </p:cNvPicPr>

</xml_diff>